<commit_message>
Match final report layout to midterm IEEE paper format
Rewrote fill_final_report.py to clear the IEEE template body and rebuild
content fresh while keeping the template's styles. Fixes:
- Title + author + abstract + keywords on page 1 (single column)
- 2-column body section starting at Introduction
- Roman-numeral section numbering and A./B./C. subsection lettering
  driven by template styles (no manual prefixes that doubled the numbering)
- Fig./Table caption text no longer carries a manual "Fig. N." prefix
  (the auto-numbering in the template style handles it)
- Reference entries no longer carry a manual "[N]" prefix

Voice and structure also rewritten to match the existing midterm IEEE
paper: conversational "we" tone, Phase 1/2/3 methodology, Discussion
section with A. Limitations subsection, 8 references.
</commit_message>
<xml_diff>
--- a/AI700-Final-PPT-Hallucination-LLM.pptx
+++ b/AI700-Final-PPT-Hallucination-LLM.pptx
@@ -155,3814 +155,6 @@
 </pc:chgInfo>
 </file>
 
-<file path=ppt/diagrams/colors1.xml><?xml version="1.0" encoding="utf-8"?>
-<dgm:colorsDef xmlns:dgm="http://schemas.openxmlformats.org/drawingml/2006/diagram" xmlns:a="http://schemas.openxmlformats.org/drawingml/2006/main" uniqueId="urn:microsoft.com/office/officeart/2005/8/colors/colorful1">
-  <dgm:title val=""/>
-  <dgm:desc val=""/>
-  <dgm:catLst>
-    <dgm:cat type="colorful" pri="10100"/>
-  </dgm:catLst>
-  <dgm:styleLbl name="node0">
-    <dgm:fillClrLst meth="repeat">
-      <a:schemeClr val="accent1"/>
-    </dgm:fillClrLst>
-    <dgm:linClrLst meth="repeat">
-      <a:schemeClr val="lt1"/>
-    </dgm:linClrLst>
-    <dgm:effectClrLst/>
-    <dgm:txLinClrLst/>
-    <dgm:txFillClrLst/>
-    <dgm:txEffectClrLst/>
-  </dgm:styleLbl>
-  <dgm:styleLbl name="node1">
-    <dgm:fillClrLst meth="repeat">
-      <a:schemeClr val="accent2"/>
-      <a:schemeClr val="accent3"/>
-      <a:schemeClr val="accent4"/>
-      <a:schemeClr val="accent5"/>
-      <a:schemeClr val="accent6"/>
-    </dgm:fillClrLst>
-    <dgm:linClrLst meth="repeat">
-      <a:schemeClr val="lt1"/>
-    </dgm:linClrLst>
-    <dgm:effectClrLst/>
-    <dgm:txLinClrLst/>
-    <dgm:txFillClrLst/>
-    <dgm:txEffectClrLst/>
-  </dgm:styleLbl>
-  <dgm:styleLbl name="alignNode1">
-    <dgm:fillClrLst meth="repeat">
-      <a:schemeClr val="accent2"/>
-      <a:schemeClr val="accent3"/>
-      <a:schemeClr val="accent4"/>
-      <a:schemeClr val="accent5"/>
-      <a:schemeClr val="accent6"/>
-    </dgm:fillClrLst>
-    <dgm:linClrLst meth="repeat">
-      <a:schemeClr val="accent2"/>
-      <a:schemeClr val="accent3"/>
-      <a:schemeClr val="accent4"/>
-      <a:schemeClr val="accent5"/>
-      <a:schemeClr val="accent6"/>
-    </dgm:linClrLst>
-    <dgm:effectClrLst/>
-    <dgm:txLinClrLst/>
-    <dgm:txFillClrLst/>
-    <dgm:txEffectClrLst/>
-  </dgm:styleLbl>
-  <dgm:styleLbl name="lnNode1">
-    <dgm:fillClrLst meth="repeat">
-      <a:schemeClr val="accent2"/>
-      <a:schemeClr val="accent3"/>
-      <a:schemeClr val="accent4"/>
-      <a:schemeClr val="accent5"/>
-      <a:schemeClr val="accent6"/>
-    </dgm:fillClrLst>
-    <dgm:linClrLst meth="repeat">
-      <a:schemeClr val="lt1"/>
-    </dgm:linClrLst>
-    <dgm:effectClrLst/>
-    <dgm:txLinClrLst/>
-    <dgm:txFillClrLst/>
-    <dgm:txEffectClrLst/>
-  </dgm:styleLbl>
-  <dgm:styleLbl name="vennNode1">
-    <dgm:fillClrLst meth="repeat">
-      <a:schemeClr val="accent2">
-        <a:alpha val="50000"/>
-      </a:schemeClr>
-      <a:schemeClr val="accent3">
-        <a:alpha val="50000"/>
-      </a:schemeClr>
-      <a:schemeClr val="accent4">
-        <a:alpha val="50000"/>
-      </a:schemeClr>
-      <a:schemeClr val="accent5">
-        <a:alpha val="50000"/>
-      </a:schemeClr>
-      <a:schemeClr val="accent6">
-        <a:alpha val="50000"/>
-      </a:schemeClr>
-    </dgm:fillClrLst>
-    <dgm:linClrLst meth="repeat">
-      <a:schemeClr val="lt1"/>
-    </dgm:linClrLst>
-    <dgm:effectClrLst/>
-    <dgm:txLinClrLst/>
-    <dgm:txFillClrLst/>
-    <dgm:txEffectClrLst/>
-  </dgm:styleLbl>
-  <dgm:styleLbl name="node2">
-    <dgm:fillClrLst>
-      <a:schemeClr val="accent2"/>
-    </dgm:fillClrLst>
-    <dgm:linClrLst meth="repeat">
-      <a:schemeClr val="lt1"/>
-    </dgm:linClrLst>
-    <dgm:effectClrLst/>
-    <dgm:txLinClrLst/>
-    <dgm:txFillClrLst/>
-    <dgm:txEffectClrLst/>
-  </dgm:styleLbl>
-  <dgm:styleLbl name="node3">
-    <dgm:fillClrLst>
-      <a:schemeClr val="accent3"/>
-    </dgm:fillClrLst>
-    <dgm:linClrLst meth="repeat">
-      <a:schemeClr val="lt1"/>
-    </dgm:linClrLst>
-    <dgm:effectClrLst/>
-    <dgm:txLinClrLst/>
-    <dgm:txFillClrLst/>
-    <dgm:txEffectClrLst/>
-  </dgm:styleLbl>
-  <dgm:styleLbl name="node4">
-    <dgm:fillClrLst>
-      <a:schemeClr val="accent4"/>
-    </dgm:fillClrLst>
-    <dgm:linClrLst meth="repeat">
-      <a:schemeClr val="lt1"/>
-    </dgm:linClrLst>
-    <dgm:effectClrLst/>
-    <dgm:txLinClrLst/>
-    <dgm:txFillClrLst/>
-    <dgm:txEffectClrLst/>
-  </dgm:styleLbl>
-  <dgm:styleLbl name="fgImgPlace1">
-    <dgm:fillClrLst meth="repeat">
-      <a:schemeClr val="accent2">
-        <a:tint val="50000"/>
-      </a:schemeClr>
-      <a:schemeClr val="accent3">
-        <a:tint val="50000"/>
-      </a:schemeClr>
-      <a:schemeClr val="accent4">
-        <a:tint val="50000"/>
-      </a:schemeClr>
-      <a:schemeClr val="accent5">
-        <a:tint val="50000"/>
-      </a:schemeClr>
-      <a:schemeClr val="accent6">
-        <a:tint val="50000"/>
-      </a:schemeClr>
-    </dgm:fillClrLst>
-    <dgm:linClrLst meth="repeat">
-      <a:schemeClr val="lt1"/>
-    </dgm:linClrLst>
-    <dgm:effectClrLst/>
-    <dgm:txLinClrLst/>
-    <dgm:txFillClrLst meth="repeat">
-      <a:schemeClr val="lt1"/>
-    </dgm:txFillClrLst>
-    <dgm:txEffectClrLst/>
-  </dgm:styleLbl>
-  <dgm:styleLbl name="alignImgPlace1">
-    <dgm:fillClrLst>
-      <a:schemeClr val="accent1">
-        <a:tint val="50000"/>
-      </a:schemeClr>
-      <a:schemeClr val="accent2">
-        <a:tint val="20000"/>
-      </a:schemeClr>
-    </dgm:fillClrLst>
-    <dgm:linClrLst meth="repeat">
-      <a:schemeClr val="lt1"/>
-    </dgm:linClrLst>
-    <dgm:effectClrLst/>
-    <dgm:txLinClrLst/>
-    <dgm:txFillClrLst meth="repeat">
-      <a:schemeClr val="lt1"/>
-    </dgm:txFillClrLst>
-    <dgm:txEffectClrLst/>
-  </dgm:styleLbl>
-  <dgm:styleLbl name="bgImgPlace1">
-    <dgm:fillClrLst>
-      <a:schemeClr val="accent1">
-        <a:tint val="50000"/>
-      </a:schemeClr>
-      <a:schemeClr val="accent2">
-        <a:tint val="20000"/>
-      </a:schemeClr>
-    </dgm:fillClrLst>
-    <dgm:linClrLst meth="repeat">
-      <a:schemeClr val="lt1"/>
-    </dgm:linClrLst>
-    <dgm:effectClrLst/>
-    <dgm:txLinClrLst/>
-    <dgm:txFillClrLst meth="repeat">
-      <a:schemeClr val="lt1"/>
-    </dgm:txFillClrLst>
-    <dgm:txEffectClrLst/>
-  </dgm:styleLbl>
-  <dgm:styleLbl name="sibTrans2D1">
-    <dgm:fillClrLst meth="repeat">
-      <a:schemeClr val="accent2"/>
-      <a:schemeClr val="accent3"/>
-      <a:schemeClr val="accent4"/>
-      <a:schemeClr val="accent5"/>
-      <a:schemeClr val="accent6"/>
-    </dgm:fillClrLst>
-    <dgm:linClrLst meth="cycle">
-      <a:schemeClr val="lt1"/>
-    </dgm:linClrLst>
-    <dgm:effectClrLst/>
-    <dgm:txLinClrLst/>
-    <dgm:txFillClrLst/>
-    <dgm:txEffectClrLst/>
-  </dgm:styleLbl>
-  <dgm:styleLbl name="fgSibTrans2D1">
-    <dgm:fillClrLst meth="repeat">
-      <a:schemeClr val="accent2"/>
-      <a:schemeClr val="accent3"/>
-      <a:schemeClr val="accent4"/>
-      <a:schemeClr val="accent5"/>
-      <a:schemeClr val="accent6"/>
-    </dgm:fillClrLst>
-    <dgm:linClrLst meth="cycle">
-      <a:schemeClr val="lt1"/>
-    </dgm:linClrLst>
-    <dgm:effectClrLst/>
-    <dgm:txLinClrLst/>
-    <dgm:txFillClrLst meth="repeat">
-      <a:schemeClr val="lt1"/>
-    </dgm:txFillClrLst>
-    <dgm:txEffectClrLst/>
-  </dgm:styleLbl>
-  <dgm:styleLbl name="bgSibTrans2D1">
-    <dgm:fillClrLst meth="repeat">
-      <a:schemeClr val="accent2"/>
-      <a:schemeClr val="accent3"/>
-      <a:schemeClr val="accent4"/>
-      <a:schemeClr val="accent5"/>
-      <a:schemeClr val="accent6"/>
-    </dgm:fillClrLst>
-    <dgm:linClrLst meth="cycle">
-      <a:schemeClr val="lt1"/>
-    </dgm:linClrLst>
-    <dgm:effectClrLst/>
-    <dgm:txLinClrLst/>
-    <dgm:txFillClrLst meth="repeat">
-      <a:schemeClr val="lt1"/>
-    </dgm:txFillClrLst>
-    <dgm:txEffectClrLst/>
-  </dgm:styleLbl>
-  <dgm:styleLbl name="sibTrans1D1">
-    <dgm:fillClrLst meth="repeat">
-      <a:schemeClr val="accent2"/>
-      <a:schemeClr val="accent3"/>
-      <a:schemeClr val="accent4"/>
-      <a:schemeClr val="accent5"/>
-      <a:schemeClr val="accent6"/>
-    </dgm:fillClrLst>
-    <dgm:linClrLst meth="repeat">
-      <a:schemeClr val="accent2"/>
-      <a:schemeClr val="accent3"/>
-      <a:schemeClr val="accent4"/>
-      <a:schemeClr val="accent5"/>
-      <a:schemeClr val="accent6"/>
-    </dgm:linClrLst>
-    <dgm:effectClrLst/>
-    <dgm:txLinClrLst/>
-    <dgm:txFillClrLst meth="repeat">
-      <a:schemeClr val="tx1"/>
-    </dgm:txFillClrLst>
-    <dgm:txEffectClrLst/>
-  </dgm:styleLbl>
-  <dgm:styleLbl name="callout">
-    <dgm:fillClrLst meth="repeat">
-      <a:schemeClr val="accent2"/>
-    </dgm:fillClrLst>
-    <dgm:linClrLst meth="repeat">
-      <a:schemeClr val="accent2">
-        <a:tint val="50000"/>
-      </a:schemeClr>
-    </dgm:linClrLst>
-    <dgm:effectClrLst/>
-    <dgm:txLinClrLst/>
-    <dgm:txFillClrLst meth="repeat">
-      <a:schemeClr val="tx1"/>
-    </dgm:txFillClrLst>
-    <dgm:txEffectClrLst/>
-  </dgm:styleLbl>
-  <dgm:styleLbl name="asst0">
-    <dgm:fillClrLst meth="repeat">
-      <a:schemeClr val="accent1"/>
-    </dgm:fillClrLst>
-    <dgm:linClrLst meth="repeat">
-      <a:schemeClr val="lt1"/>
-    </dgm:linClrLst>
-    <dgm:effectClrLst/>
-    <dgm:txLinClrLst/>
-    <dgm:txFillClrLst/>
-    <dgm:txEffectClrLst/>
-  </dgm:styleLbl>
-  <dgm:styleLbl name="asst1">
-    <dgm:fillClrLst meth="repeat">
-      <a:schemeClr val="accent2"/>
-    </dgm:fillClrLst>
-    <dgm:linClrLst meth="repeat">
-      <a:schemeClr val="lt1"/>
-    </dgm:linClrLst>
-    <dgm:effectClrLst/>
-    <dgm:txLinClrLst/>
-    <dgm:txFillClrLst/>
-    <dgm:txEffectClrLst/>
-  </dgm:styleLbl>
-  <dgm:styleLbl name="asst2">
-    <dgm:fillClrLst>
-      <a:schemeClr val="accent3"/>
-    </dgm:fillClrLst>
-    <dgm:linClrLst meth="repeat">
-      <a:schemeClr val="lt1"/>
-    </dgm:linClrLst>
-    <dgm:effectClrLst/>
-    <dgm:txLinClrLst/>
-    <dgm:txFillClrLst/>
-    <dgm:txEffectClrLst/>
-  </dgm:styleLbl>
-  <dgm:styleLbl name="asst3">
-    <dgm:fillClrLst>
-      <a:schemeClr val="accent4"/>
-    </dgm:fillClrLst>
-    <dgm:linClrLst meth="repeat">
-      <a:schemeClr val="lt1"/>
-    </dgm:linClrLst>
-    <dgm:effectClrLst/>
-    <dgm:txLinClrLst/>
-    <dgm:txFillClrLst/>
-    <dgm:txEffectClrLst/>
-  </dgm:styleLbl>
-  <dgm:styleLbl name="asst4">
-    <dgm:fillClrLst>
-      <a:schemeClr val="accent5"/>
-    </dgm:fillClrLst>
-    <dgm:linClrLst meth="repeat">
-      <a:schemeClr val="lt1"/>
-    </dgm:linClrLst>
-    <dgm:effectClrLst/>
-    <dgm:txLinClrLst/>
-    <dgm:txFillClrLst/>
-    <dgm:txEffectClrLst/>
-  </dgm:styleLbl>
-  <dgm:styleLbl name="parChTrans2D1">
-    <dgm:fillClrLst meth="repeat">
-      <a:schemeClr val="accent2"/>
-    </dgm:fillClrLst>
-    <dgm:linClrLst meth="repeat">
-      <a:schemeClr val="lt1"/>
-    </dgm:linClrLst>
-    <dgm:effectClrLst/>
-    <dgm:txLinClrLst/>
-    <dgm:txFillClrLst meth="repeat">
-      <a:schemeClr val="lt1"/>
-    </dgm:txFillClrLst>
-    <dgm:txEffectClrLst/>
-  </dgm:styleLbl>
-  <dgm:styleLbl name="parChTrans2D2">
-    <dgm:fillClrLst meth="repeat">
-      <a:schemeClr val="accent3"/>
-    </dgm:fillClrLst>
-    <dgm:linClrLst meth="repeat">
-      <a:schemeClr val="lt1"/>
-    </dgm:linClrLst>
-    <dgm:effectClrLst/>
-    <dgm:txLinClrLst/>
-    <dgm:txFillClrLst/>
-    <dgm:txEffectClrLst/>
-  </dgm:styleLbl>
-  <dgm:styleLbl name="parChTrans2D3">
-    <dgm:fillClrLst meth="repeat">
-      <a:schemeClr val="accent4"/>
-    </dgm:fillClrLst>
-    <dgm:linClrLst meth="repeat">
-      <a:schemeClr val="lt1"/>
-    </dgm:linClrLst>
-    <dgm:effectClrLst/>
-    <dgm:txLinClrLst/>
-    <dgm:txFillClrLst/>
-    <dgm:txEffectClrLst/>
-  </dgm:styleLbl>
-  <dgm:styleLbl name="parChTrans2D4">
-    <dgm:fillClrLst meth="repeat">
-      <a:schemeClr val="accent5"/>
-    </dgm:fillClrLst>
-    <dgm:linClrLst meth="repeat">
-      <a:schemeClr val="lt1"/>
-    </dgm:linClrLst>
-    <dgm:effectClrLst/>
-    <dgm:txLinClrLst/>
-    <dgm:txFillClrLst meth="repeat">
-      <a:schemeClr val="lt1"/>
-    </dgm:txFillClrLst>
-    <dgm:txEffectClrLst/>
-  </dgm:styleLbl>
-  <dgm:styleLbl name="parChTrans1D1">
-    <dgm:fillClrLst meth="repeat">
-      <a:schemeClr val="accent2"/>
-    </dgm:fillClrLst>
-    <dgm:linClrLst meth="repeat">
-      <a:schemeClr val="accent1"/>
-    </dgm:linClrLst>
-    <dgm:effectClrLst/>
-    <dgm:txLinClrLst/>
-    <dgm:txFillClrLst meth="repeat">
-      <a:schemeClr val="tx1"/>
-    </dgm:txFillClrLst>
-    <dgm:txEffectClrLst/>
-  </dgm:styleLbl>
-  <dgm:styleLbl name="parChTrans1D2">
-    <dgm:fillClrLst meth="repeat">
-      <a:schemeClr val="accent3">
-        <a:tint val="90000"/>
-      </a:schemeClr>
-    </dgm:fillClrLst>
-    <dgm:linClrLst meth="repeat">
-      <a:schemeClr val="accent2"/>
-    </dgm:linClrLst>
-    <dgm:effectClrLst/>
-    <dgm:txLinClrLst/>
-    <dgm:txFillClrLst meth="repeat">
-      <a:schemeClr val="tx1"/>
-    </dgm:txFillClrLst>
-    <dgm:txEffectClrLst/>
-  </dgm:styleLbl>
-  <dgm:styleLbl name="parChTrans1D3">
-    <dgm:fillClrLst meth="repeat">
-      <a:schemeClr val="accent4">
-        <a:tint val="70000"/>
-      </a:schemeClr>
-    </dgm:fillClrLst>
-    <dgm:linClrLst meth="repeat">
-      <a:schemeClr val="accent3"/>
-    </dgm:linClrLst>
-    <dgm:effectClrLst/>
-    <dgm:txLinClrLst/>
-    <dgm:txFillClrLst meth="repeat">
-      <a:schemeClr val="tx1"/>
-    </dgm:txFillClrLst>
-    <dgm:txEffectClrLst/>
-  </dgm:styleLbl>
-  <dgm:styleLbl name="parChTrans1D4">
-    <dgm:fillClrLst meth="repeat">
-      <a:schemeClr val="accent5">
-        <a:tint val="50000"/>
-      </a:schemeClr>
-    </dgm:fillClrLst>
-    <dgm:linClrLst meth="repeat">
-      <a:schemeClr val="accent4"/>
-    </dgm:linClrLst>
-    <dgm:effectClrLst/>
-    <dgm:txLinClrLst/>
-    <dgm:txFillClrLst meth="repeat">
-      <a:schemeClr val="tx1"/>
-    </dgm:txFillClrLst>
-    <dgm:txEffectClrLst/>
-  </dgm:styleLbl>
-  <dgm:styleLbl name="fgAcc1">
-    <dgm:fillClrLst meth="repeat">
-      <a:schemeClr val="lt1">
-        <a:alpha val="90000"/>
-      </a:schemeClr>
-    </dgm:fillClrLst>
-    <dgm:linClrLst meth="repeat">
-      <a:schemeClr val="accent2"/>
-      <a:schemeClr val="accent3"/>
-      <a:schemeClr val="accent4"/>
-      <a:schemeClr val="accent5"/>
-      <a:schemeClr val="accent6"/>
-    </dgm:linClrLst>
-    <dgm:effectClrLst/>
-    <dgm:txLinClrLst/>
-    <dgm:txFillClrLst meth="repeat">
-      <a:schemeClr val="dk1"/>
-    </dgm:txFillClrLst>
-    <dgm:txEffectClrLst/>
-  </dgm:styleLbl>
-  <dgm:styleLbl name="conFgAcc1">
-    <dgm:fillClrLst meth="repeat">
-      <a:schemeClr val="lt1">
-        <a:alpha val="90000"/>
-      </a:schemeClr>
-    </dgm:fillClrLst>
-    <dgm:linClrLst meth="repeat">
-      <a:schemeClr val="accent2"/>
-      <a:schemeClr val="accent3"/>
-      <a:schemeClr val="accent4"/>
-      <a:schemeClr val="accent5"/>
-      <a:schemeClr val="accent6"/>
-    </dgm:linClrLst>
-    <dgm:effectClrLst/>
-    <dgm:txLinClrLst/>
-    <dgm:txFillClrLst meth="repeat">
-      <a:schemeClr val="dk1"/>
-    </dgm:txFillClrLst>
-    <dgm:txEffectClrLst/>
-  </dgm:styleLbl>
-  <dgm:styleLbl name="alignAcc1">
-    <dgm:fillClrLst meth="repeat">
-      <a:schemeClr val="lt1">
-        <a:alpha val="90000"/>
-      </a:schemeClr>
-    </dgm:fillClrLst>
-    <dgm:linClrLst meth="repeat">
-      <a:schemeClr val="accent2"/>
-      <a:schemeClr val="accent3"/>
-      <a:schemeClr val="accent4"/>
-      <a:schemeClr val="accent5"/>
-      <a:schemeClr val="accent6"/>
-    </dgm:linClrLst>
-    <dgm:effectClrLst/>
-    <dgm:txLinClrLst/>
-    <dgm:txFillClrLst meth="repeat">
-      <a:schemeClr val="dk1"/>
-    </dgm:txFillClrLst>
-    <dgm:txEffectClrLst/>
-  </dgm:styleLbl>
-  <dgm:styleLbl name="trAlignAcc1">
-    <dgm:fillClrLst meth="repeat">
-      <a:schemeClr val="lt1">
-        <a:alpha val="40000"/>
-      </a:schemeClr>
-    </dgm:fillClrLst>
-    <dgm:linClrLst meth="repeat">
-      <a:schemeClr val="accent1"/>
-    </dgm:linClrLst>
-    <dgm:effectClrLst/>
-    <dgm:txLinClrLst/>
-    <dgm:txFillClrLst meth="repeat">
-      <a:schemeClr val="dk1"/>
-    </dgm:txFillClrLst>
-    <dgm:txEffectClrLst/>
-  </dgm:styleLbl>
-  <dgm:styleLbl name="bgAcc1">
-    <dgm:fillClrLst meth="repeat">
-      <a:schemeClr val="lt1">
-        <a:alpha val="90000"/>
-      </a:schemeClr>
-    </dgm:fillClrLst>
-    <dgm:linClrLst meth="repeat">
-      <a:schemeClr val="accent2"/>
-      <a:schemeClr val="accent3"/>
-      <a:schemeClr val="accent4"/>
-      <a:schemeClr val="accent5"/>
-      <a:schemeClr val="accent6"/>
-    </dgm:linClrLst>
-    <dgm:effectClrLst/>
-    <dgm:txLinClrLst/>
-    <dgm:txFillClrLst meth="repeat">
-      <a:schemeClr val="dk1"/>
-    </dgm:txFillClrLst>
-    <dgm:txEffectClrLst/>
-  </dgm:styleLbl>
-  <dgm:styleLbl name="solidFgAcc1">
-    <dgm:fillClrLst meth="repeat">
-      <a:schemeClr val="lt1"/>
-    </dgm:fillClrLst>
-    <dgm:linClrLst meth="repeat">
-      <a:schemeClr val="accent2"/>
-      <a:schemeClr val="accent3"/>
-      <a:schemeClr val="accent4"/>
-      <a:schemeClr val="accent5"/>
-      <a:schemeClr val="accent6"/>
-    </dgm:linClrLst>
-    <dgm:effectClrLst/>
-    <dgm:txLinClrLst/>
-    <dgm:txFillClrLst meth="repeat">
-      <a:schemeClr val="dk1"/>
-    </dgm:txFillClrLst>
-    <dgm:txEffectClrLst/>
-  </dgm:styleLbl>
-  <dgm:styleLbl name="solidAlignAcc1">
-    <dgm:fillClrLst meth="repeat">
-      <a:schemeClr val="lt1"/>
-    </dgm:fillClrLst>
-    <dgm:linClrLst meth="repeat">
-      <a:schemeClr val="accent2"/>
-      <a:schemeClr val="accent3"/>
-      <a:schemeClr val="accent4"/>
-      <a:schemeClr val="accent5"/>
-      <a:schemeClr val="accent6"/>
-    </dgm:linClrLst>
-    <dgm:effectClrLst/>
-    <dgm:txLinClrLst/>
-    <dgm:txFillClrLst meth="repeat">
-      <a:schemeClr val="dk1"/>
-    </dgm:txFillClrLst>
-    <dgm:txEffectClrLst/>
-  </dgm:styleLbl>
-  <dgm:styleLbl name="solidBgAcc1">
-    <dgm:fillClrLst meth="repeat">
-      <a:schemeClr val="lt1"/>
-    </dgm:fillClrLst>
-    <dgm:linClrLst meth="repeat">
-      <a:schemeClr val="accent2"/>
-      <a:schemeClr val="accent3"/>
-      <a:schemeClr val="accent4"/>
-      <a:schemeClr val="accent5"/>
-      <a:schemeClr val="accent6"/>
-    </dgm:linClrLst>
-    <dgm:effectClrLst/>
-    <dgm:txLinClrLst/>
-    <dgm:txFillClrLst meth="repeat">
-      <a:schemeClr val="dk1"/>
-    </dgm:txFillClrLst>
-    <dgm:txEffectClrLst/>
-  </dgm:styleLbl>
-  <dgm:styleLbl name="fgAccFollowNode1">
-    <dgm:fillClrLst meth="repeat">
-      <a:schemeClr val="accent2">
-        <a:tint val="40000"/>
-        <a:alpha val="90000"/>
-      </a:schemeClr>
-      <a:schemeClr val="accent3">
-        <a:tint val="40000"/>
-        <a:alpha val="90000"/>
-      </a:schemeClr>
-      <a:schemeClr val="accent4">
-        <a:tint val="40000"/>
-        <a:alpha val="90000"/>
-      </a:schemeClr>
-      <a:schemeClr val="accent5">
-        <a:tint val="40000"/>
-        <a:alpha val="90000"/>
-      </a:schemeClr>
-      <a:schemeClr val="accent6">
-        <a:tint val="40000"/>
-        <a:alpha val="90000"/>
-      </a:schemeClr>
-    </dgm:fillClrLst>
-    <dgm:linClrLst meth="repeat">
-      <a:schemeClr val="accent2">
-        <a:tint val="40000"/>
-        <a:alpha val="90000"/>
-      </a:schemeClr>
-      <a:schemeClr val="accent3">
-        <a:tint val="40000"/>
-        <a:alpha val="90000"/>
-      </a:schemeClr>
-      <a:schemeClr val="accent4">
-        <a:tint val="40000"/>
-        <a:alpha val="90000"/>
-      </a:schemeClr>
-      <a:schemeClr val="accent5">
-        <a:tint val="40000"/>
-        <a:alpha val="90000"/>
-      </a:schemeClr>
-      <a:schemeClr val="accent6">
-        <a:tint val="40000"/>
-        <a:alpha val="90000"/>
-      </a:schemeClr>
-    </dgm:linClrLst>
-    <dgm:effectClrLst/>
-    <dgm:txLinClrLst/>
-    <dgm:txFillClrLst meth="repeat">
-      <a:schemeClr val="dk1"/>
-    </dgm:txFillClrLst>
-    <dgm:txEffectClrLst/>
-  </dgm:styleLbl>
-  <dgm:styleLbl name="alignAccFollowNode1">
-    <dgm:fillClrLst meth="repeat">
-      <a:schemeClr val="accent2">
-        <a:tint val="40000"/>
-        <a:alpha val="90000"/>
-      </a:schemeClr>
-      <a:schemeClr val="accent3">
-        <a:tint val="40000"/>
-        <a:alpha val="90000"/>
-      </a:schemeClr>
-      <a:schemeClr val="accent4">
-        <a:tint val="40000"/>
-        <a:alpha val="90000"/>
-      </a:schemeClr>
-      <a:schemeClr val="accent5">
-        <a:tint val="40000"/>
-        <a:alpha val="90000"/>
-      </a:schemeClr>
-      <a:schemeClr val="accent6">
-        <a:tint val="40000"/>
-        <a:alpha val="90000"/>
-      </a:schemeClr>
-    </dgm:fillClrLst>
-    <dgm:linClrLst meth="repeat">
-      <a:schemeClr val="accent2">
-        <a:tint val="40000"/>
-        <a:alpha val="90000"/>
-      </a:schemeClr>
-      <a:schemeClr val="accent3">
-        <a:tint val="40000"/>
-        <a:alpha val="90000"/>
-      </a:schemeClr>
-      <a:schemeClr val="accent4">
-        <a:tint val="40000"/>
-        <a:alpha val="90000"/>
-      </a:schemeClr>
-      <a:schemeClr val="accent5">
-        <a:tint val="40000"/>
-        <a:alpha val="90000"/>
-      </a:schemeClr>
-      <a:schemeClr val="accent6">
-        <a:tint val="40000"/>
-        <a:alpha val="90000"/>
-      </a:schemeClr>
-    </dgm:linClrLst>
-    <dgm:effectClrLst/>
-    <dgm:txLinClrLst/>
-    <dgm:txFillClrLst meth="repeat">
-      <a:schemeClr val="dk1"/>
-    </dgm:txFillClrLst>
-    <dgm:txEffectClrLst/>
-  </dgm:styleLbl>
-  <dgm:styleLbl name="bgAccFollowNode1">
-    <dgm:fillClrLst meth="repeat">
-      <a:schemeClr val="accent2">
-        <a:tint val="40000"/>
-        <a:alpha val="90000"/>
-      </a:schemeClr>
-      <a:schemeClr val="accent3">
-        <a:tint val="40000"/>
-        <a:alpha val="90000"/>
-      </a:schemeClr>
-      <a:schemeClr val="accent4">
-        <a:tint val="40000"/>
-        <a:alpha val="90000"/>
-      </a:schemeClr>
-      <a:schemeClr val="accent5">
-        <a:tint val="40000"/>
-        <a:alpha val="90000"/>
-      </a:schemeClr>
-      <a:schemeClr val="accent6">
-        <a:tint val="40000"/>
-        <a:alpha val="90000"/>
-      </a:schemeClr>
-    </dgm:fillClrLst>
-    <dgm:linClrLst meth="repeat">
-      <a:schemeClr val="accent2">
-        <a:tint val="40000"/>
-        <a:alpha val="90000"/>
-      </a:schemeClr>
-      <a:schemeClr val="accent3">
-        <a:tint val="40000"/>
-        <a:alpha val="90000"/>
-      </a:schemeClr>
-      <a:schemeClr val="accent4">
-        <a:tint val="40000"/>
-        <a:alpha val="90000"/>
-      </a:schemeClr>
-      <a:schemeClr val="accent5">
-        <a:tint val="40000"/>
-        <a:alpha val="90000"/>
-      </a:schemeClr>
-      <a:schemeClr val="accent6">
-        <a:tint val="40000"/>
-        <a:alpha val="90000"/>
-      </a:schemeClr>
-    </dgm:linClrLst>
-    <dgm:effectClrLst/>
-    <dgm:txLinClrLst/>
-    <dgm:txFillClrLst meth="repeat">
-      <a:schemeClr val="dk1"/>
-    </dgm:txFillClrLst>
-    <dgm:txEffectClrLst/>
-  </dgm:styleLbl>
-  <dgm:styleLbl name="fgAcc0">
-    <dgm:fillClrLst meth="repeat">
-      <a:schemeClr val="lt1">
-        <a:alpha val="90000"/>
-      </a:schemeClr>
-    </dgm:fillClrLst>
-    <dgm:linClrLst>
-      <a:schemeClr val="accent1"/>
-    </dgm:linClrLst>
-    <dgm:effectClrLst/>
-    <dgm:txLinClrLst/>
-    <dgm:txFillClrLst meth="repeat">
-      <a:schemeClr val="dk1"/>
-    </dgm:txFillClrLst>
-    <dgm:txEffectClrLst/>
-  </dgm:styleLbl>
-  <dgm:styleLbl name="fgAcc2">
-    <dgm:fillClrLst meth="repeat">
-      <a:schemeClr val="lt1">
-        <a:alpha val="90000"/>
-      </a:schemeClr>
-    </dgm:fillClrLst>
-    <dgm:linClrLst>
-      <a:schemeClr val="accent2"/>
-    </dgm:linClrLst>
-    <dgm:effectClrLst/>
-    <dgm:txLinClrLst/>
-    <dgm:txFillClrLst meth="repeat">
-      <a:schemeClr val="dk1"/>
-    </dgm:txFillClrLst>
-    <dgm:txEffectClrLst/>
-  </dgm:styleLbl>
-  <dgm:styleLbl name="fgAcc3">
-    <dgm:fillClrLst meth="repeat">
-      <a:schemeClr val="lt1">
-        <a:alpha val="90000"/>
-      </a:schemeClr>
-    </dgm:fillClrLst>
-    <dgm:linClrLst>
-      <a:schemeClr val="accent3"/>
-    </dgm:linClrLst>
-    <dgm:effectClrLst/>
-    <dgm:txLinClrLst/>
-    <dgm:txFillClrLst meth="repeat">
-      <a:schemeClr val="dk1"/>
-    </dgm:txFillClrLst>
-    <dgm:txEffectClrLst/>
-  </dgm:styleLbl>
-  <dgm:styleLbl name="fgAcc4">
-    <dgm:fillClrLst meth="repeat">
-      <a:schemeClr val="lt1">
-        <a:alpha val="90000"/>
-      </a:schemeClr>
-    </dgm:fillClrLst>
-    <dgm:linClrLst>
-      <a:schemeClr val="accent4"/>
-    </dgm:linClrLst>
-    <dgm:effectClrLst/>
-    <dgm:txLinClrLst/>
-    <dgm:txFillClrLst meth="repeat">
-      <a:schemeClr val="dk1"/>
-    </dgm:txFillClrLst>
-    <dgm:txEffectClrLst/>
-  </dgm:styleLbl>
-  <dgm:styleLbl name="bgShp">
-    <dgm:fillClrLst meth="repeat">
-      <a:schemeClr val="accent2">
-        <a:tint val="40000"/>
-      </a:schemeClr>
-    </dgm:fillClrLst>
-    <dgm:linClrLst meth="repeat">
-      <a:schemeClr val="dk1"/>
-    </dgm:linClrLst>
-    <dgm:effectClrLst/>
-    <dgm:txLinClrLst/>
-    <dgm:txFillClrLst meth="repeat">
-      <a:schemeClr val="dk1"/>
-    </dgm:txFillClrLst>
-    <dgm:txEffectClrLst/>
-  </dgm:styleLbl>
-  <dgm:styleLbl name="dkBgShp">
-    <dgm:fillClrLst meth="repeat">
-      <a:schemeClr val="accent2">
-        <a:shade val="90000"/>
-      </a:schemeClr>
-    </dgm:fillClrLst>
-    <dgm:linClrLst meth="repeat">
-      <a:schemeClr val="dk1"/>
-    </dgm:linClrLst>
-    <dgm:effectClrLst/>
-    <dgm:txLinClrLst/>
-    <dgm:txFillClrLst meth="repeat">
-      <a:schemeClr val="lt1"/>
-    </dgm:txFillClrLst>
-    <dgm:txEffectClrLst/>
-  </dgm:styleLbl>
-  <dgm:styleLbl name="trBgShp">
-    <dgm:fillClrLst meth="repeat">
-      <a:schemeClr val="accent1">
-        <a:tint val="50000"/>
-        <a:alpha val="40000"/>
-      </a:schemeClr>
-    </dgm:fillClrLst>
-    <dgm:linClrLst meth="repeat">
-      <a:schemeClr val="accent2"/>
-    </dgm:linClrLst>
-    <dgm:effectClrLst/>
-    <dgm:txLinClrLst/>
-    <dgm:txFillClrLst meth="repeat">
-      <a:schemeClr val="lt1"/>
-    </dgm:txFillClrLst>
-    <dgm:txEffectClrLst/>
-  </dgm:styleLbl>
-  <dgm:styleLbl name="fgShp">
-    <dgm:fillClrLst meth="repeat">
-      <a:schemeClr val="accent2">
-        <a:tint val="40000"/>
-      </a:schemeClr>
-    </dgm:fillClrLst>
-    <dgm:linClrLst meth="repeat">
-      <a:schemeClr val="lt1"/>
-    </dgm:linClrLst>
-    <dgm:effectClrLst/>
-    <dgm:txLinClrLst/>
-    <dgm:txFillClrLst meth="repeat">
-      <a:schemeClr val="dk1"/>
-    </dgm:txFillClrLst>
-    <dgm:txEffectClrLst/>
-  </dgm:styleLbl>
-  <dgm:styleLbl name="revTx">
-    <dgm:fillClrLst meth="repeat">
-      <a:schemeClr val="lt1">
-        <a:alpha val="0"/>
-      </a:schemeClr>
-    </dgm:fillClrLst>
-    <dgm:linClrLst meth="repeat">
-      <a:schemeClr val="dk1">
-        <a:alpha val="0"/>
-      </a:schemeClr>
-    </dgm:linClrLst>
-    <dgm:effectClrLst/>
-    <dgm:txLinClrLst/>
-    <dgm:txFillClrLst meth="repeat">
-      <a:schemeClr val="tx1"/>
-    </dgm:txFillClrLst>
-    <dgm:txEffectClrLst/>
-  </dgm:styleLbl>
-</dgm:colorsDef>
-</file>
-
-<file path=ppt/diagrams/data1.xml><?xml version="1.0" encoding="utf-8"?>
-<dgm:dataModel xmlns:dgm="http://schemas.openxmlformats.org/drawingml/2006/diagram" xmlns:a="http://schemas.openxmlformats.org/drawingml/2006/main">
-  <dgm:ptLst>
-    <dgm:pt modelId="{054F5539-A4B2-4FEE-A14D-FA1C40DA1A04}" type="doc">
-      <dgm:prSet loTypeId="urn:microsoft.com/office/officeart/2016/7/layout/VerticalDownArrowProcess" loCatId="process" qsTypeId="urn:microsoft.com/office/officeart/2005/8/quickstyle/simple1" qsCatId="simple" csTypeId="urn:microsoft.com/office/officeart/2005/8/colors/colorful1" csCatId="colorful" phldr="1"/>
-      <dgm:spPr/>
-      <dgm:t>
-        <a:bodyPr/>
-        <a:lstStyle/>
-        <a:p>
-          <a:endParaRPr lang="en-US"/>
-        </a:p>
-      </dgm:t>
-    </dgm:pt>
-    <dgm:pt modelId="{9B453CB0-161B-4585-9690-EF5C96AC0561}">
-      <dgm:prSet/>
-      <dgm:spPr/>
-      <dgm:t>
-        <a:bodyPr/>
-        <a:lstStyle/>
-        <a:p>
-          <a:r>
-            <a:rPr lang="en-US"/>
-            <a:t>Step 1</a:t>
-          </a:r>
-        </a:p>
-      </dgm:t>
-    </dgm:pt>
-    <dgm:pt modelId="{FA693E23-FB71-4DFC-B4CC-0E8A44700A6B}" type="parTrans" cxnId="{F94392AE-4D3C-4412-B053-476917C9251E}">
-      <dgm:prSet/>
-      <dgm:spPr/>
-      <dgm:t>
-        <a:bodyPr/>
-        <a:lstStyle/>
-        <a:p>
-          <a:endParaRPr lang="en-US"/>
-        </a:p>
-      </dgm:t>
-    </dgm:pt>
-    <dgm:pt modelId="{57C530ED-327E-4F53-9E8B-4490FF5CD35C}" type="sibTrans" cxnId="{F94392AE-4D3C-4412-B053-476917C9251E}">
-      <dgm:prSet/>
-      <dgm:spPr/>
-      <dgm:t>
-        <a:bodyPr/>
-        <a:lstStyle/>
-        <a:p>
-          <a:endParaRPr lang="en-US"/>
-        </a:p>
-      </dgm:t>
-    </dgm:pt>
-    <dgm:pt modelId="{87A60A5B-482C-4AD5-A6E5-D153689F4441}">
-      <dgm:prSet/>
-      <dgm:spPr/>
-      <dgm:t>
-        <a:bodyPr/>
-        <a:lstStyle/>
-        <a:p>
-          <a:endParaRPr lang="en-US" dirty="0"/>
-        </a:p>
-      </dgm:t>
-    </dgm:pt>
-    <dgm:pt modelId="{FF7B3691-CFFD-4F2B-89CB-CDC6A42A9117}" type="parTrans" cxnId="{48EA755B-F6D2-4E93-9AD7-44D32C32175B}">
-      <dgm:prSet/>
-      <dgm:spPr/>
-      <dgm:t>
-        <a:bodyPr/>
-        <a:lstStyle/>
-        <a:p>
-          <a:endParaRPr lang="en-US"/>
-        </a:p>
-      </dgm:t>
-    </dgm:pt>
-    <dgm:pt modelId="{4CF983F8-A278-40BD-BC0D-C70610B1D870}" type="sibTrans" cxnId="{48EA755B-F6D2-4E93-9AD7-44D32C32175B}">
-      <dgm:prSet/>
-      <dgm:spPr/>
-      <dgm:t>
-        <a:bodyPr/>
-        <a:lstStyle/>
-        <a:p>
-          <a:endParaRPr lang="en-US"/>
-        </a:p>
-      </dgm:t>
-    </dgm:pt>
-    <dgm:pt modelId="{D610ED89-638F-4716-BD0A-DF71726D5551}">
-      <dgm:prSet/>
-      <dgm:spPr/>
-      <dgm:t>
-        <a:bodyPr/>
-        <a:lstStyle/>
-        <a:p>
-          <a:r>
-            <a:rPr lang="en-US"/>
-            <a:t>Step 2</a:t>
-          </a:r>
-        </a:p>
-      </dgm:t>
-    </dgm:pt>
-    <dgm:pt modelId="{7FB1D790-10EA-4363-A918-FF0FD601558C}" type="parTrans" cxnId="{39B27E9D-4C8B-4AF5-A464-6508351846F1}">
-      <dgm:prSet/>
-      <dgm:spPr/>
-      <dgm:t>
-        <a:bodyPr/>
-        <a:lstStyle/>
-        <a:p>
-          <a:endParaRPr lang="en-US"/>
-        </a:p>
-      </dgm:t>
-    </dgm:pt>
-    <dgm:pt modelId="{1D5951E0-348B-41B9-B98B-393B87F2D50A}" type="sibTrans" cxnId="{39B27E9D-4C8B-4AF5-A464-6508351846F1}">
-      <dgm:prSet/>
-      <dgm:spPr/>
-      <dgm:t>
-        <a:bodyPr/>
-        <a:lstStyle/>
-        <a:p>
-          <a:endParaRPr lang="en-US"/>
-        </a:p>
-      </dgm:t>
-    </dgm:pt>
-    <dgm:pt modelId="{0D1E1E27-82CA-41D5-9B41-4CE86FAC852E}">
-      <dgm:prSet/>
-      <dgm:spPr/>
-      <dgm:t>
-        <a:bodyPr/>
-        <a:lstStyle/>
-        <a:p>
-          <a:endParaRPr lang="en-US" dirty="0"/>
-        </a:p>
-      </dgm:t>
-    </dgm:pt>
-    <dgm:pt modelId="{8D890A82-9841-4427-BAD8-BB35D5CF0EA5}" type="parTrans" cxnId="{44421614-120A-4780-952D-54497DBB42ED}">
-      <dgm:prSet/>
-      <dgm:spPr/>
-      <dgm:t>
-        <a:bodyPr/>
-        <a:lstStyle/>
-        <a:p>
-          <a:endParaRPr lang="en-US"/>
-        </a:p>
-      </dgm:t>
-    </dgm:pt>
-    <dgm:pt modelId="{08AB264C-69F7-4285-9E14-E43C11385752}" type="sibTrans" cxnId="{44421614-120A-4780-952D-54497DBB42ED}">
-      <dgm:prSet/>
-      <dgm:spPr/>
-      <dgm:t>
-        <a:bodyPr/>
-        <a:lstStyle/>
-        <a:p>
-          <a:endParaRPr lang="en-US"/>
-        </a:p>
-      </dgm:t>
-    </dgm:pt>
-    <dgm:pt modelId="{CF4DC95C-4970-42B3-A322-496294BAE48D}">
-      <dgm:prSet/>
-      <dgm:spPr/>
-      <dgm:t>
-        <a:bodyPr/>
-        <a:lstStyle/>
-        <a:p>
-          <a:r>
-            <a:rPr lang="en-US"/>
-            <a:t>Step 3</a:t>
-          </a:r>
-        </a:p>
-      </dgm:t>
-    </dgm:pt>
-    <dgm:pt modelId="{16B00682-E294-46FB-B3F9-BC111E4135BC}" type="parTrans" cxnId="{61A13AEC-E7F6-4371-9B3C-D229F1D6B5C5}">
-      <dgm:prSet/>
-      <dgm:spPr/>
-      <dgm:t>
-        <a:bodyPr/>
-        <a:lstStyle/>
-        <a:p>
-          <a:endParaRPr lang="en-US"/>
-        </a:p>
-      </dgm:t>
-    </dgm:pt>
-    <dgm:pt modelId="{ABFACD7A-CFAF-4862-BB02-AC2A480CB979}" type="sibTrans" cxnId="{61A13AEC-E7F6-4371-9B3C-D229F1D6B5C5}">
-      <dgm:prSet/>
-      <dgm:spPr/>
-      <dgm:t>
-        <a:bodyPr/>
-        <a:lstStyle/>
-        <a:p>
-          <a:endParaRPr lang="en-US"/>
-        </a:p>
-      </dgm:t>
-    </dgm:pt>
-    <dgm:pt modelId="{FF331CDF-855B-4173-9A70-BF7C7C7A45AA}">
-      <dgm:prSet/>
-      <dgm:spPr/>
-      <dgm:t>
-        <a:bodyPr/>
-        <a:lstStyle/>
-        <a:p>
-          <a:endParaRPr lang="en-US" dirty="0"/>
-        </a:p>
-      </dgm:t>
-    </dgm:pt>
-    <dgm:pt modelId="{0D12DB5C-BA05-47E4-B00C-F945B57C60F8}" type="parTrans" cxnId="{DB133841-4C22-43B9-9C8F-B0B0F1022A51}">
-      <dgm:prSet/>
-      <dgm:spPr/>
-      <dgm:t>
-        <a:bodyPr/>
-        <a:lstStyle/>
-        <a:p>
-          <a:endParaRPr lang="en-US"/>
-        </a:p>
-      </dgm:t>
-    </dgm:pt>
-    <dgm:pt modelId="{B9F51368-D885-4CD4-9A93-689146EFA290}" type="sibTrans" cxnId="{DB133841-4C22-43B9-9C8F-B0B0F1022A51}">
-      <dgm:prSet/>
-      <dgm:spPr/>
-      <dgm:t>
-        <a:bodyPr/>
-        <a:lstStyle/>
-        <a:p>
-          <a:endParaRPr lang="en-US"/>
-        </a:p>
-      </dgm:t>
-    </dgm:pt>
-    <dgm:pt modelId="{D032B980-8EA0-45C4-94CD-11681523ED9B}">
-      <dgm:prSet/>
-      <dgm:spPr/>
-      <dgm:t>
-        <a:bodyPr/>
-        <a:lstStyle/>
-        <a:p>
-          <a:r>
-            <a:rPr lang="en-US"/>
-            <a:t>Step 4</a:t>
-          </a:r>
-        </a:p>
-      </dgm:t>
-    </dgm:pt>
-    <dgm:pt modelId="{01EC26F4-0092-474A-A7DB-3061A1C71497}" type="parTrans" cxnId="{E844F8B4-2E87-409D-8D59-EF8A996CD68E}">
-      <dgm:prSet/>
-      <dgm:spPr/>
-      <dgm:t>
-        <a:bodyPr/>
-        <a:lstStyle/>
-        <a:p>
-          <a:endParaRPr lang="en-US"/>
-        </a:p>
-      </dgm:t>
-    </dgm:pt>
-    <dgm:pt modelId="{148346F7-A47A-48D9-9326-7C1CBF78CEE7}" type="sibTrans" cxnId="{E844F8B4-2E87-409D-8D59-EF8A996CD68E}">
-      <dgm:prSet/>
-      <dgm:spPr/>
-      <dgm:t>
-        <a:bodyPr/>
-        <a:lstStyle/>
-        <a:p>
-          <a:endParaRPr lang="en-US"/>
-        </a:p>
-      </dgm:t>
-    </dgm:pt>
-    <dgm:pt modelId="{A4127645-66A7-4D14-A962-F106C8024E5E}">
-      <dgm:prSet/>
-      <dgm:spPr/>
-      <dgm:t>
-        <a:bodyPr/>
-        <a:lstStyle/>
-        <a:p>
-          <a:endParaRPr lang="en-US" dirty="0"/>
-        </a:p>
-      </dgm:t>
-    </dgm:pt>
-    <dgm:pt modelId="{1425AA94-0E14-4E88-859D-335681E52552}" type="parTrans" cxnId="{6DA8AE73-FEB7-45F1-BEA4-9095738EF64A}">
-      <dgm:prSet/>
-      <dgm:spPr/>
-      <dgm:t>
-        <a:bodyPr/>
-        <a:lstStyle/>
-        <a:p>
-          <a:endParaRPr lang="en-US"/>
-        </a:p>
-      </dgm:t>
-    </dgm:pt>
-    <dgm:pt modelId="{01DDBEC6-EBD4-467B-8EDC-BB1B59B8ECD1}" type="sibTrans" cxnId="{6DA8AE73-FEB7-45F1-BEA4-9095738EF64A}">
-      <dgm:prSet/>
-      <dgm:spPr/>
-      <dgm:t>
-        <a:bodyPr/>
-        <a:lstStyle/>
-        <a:p>
-          <a:endParaRPr lang="en-US"/>
-        </a:p>
-      </dgm:t>
-    </dgm:pt>
-    <dgm:pt modelId="{1DFC9E3C-0C21-428E-8DDB-4DBBE100A96B}">
-      <dgm:prSet/>
-      <dgm:spPr/>
-      <dgm:t>
-        <a:bodyPr/>
-        <a:lstStyle/>
-        <a:p>
-          <a:r>
-            <a:rPr lang="en-US"/>
-            <a:t>Step 5</a:t>
-          </a:r>
-        </a:p>
-      </dgm:t>
-    </dgm:pt>
-    <dgm:pt modelId="{E528EC6B-C75B-47B1-B637-B54FB2837A10}" type="parTrans" cxnId="{0C9439E6-59F5-450D-9939-6DD9FA275CA5}">
-      <dgm:prSet/>
-      <dgm:spPr/>
-      <dgm:t>
-        <a:bodyPr/>
-        <a:lstStyle/>
-        <a:p>
-          <a:endParaRPr lang="en-US"/>
-        </a:p>
-      </dgm:t>
-    </dgm:pt>
-    <dgm:pt modelId="{CB477C9B-DC8B-4FC3-9139-A0E2C70D9711}" type="sibTrans" cxnId="{0C9439E6-59F5-450D-9939-6DD9FA275CA5}">
-      <dgm:prSet/>
-      <dgm:spPr/>
-      <dgm:t>
-        <a:bodyPr/>
-        <a:lstStyle/>
-        <a:p>
-          <a:endParaRPr lang="en-US"/>
-        </a:p>
-      </dgm:t>
-    </dgm:pt>
-    <dgm:pt modelId="{8528CF68-4B35-4D8F-9A63-AA61D6100817}">
-      <dgm:prSet/>
-      <dgm:spPr/>
-      <dgm:t>
-        <a:bodyPr/>
-        <a:lstStyle/>
-        <a:p>
-          <a:endParaRPr lang="en-US" dirty="0"/>
-        </a:p>
-      </dgm:t>
-    </dgm:pt>
-    <dgm:pt modelId="{B78FD11E-EE0C-4F52-8D05-B5BECE946536}" type="parTrans" cxnId="{DB60F469-EF34-4F2D-8DEF-C25D2B99700B}">
-      <dgm:prSet/>
-      <dgm:spPr/>
-      <dgm:t>
-        <a:bodyPr/>
-        <a:lstStyle/>
-        <a:p>
-          <a:endParaRPr lang="en-US"/>
-        </a:p>
-      </dgm:t>
-    </dgm:pt>
-    <dgm:pt modelId="{2B400DD6-1458-4846-9D85-C14DDE87E229}" type="sibTrans" cxnId="{DB60F469-EF34-4F2D-8DEF-C25D2B99700B}">
-      <dgm:prSet/>
-      <dgm:spPr/>
-      <dgm:t>
-        <a:bodyPr/>
-        <a:lstStyle/>
-        <a:p>
-          <a:endParaRPr lang="en-US"/>
-        </a:p>
-      </dgm:t>
-    </dgm:pt>
-    <dgm:pt modelId="{8D77AF8C-F19A-4226-AE34-79F79F00CAA1}">
-      <dgm:prSet/>
-      <dgm:spPr/>
-      <dgm:t>
-        <a:bodyPr/>
-        <a:lstStyle/>
-        <a:p>
-          <a:r>
-            <a:rPr lang="en-US"/>
-            <a:t>Step 6</a:t>
-          </a:r>
-        </a:p>
-      </dgm:t>
-    </dgm:pt>
-    <dgm:pt modelId="{F91A3FB7-F705-44CB-8B02-783CBE2F6024}" type="parTrans" cxnId="{1AF4D3C2-61B6-4483-9114-9064A690FA07}">
-      <dgm:prSet/>
-      <dgm:spPr/>
-      <dgm:t>
-        <a:bodyPr/>
-        <a:lstStyle/>
-        <a:p>
-          <a:endParaRPr lang="en-US"/>
-        </a:p>
-      </dgm:t>
-    </dgm:pt>
-    <dgm:pt modelId="{7F6FFC55-3ABF-477B-8D0A-31BF8F0D97F8}" type="sibTrans" cxnId="{1AF4D3C2-61B6-4483-9114-9064A690FA07}">
-      <dgm:prSet/>
-      <dgm:spPr/>
-      <dgm:t>
-        <a:bodyPr/>
-        <a:lstStyle/>
-        <a:p>
-          <a:endParaRPr lang="en-US"/>
-        </a:p>
-      </dgm:t>
-    </dgm:pt>
-    <dgm:pt modelId="{A7A6DF71-F1C4-4BB3-98DA-F3752204B3FF}">
-      <dgm:prSet/>
-      <dgm:spPr/>
-      <dgm:t>
-        <a:bodyPr/>
-        <a:lstStyle/>
-        <a:p>
-          <a:endParaRPr lang="en-US" dirty="0"/>
-        </a:p>
-      </dgm:t>
-    </dgm:pt>
-    <dgm:pt modelId="{2B90D3B0-87D6-42C3-89AD-5E0510E15EE7}" type="parTrans" cxnId="{9C336E40-2074-461A-BAFB-D5EDDD098D9B}">
-      <dgm:prSet/>
-      <dgm:spPr/>
-      <dgm:t>
-        <a:bodyPr/>
-        <a:lstStyle/>
-        <a:p>
-          <a:endParaRPr lang="en-US"/>
-        </a:p>
-      </dgm:t>
-    </dgm:pt>
-    <dgm:pt modelId="{7AAAEBEA-E194-4043-9B72-5AB2895C9CD3}" type="sibTrans" cxnId="{9C336E40-2074-461A-BAFB-D5EDDD098D9B}">
-      <dgm:prSet/>
-      <dgm:spPr/>
-      <dgm:t>
-        <a:bodyPr/>
-        <a:lstStyle/>
-        <a:p>
-          <a:endParaRPr lang="en-US"/>
-        </a:p>
-      </dgm:t>
-    </dgm:pt>
-    <dgm:pt modelId="{8CBE272C-DFEC-3E45-AFDE-7830A02CF440}" type="pres">
-      <dgm:prSet presAssocID="{054F5539-A4B2-4FEE-A14D-FA1C40DA1A04}" presName="Name0" presStyleCnt="0">
-        <dgm:presLayoutVars>
-          <dgm:dir/>
-          <dgm:animLvl val="lvl"/>
-          <dgm:resizeHandles val="exact"/>
-        </dgm:presLayoutVars>
-      </dgm:prSet>
-      <dgm:spPr/>
-    </dgm:pt>
-    <dgm:pt modelId="{C8D06AD8-D842-F045-8085-F43473BC625B}" type="pres">
-      <dgm:prSet presAssocID="{8D77AF8C-F19A-4226-AE34-79F79F00CAA1}" presName="boxAndChildren" presStyleCnt="0"/>
-      <dgm:spPr/>
-    </dgm:pt>
-    <dgm:pt modelId="{A4A5C01C-9CEA-7542-A9DA-F0BCE5A9D71E}" type="pres">
-      <dgm:prSet presAssocID="{8D77AF8C-F19A-4226-AE34-79F79F00CAA1}" presName="parentTextBox" presStyleLbl="alignNode1" presStyleIdx="0" presStyleCnt="6"/>
-      <dgm:spPr/>
-    </dgm:pt>
-    <dgm:pt modelId="{A4DCEA11-1C52-B84D-831C-C6E82835E69F}" type="pres">
-      <dgm:prSet presAssocID="{8D77AF8C-F19A-4226-AE34-79F79F00CAA1}" presName="descendantBox" presStyleLbl="bgAccFollowNode1" presStyleIdx="0" presStyleCnt="6"/>
-      <dgm:spPr/>
-    </dgm:pt>
-    <dgm:pt modelId="{95DA5E82-5E48-AB4A-90E0-9E1B14315635}" type="pres">
-      <dgm:prSet presAssocID="{CB477C9B-DC8B-4FC3-9139-A0E2C70D9711}" presName="sp" presStyleCnt="0"/>
-      <dgm:spPr/>
-    </dgm:pt>
-    <dgm:pt modelId="{86968BF5-40DD-A34D-8CF7-A6192843846F}" type="pres">
-      <dgm:prSet presAssocID="{1DFC9E3C-0C21-428E-8DDB-4DBBE100A96B}" presName="arrowAndChildren" presStyleCnt="0"/>
-      <dgm:spPr/>
-    </dgm:pt>
-    <dgm:pt modelId="{BFBDC332-3138-214B-A1F1-13EAD053CC66}" type="pres">
-      <dgm:prSet presAssocID="{1DFC9E3C-0C21-428E-8DDB-4DBBE100A96B}" presName="parentTextArrow" presStyleLbl="node1" presStyleIdx="0" presStyleCnt="0"/>
-      <dgm:spPr/>
-    </dgm:pt>
-    <dgm:pt modelId="{59612E42-2966-7D4B-8F21-AF4D32219590}" type="pres">
-      <dgm:prSet presAssocID="{1DFC9E3C-0C21-428E-8DDB-4DBBE100A96B}" presName="arrow" presStyleLbl="alignNode1" presStyleIdx="1" presStyleCnt="6"/>
-      <dgm:spPr/>
-    </dgm:pt>
-    <dgm:pt modelId="{C2A69F78-D06B-8642-9EF8-2DFE7BC3FE00}" type="pres">
-      <dgm:prSet presAssocID="{1DFC9E3C-0C21-428E-8DDB-4DBBE100A96B}" presName="descendantArrow" presStyleLbl="bgAccFollowNode1" presStyleIdx="1" presStyleCnt="6"/>
-      <dgm:spPr/>
-    </dgm:pt>
-    <dgm:pt modelId="{1452FA4D-1DEA-5342-8F11-F68942AE28AB}" type="pres">
-      <dgm:prSet presAssocID="{148346F7-A47A-48D9-9326-7C1CBF78CEE7}" presName="sp" presStyleCnt="0"/>
-      <dgm:spPr/>
-    </dgm:pt>
-    <dgm:pt modelId="{0ACC7AC5-BA94-A648-A5C7-13337D94E2F6}" type="pres">
-      <dgm:prSet presAssocID="{D032B980-8EA0-45C4-94CD-11681523ED9B}" presName="arrowAndChildren" presStyleCnt="0"/>
-      <dgm:spPr/>
-    </dgm:pt>
-    <dgm:pt modelId="{ED15DB2C-D5D3-F044-9CF3-AF03D8CA1D4B}" type="pres">
-      <dgm:prSet presAssocID="{D032B980-8EA0-45C4-94CD-11681523ED9B}" presName="parentTextArrow" presStyleLbl="node1" presStyleIdx="0" presStyleCnt="0"/>
-      <dgm:spPr/>
-    </dgm:pt>
-    <dgm:pt modelId="{8C01F75D-600F-D849-A747-509E8DF8D7E6}" type="pres">
-      <dgm:prSet presAssocID="{D032B980-8EA0-45C4-94CD-11681523ED9B}" presName="arrow" presStyleLbl="alignNode1" presStyleIdx="2" presStyleCnt="6"/>
-      <dgm:spPr/>
-    </dgm:pt>
-    <dgm:pt modelId="{CE355F69-3EFD-FC43-B36A-0B710B93612D}" type="pres">
-      <dgm:prSet presAssocID="{D032B980-8EA0-45C4-94CD-11681523ED9B}" presName="descendantArrow" presStyleLbl="bgAccFollowNode1" presStyleIdx="2" presStyleCnt="6"/>
-      <dgm:spPr/>
-    </dgm:pt>
-    <dgm:pt modelId="{18F2BC71-4D0B-0C4E-8099-0F0767B00F21}" type="pres">
-      <dgm:prSet presAssocID="{ABFACD7A-CFAF-4862-BB02-AC2A480CB979}" presName="sp" presStyleCnt="0"/>
-      <dgm:spPr/>
-    </dgm:pt>
-    <dgm:pt modelId="{6CB34CEA-60BF-1A4C-B4E7-3AA96A152836}" type="pres">
-      <dgm:prSet presAssocID="{CF4DC95C-4970-42B3-A322-496294BAE48D}" presName="arrowAndChildren" presStyleCnt="0"/>
-      <dgm:spPr/>
-    </dgm:pt>
-    <dgm:pt modelId="{10977552-9294-7341-AEB9-BE68B0473891}" type="pres">
-      <dgm:prSet presAssocID="{CF4DC95C-4970-42B3-A322-496294BAE48D}" presName="parentTextArrow" presStyleLbl="node1" presStyleIdx="0" presStyleCnt="0"/>
-      <dgm:spPr/>
-    </dgm:pt>
-    <dgm:pt modelId="{176FB10E-67F2-244A-9C51-F1A5D4E7014B}" type="pres">
-      <dgm:prSet presAssocID="{CF4DC95C-4970-42B3-A322-496294BAE48D}" presName="arrow" presStyleLbl="alignNode1" presStyleIdx="3" presStyleCnt="6"/>
-      <dgm:spPr/>
-    </dgm:pt>
-    <dgm:pt modelId="{B5ADD037-1B52-0741-85DE-261FBD030161}" type="pres">
-      <dgm:prSet presAssocID="{CF4DC95C-4970-42B3-A322-496294BAE48D}" presName="descendantArrow" presStyleLbl="bgAccFollowNode1" presStyleIdx="3" presStyleCnt="6"/>
-      <dgm:spPr/>
-    </dgm:pt>
-    <dgm:pt modelId="{E0985A41-6445-5346-A233-1C098977BC8B}" type="pres">
-      <dgm:prSet presAssocID="{1D5951E0-348B-41B9-B98B-393B87F2D50A}" presName="sp" presStyleCnt="0"/>
-      <dgm:spPr/>
-    </dgm:pt>
-    <dgm:pt modelId="{0696557E-84D9-4845-BB42-819641E758FC}" type="pres">
-      <dgm:prSet presAssocID="{D610ED89-638F-4716-BD0A-DF71726D5551}" presName="arrowAndChildren" presStyleCnt="0"/>
-      <dgm:spPr/>
-    </dgm:pt>
-    <dgm:pt modelId="{67523CA7-E1FC-C74E-830E-94853D532541}" type="pres">
-      <dgm:prSet presAssocID="{D610ED89-638F-4716-BD0A-DF71726D5551}" presName="parentTextArrow" presStyleLbl="node1" presStyleIdx="0" presStyleCnt="0"/>
-      <dgm:spPr/>
-    </dgm:pt>
-    <dgm:pt modelId="{65CC2DDA-74B7-1C40-9934-246CA94A0A05}" type="pres">
-      <dgm:prSet presAssocID="{D610ED89-638F-4716-BD0A-DF71726D5551}" presName="arrow" presStyleLbl="alignNode1" presStyleIdx="4" presStyleCnt="6"/>
-      <dgm:spPr/>
-    </dgm:pt>
-    <dgm:pt modelId="{64E655E2-8A0E-AC40-BEC2-54C12707DA08}" type="pres">
-      <dgm:prSet presAssocID="{D610ED89-638F-4716-BD0A-DF71726D5551}" presName="descendantArrow" presStyleLbl="bgAccFollowNode1" presStyleIdx="4" presStyleCnt="6"/>
-      <dgm:spPr/>
-    </dgm:pt>
-    <dgm:pt modelId="{C97009CD-0E4D-F94E-AE4A-6A7E84864B1E}" type="pres">
-      <dgm:prSet presAssocID="{57C530ED-327E-4F53-9E8B-4490FF5CD35C}" presName="sp" presStyleCnt="0"/>
-      <dgm:spPr/>
-    </dgm:pt>
-    <dgm:pt modelId="{72B03B82-A775-DD47-94DD-2948BCDE37F9}" type="pres">
-      <dgm:prSet presAssocID="{9B453CB0-161B-4585-9690-EF5C96AC0561}" presName="arrowAndChildren" presStyleCnt="0"/>
-      <dgm:spPr/>
-    </dgm:pt>
-    <dgm:pt modelId="{6792E3CC-CC2C-2F42-9E59-6B2599D9ED15}" type="pres">
-      <dgm:prSet presAssocID="{9B453CB0-161B-4585-9690-EF5C96AC0561}" presName="parentTextArrow" presStyleLbl="node1" presStyleIdx="0" presStyleCnt="0"/>
-      <dgm:spPr/>
-    </dgm:pt>
-    <dgm:pt modelId="{772BFCBB-F9A7-754D-A415-B99AFA81DF30}" type="pres">
-      <dgm:prSet presAssocID="{9B453CB0-161B-4585-9690-EF5C96AC0561}" presName="arrow" presStyleLbl="alignNode1" presStyleIdx="5" presStyleCnt="6"/>
-      <dgm:spPr/>
-    </dgm:pt>
-    <dgm:pt modelId="{D5C2C13A-A3EF-644D-B983-85DA242B99E6}" type="pres">
-      <dgm:prSet presAssocID="{9B453CB0-161B-4585-9690-EF5C96AC0561}" presName="descendantArrow" presStyleLbl="bgAccFollowNode1" presStyleIdx="5" presStyleCnt="6"/>
-      <dgm:spPr/>
-    </dgm:pt>
-  </dgm:ptLst>
-  <dgm:cxnLst>
-    <dgm:cxn modelId="{44421614-120A-4780-952D-54497DBB42ED}" srcId="{D610ED89-638F-4716-BD0A-DF71726D5551}" destId="{0D1E1E27-82CA-41D5-9B41-4CE86FAC852E}" srcOrd="0" destOrd="0" parTransId="{8D890A82-9841-4427-BAD8-BB35D5CF0EA5}" sibTransId="{08AB264C-69F7-4285-9E14-E43C11385752}"/>
-    <dgm:cxn modelId="{7FFCEC18-DC7C-6349-A61D-F8FFA8BFEAF5}" type="presOf" srcId="{0D1E1E27-82CA-41D5-9B41-4CE86FAC852E}" destId="{64E655E2-8A0E-AC40-BEC2-54C12707DA08}" srcOrd="0" destOrd="0" presId="urn:microsoft.com/office/officeart/2016/7/layout/VerticalDownArrowProcess"/>
-    <dgm:cxn modelId="{6CD47019-DEBA-CA4C-96D0-391B54E7E6B4}" type="presOf" srcId="{D610ED89-638F-4716-BD0A-DF71726D5551}" destId="{65CC2DDA-74B7-1C40-9934-246CA94A0A05}" srcOrd="1" destOrd="0" presId="urn:microsoft.com/office/officeart/2016/7/layout/VerticalDownArrowProcess"/>
-    <dgm:cxn modelId="{5F9DC12A-E59A-D84C-9FC3-65397C6983C0}" type="presOf" srcId="{D032B980-8EA0-45C4-94CD-11681523ED9B}" destId="{8C01F75D-600F-D849-A747-509E8DF8D7E6}" srcOrd="1" destOrd="0" presId="urn:microsoft.com/office/officeart/2016/7/layout/VerticalDownArrowProcess"/>
-    <dgm:cxn modelId="{74A7543A-BFD4-7348-8EB3-4B21B550ABD5}" type="presOf" srcId="{D610ED89-638F-4716-BD0A-DF71726D5551}" destId="{67523CA7-E1FC-C74E-830E-94853D532541}" srcOrd="0" destOrd="0" presId="urn:microsoft.com/office/officeart/2016/7/layout/VerticalDownArrowProcess"/>
-    <dgm:cxn modelId="{4D9D803C-85CC-1C4D-BF3F-51C92B250430}" type="presOf" srcId="{FF331CDF-855B-4173-9A70-BF7C7C7A45AA}" destId="{B5ADD037-1B52-0741-85DE-261FBD030161}" srcOrd="0" destOrd="0" presId="urn:microsoft.com/office/officeart/2016/7/layout/VerticalDownArrowProcess"/>
-    <dgm:cxn modelId="{9C336E40-2074-461A-BAFB-D5EDDD098D9B}" srcId="{8D77AF8C-F19A-4226-AE34-79F79F00CAA1}" destId="{A7A6DF71-F1C4-4BB3-98DA-F3752204B3FF}" srcOrd="0" destOrd="0" parTransId="{2B90D3B0-87D6-42C3-89AD-5E0510E15EE7}" sibTransId="{7AAAEBEA-E194-4043-9B72-5AB2895C9CD3}"/>
-    <dgm:cxn modelId="{48EA755B-F6D2-4E93-9AD7-44D32C32175B}" srcId="{9B453CB0-161B-4585-9690-EF5C96AC0561}" destId="{87A60A5B-482C-4AD5-A6E5-D153689F4441}" srcOrd="0" destOrd="0" parTransId="{FF7B3691-CFFD-4F2B-89CB-CDC6A42A9117}" sibTransId="{4CF983F8-A278-40BD-BC0D-C70610B1D870}"/>
-    <dgm:cxn modelId="{DB133841-4C22-43B9-9C8F-B0B0F1022A51}" srcId="{CF4DC95C-4970-42B3-A322-496294BAE48D}" destId="{FF331CDF-855B-4173-9A70-BF7C7C7A45AA}" srcOrd="0" destOrd="0" parTransId="{0D12DB5C-BA05-47E4-B00C-F945B57C60F8}" sibTransId="{B9F51368-D885-4CD4-9A93-689146EFA290}"/>
-    <dgm:cxn modelId="{86F26842-E882-064F-B589-93B5270081CA}" type="presOf" srcId="{1DFC9E3C-0C21-428E-8DDB-4DBBE100A96B}" destId="{BFBDC332-3138-214B-A1F1-13EAD053CC66}" srcOrd="0" destOrd="0" presId="urn:microsoft.com/office/officeart/2016/7/layout/VerticalDownArrowProcess"/>
-    <dgm:cxn modelId="{13428E48-266C-7D45-B16B-93523EA24303}" type="presOf" srcId="{87A60A5B-482C-4AD5-A6E5-D153689F4441}" destId="{D5C2C13A-A3EF-644D-B983-85DA242B99E6}" srcOrd="0" destOrd="0" presId="urn:microsoft.com/office/officeart/2016/7/layout/VerticalDownArrowProcess"/>
-    <dgm:cxn modelId="{F2AC0569-737A-014E-B5BA-33DBCDAD2A76}" type="presOf" srcId="{9B453CB0-161B-4585-9690-EF5C96AC0561}" destId="{6792E3CC-CC2C-2F42-9E59-6B2599D9ED15}" srcOrd="0" destOrd="0" presId="urn:microsoft.com/office/officeart/2016/7/layout/VerticalDownArrowProcess"/>
-    <dgm:cxn modelId="{DB60F469-EF34-4F2D-8DEF-C25D2B99700B}" srcId="{1DFC9E3C-0C21-428E-8DDB-4DBBE100A96B}" destId="{8528CF68-4B35-4D8F-9A63-AA61D6100817}" srcOrd="0" destOrd="0" parTransId="{B78FD11E-EE0C-4F52-8D05-B5BECE946536}" sibTransId="{2B400DD6-1458-4846-9D85-C14DDE87E229}"/>
-    <dgm:cxn modelId="{BD911551-34B3-2046-AAFC-B3AF9D609CFC}" type="presOf" srcId="{8D77AF8C-F19A-4226-AE34-79F79F00CAA1}" destId="{A4A5C01C-9CEA-7542-A9DA-F0BCE5A9D71E}" srcOrd="0" destOrd="0" presId="urn:microsoft.com/office/officeart/2016/7/layout/VerticalDownArrowProcess"/>
-    <dgm:cxn modelId="{6DA8AE73-FEB7-45F1-BEA4-9095738EF64A}" srcId="{D032B980-8EA0-45C4-94CD-11681523ED9B}" destId="{A4127645-66A7-4D14-A962-F106C8024E5E}" srcOrd="0" destOrd="0" parTransId="{1425AA94-0E14-4E88-859D-335681E52552}" sibTransId="{01DDBEC6-EBD4-467B-8EDC-BB1B59B8ECD1}"/>
-    <dgm:cxn modelId="{E9A00054-562F-A343-8D3E-923C7C072006}" type="presOf" srcId="{8528CF68-4B35-4D8F-9A63-AA61D6100817}" destId="{C2A69F78-D06B-8642-9EF8-2DFE7BC3FE00}" srcOrd="0" destOrd="0" presId="urn:microsoft.com/office/officeart/2016/7/layout/VerticalDownArrowProcess"/>
-    <dgm:cxn modelId="{2B62F086-753D-714F-9224-3BBC13D86377}" type="presOf" srcId="{A4127645-66A7-4D14-A962-F106C8024E5E}" destId="{CE355F69-3EFD-FC43-B36A-0B710B93612D}" srcOrd="0" destOrd="0" presId="urn:microsoft.com/office/officeart/2016/7/layout/VerticalDownArrowProcess"/>
-    <dgm:cxn modelId="{B953D293-8406-AC4E-B9F7-6D866C5BC113}" type="presOf" srcId="{A7A6DF71-F1C4-4BB3-98DA-F3752204B3FF}" destId="{A4DCEA11-1C52-B84D-831C-C6E82835E69F}" srcOrd="0" destOrd="0" presId="urn:microsoft.com/office/officeart/2016/7/layout/VerticalDownArrowProcess"/>
-    <dgm:cxn modelId="{39B27E9D-4C8B-4AF5-A464-6508351846F1}" srcId="{054F5539-A4B2-4FEE-A14D-FA1C40DA1A04}" destId="{D610ED89-638F-4716-BD0A-DF71726D5551}" srcOrd="1" destOrd="0" parTransId="{7FB1D790-10EA-4363-A918-FF0FD601558C}" sibTransId="{1D5951E0-348B-41B9-B98B-393B87F2D50A}"/>
-    <dgm:cxn modelId="{C1DEE7A4-80F1-6049-A5E5-743A22D3F4A6}" type="presOf" srcId="{CF4DC95C-4970-42B3-A322-496294BAE48D}" destId="{176FB10E-67F2-244A-9C51-F1A5D4E7014B}" srcOrd="1" destOrd="0" presId="urn:microsoft.com/office/officeart/2016/7/layout/VerticalDownArrowProcess"/>
-    <dgm:cxn modelId="{F94392AE-4D3C-4412-B053-476917C9251E}" srcId="{054F5539-A4B2-4FEE-A14D-FA1C40DA1A04}" destId="{9B453CB0-161B-4585-9690-EF5C96AC0561}" srcOrd="0" destOrd="0" parTransId="{FA693E23-FB71-4DFC-B4CC-0E8A44700A6B}" sibTransId="{57C530ED-327E-4F53-9E8B-4490FF5CD35C}"/>
-    <dgm:cxn modelId="{E844F8B4-2E87-409D-8D59-EF8A996CD68E}" srcId="{054F5539-A4B2-4FEE-A14D-FA1C40DA1A04}" destId="{D032B980-8EA0-45C4-94CD-11681523ED9B}" srcOrd="3" destOrd="0" parTransId="{01EC26F4-0092-474A-A7DB-3061A1C71497}" sibTransId="{148346F7-A47A-48D9-9326-7C1CBF78CEE7}"/>
-    <dgm:cxn modelId="{B5E8ABBC-DE29-9840-9EF5-3ABD77FA2237}" type="presOf" srcId="{1DFC9E3C-0C21-428E-8DDB-4DBBE100A96B}" destId="{59612E42-2966-7D4B-8F21-AF4D32219590}" srcOrd="1" destOrd="0" presId="urn:microsoft.com/office/officeart/2016/7/layout/VerticalDownArrowProcess"/>
-    <dgm:cxn modelId="{15E69BBE-9288-C546-9B8C-984CB5E61162}" type="presOf" srcId="{D032B980-8EA0-45C4-94CD-11681523ED9B}" destId="{ED15DB2C-D5D3-F044-9CF3-AF03D8CA1D4B}" srcOrd="0" destOrd="0" presId="urn:microsoft.com/office/officeart/2016/7/layout/VerticalDownArrowProcess"/>
-    <dgm:cxn modelId="{1AF4D3C2-61B6-4483-9114-9064A690FA07}" srcId="{054F5539-A4B2-4FEE-A14D-FA1C40DA1A04}" destId="{8D77AF8C-F19A-4226-AE34-79F79F00CAA1}" srcOrd="5" destOrd="0" parTransId="{F91A3FB7-F705-44CB-8B02-783CBE2F6024}" sibTransId="{7F6FFC55-3ABF-477B-8D0A-31BF8F0D97F8}"/>
-    <dgm:cxn modelId="{99B4C5DE-19AF-6440-92FE-CCBB9E4A0F1F}" type="presOf" srcId="{CF4DC95C-4970-42B3-A322-496294BAE48D}" destId="{10977552-9294-7341-AEB9-BE68B0473891}" srcOrd="0" destOrd="0" presId="urn:microsoft.com/office/officeart/2016/7/layout/VerticalDownArrowProcess"/>
-    <dgm:cxn modelId="{0C9439E6-59F5-450D-9939-6DD9FA275CA5}" srcId="{054F5539-A4B2-4FEE-A14D-FA1C40DA1A04}" destId="{1DFC9E3C-0C21-428E-8DDB-4DBBE100A96B}" srcOrd="4" destOrd="0" parTransId="{E528EC6B-C75B-47B1-B637-B54FB2837A10}" sibTransId="{CB477C9B-DC8B-4FC3-9139-A0E2C70D9711}"/>
-    <dgm:cxn modelId="{61A13AEC-E7F6-4371-9B3C-D229F1D6B5C5}" srcId="{054F5539-A4B2-4FEE-A14D-FA1C40DA1A04}" destId="{CF4DC95C-4970-42B3-A322-496294BAE48D}" srcOrd="2" destOrd="0" parTransId="{16B00682-E294-46FB-B3F9-BC111E4135BC}" sibTransId="{ABFACD7A-CFAF-4862-BB02-AC2A480CB979}"/>
-    <dgm:cxn modelId="{167C3AF1-3DE2-354D-B7C4-C582ABF63376}" type="presOf" srcId="{054F5539-A4B2-4FEE-A14D-FA1C40DA1A04}" destId="{8CBE272C-DFEC-3E45-AFDE-7830A02CF440}" srcOrd="0" destOrd="0" presId="urn:microsoft.com/office/officeart/2016/7/layout/VerticalDownArrowProcess"/>
-    <dgm:cxn modelId="{088353FB-61F2-ED48-A113-226A59201F22}" type="presOf" srcId="{9B453CB0-161B-4585-9690-EF5C96AC0561}" destId="{772BFCBB-F9A7-754D-A415-B99AFA81DF30}" srcOrd="1" destOrd="0" presId="urn:microsoft.com/office/officeart/2016/7/layout/VerticalDownArrowProcess"/>
-    <dgm:cxn modelId="{423117E8-9C13-BE46-8555-C320AB2E7B75}" type="presParOf" srcId="{8CBE272C-DFEC-3E45-AFDE-7830A02CF440}" destId="{C8D06AD8-D842-F045-8085-F43473BC625B}" srcOrd="0" destOrd="0" presId="urn:microsoft.com/office/officeart/2016/7/layout/VerticalDownArrowProcess"/>
-    <dgm:cxn modelId="{AE909291-26E6-B049-BB0A-315D88078BAC}" type="presParOf" srcId="{C8D06AD8-D842-F045-8085-F43473BC625B}" destId="{A4A5C01C-9CEA-7542-A9DA-F0BCE5A9D71E}" srcOrd="0" destOrd="0" presId="urn:microsoft.com/office/officeart/2016/7/layout/VerticalDownArrowProcess"/>
-    <dgm:cxn modelId="{37BC5EF8-4C31-AA4F-8B00-9A9777789878}" type="presParOf" srcId="{C8D06AD8-D842-F045-8085-F43473BC625B}" destId="{A4DCEA11-1C52-B84D-831C-C6E82835E69F}" srcOrd="1" destOrd="0" presId="urn:microsoft.com/office/officeart/2016/7/layout/VerticalDownArrowProcess"/>
-    <dgm:cxn modelId="{7F44F38E-E476-F74A-AAB8-199821CA73CF}" type="presParOf" srcId="{8CBE272C-DFEC-3E45-AFDE-7830A02CF440}" destId="{95DA5E82-5E48-AB4A-90E0-9E1B14315635}" srcOrd="1" destOrd="0" presId="urn:microsoft.com/office/officeart/2016/7/layout/VerticalDownArrowProcess"/>
-    <dgm:cxn modelId="{0FFC1F43-FA36-604D-BF82-E30E0D0604DB}" type="presParOf" srcId="{8CBE272C-DFEC-3E45-AFDE-7830A02CF440}" destId="{86968BF5-40DD-A34D-8CF7-A6192843846F}" srcOrd="2" destOrd="0" presId="urn:microsoft.com/office/officeart/2016/7/layout/VerticalDownArrowProcess"/>
-    <dgm:cxn modelId="{9075F20D-9A2A-D249-A3FC-996027D8C302}" type="presParOf" srcId="{86968BF5-40DD-A34D-8CF7-A6192843846F}" destId="{BFBDC332-3138-214B-A1F1-13EAD053CC66}" srcOrd="0" destOrd="0" presId="urn:microsoft.com/office/officeart/2016/7/layout/VerticalDownArrowProcess"/>
-    <dgm:cxn modelId="{227DFEC9-9783-B242-A762-50BD4982745E}" type="presParOf" srcId="{86968BF5-40DD-A34D-8CF7-A6192843846F}" destId="{59612E42-2966-7D4B-8F21-AF4D32219590}" srcOrd="1" destOrd="0" presId="urn:microsoft.com/office/officeart/2016/7/layout/VerticalDownArrowProcess"/>
-    <dgm:cxn modelId="{96FD9E4E-5831-B146-8381-7521D2CCE826}" type="presParOf" srcId="{86968BF5-40DD-A34D-8CF7-A6192843846F}" destId="{C2A69F78-D06B-8642-9EF8-2DFE7BC3FE00}" srcOrd="2" destOrd="0" presId="urn:microsoft.com/office/officeart/2016/7/layout/VerticalDownArrowProcess"/>
-    <dgm:cxn modelId="{BBB5C562-D24C-A14D-80EF-62DAE19CDEBA}" type="presParOf" srcId="{8CBE272C-DFEC-3E45-AFDE-7830A02CF440}" destId="{1452FA4D-1DEA-5342-8F11-F68942AE28AB}" srcOrd="3" destOrd="0" presId="urn:microsoft.com/office/officeart/2016/7/layout/VerticalDownArrowProcess"/>
-    <dgm:cxn modelId="{CA9BCB70-E196-4E40-AB76-726B2C1749CD}" type="presParOf" srcId="{8CBE272C-DFEC-3E45-AFDE-7830A02CF440}" destId="{0ACC7AC5-BA94-A648-A5C7-13337D94E2F6}" srcOrd="4" destOrd="0" presId="urn:microsoft.com/office/officeart/2016/7/layout/VerticalDownArrowProcess"/>
-    <dgm:cxn modelId="{85DD962C-26A9-A149-9428-E9E0C9092DFA}" type="presParOf" srcId="{0ACC7AC5-BA94-A648-A5C7-13337D94E2F6}" destId="{ED15DB2C-D5D3-F044-9CF3-AF03D8CA1D4B}" srcOrd="0" destOrd="0" presId="urn:microsoft.com/office/officeart/2016/7/layout/VerticalDownArrowProcess"/>
-    <dgm:cxn modelId="{E0E0A927-EEFF-6948-9576-E8B05FE1D87B}" type="presParOf" srcId="{0ACC7AC5-BA94-A648-A5C7-13337D94E2F6}" destId="{8C01F75D-600F-D849-A747-509E8DF8D7E6}" srcOrd="1" destOrd="0" presId="urn:microsoft.com/office/officeart/2016/7/layout/VerticalDownArrowProcess"/>
-    <dgm:cxn modelId="{D822B4EF-00AE-CB4C-A528-3C5720674C38}" type="presParOf" srcId="{0ACC7AC5-BA94-A648-A5C7-13337D94E2F6}" destId="{CE355F69-3EFD-FC43-B36A-0B710B93612D}" srcOrd="2" destOrd="0" presId="urn:microsoft.com/office/officeart/2016/7/layout/VerticalDownArrowProcess"/>
-    <dgm:cxn modelId="{9FE2BFF3-D225-3741-9610-012DC89CFF93}" type="presParOf" srcId="{8CBE272C-DFEC-3E45-AFDE-7830A02CF440}" destId="{18F2BC71-4D0B-0C4E-8099-0F0767B00F21}" srcOrd="5" destOrd="0" presId="urn:microsoft.com/office/officeart/2016/7/layout/VerticalDownArrowProcess"/>
-    <dgm:cxn modelId="{4A90C656-9F85-9D44-A9C6-3EB3DBD05361}" type="presParOf" srcId="{8CBE272C-DFEC-3E45-AFDE-7830A02CF440}" destId="{6CB34CEA-60BF-1A4C-B4E7-3AA96A152836}" srcOrd="6" destOrd="0" presId="urn:microsoft.com/office/officeart/2016/7/layout/VerticalDownArrowProcess"/>
-    <dgm:cxn modelId="{65DB8B3E-450B-F947-812B-C2B0FE33E4A9}" type="presParOf" srcId="{6CB34CEA-60BF-1A4C-B4E7-3AA96A152836}" destId="{10977552-9294-7341-AEB9-BE68B0473891}" srcOrd="0" destOrd="0" presId="urn:microsoft.com/office/officeart/2016/7/layout/VerticalDownArrowProcess"/>
-    <dgm:cxn modelId="{D66A5F8F-9EAF-734E-BE83-ABFF1E6FC7D6}" type="presParOf" srcId="{6CB34CEA-60BF-1A4C-B4E7-3AA96A152836}" destId="{176FB10E-67F2-244A-9C51-F1A5D4E7014B}" srcOrd="1" destOrd="0" presId="urn:microsoft.com/office/officeart/2016/7/layout/VerticalDownArrowProcess"/>
-    <dgm:cxn modelId="{ACA52874-0FE3-C34F-AD0D-2BA31D44D1A5}" type="presParOf" srcId="{6CB34CEA-60BF-1A4C-B4E7-3AA96A152836}" destId="{B5ADD037-1B52-0741-85DE-261FBD030161}" srcOrd="2" destOrd="0" presId="urn:microsoft.com/office/officeart/2016/7/layout/VerticalDownArrowProcess"/>
-    <dgm:cxn modelId="{35F978BB-3FB3-644D-9BB0-5F402E102123}" type="presParOf" srcId="{8CBE272C-DFEC-3E45-AFDE-7830A02CF440}" destId="{E0985A41-6445-5346-A233-1C098977BC8B}" srcOrd="7" destOrd="0" presId="urn:microsoft.com/office/officeart/2016/7/layout/VerticalDownArrowProcess"/>
-    <dgm:cxn modelId="{48A7CCA4-B711-004D-9D8A-F6B41ACA8355}" type="presParOf" srcId="{8CBE272C-DFEC-3E45-AFDE-7830A02CF440}" destId="{0696557E-84D9-4845-BB42-819641E758FC}" srcOrd="8" destOrd="0" presId="urn:microsoft.com/office/officeart/2016/7/layout/VerticalDownArrowProcess"/>
-    <dgm:cxn modelId="{9C9D7891-ACDC-3944-B3BC-9FF2EC74F4BD}" type="presParOf" srcId="{0696557E-84D9-4845-BB42-819641E758FC}" destId="{67523CA7-E1FC-C74E-830E-94853D532541}" srcOrd="0" destOrd="0" presId="urn:microsoft.com/office/officeart/2016/7/layout/VerticalDownArrowProcess"/>
-    <dgm:cxn modelId="{20EB2A0E-D236-D245-A481-E6ECBD395AE3}" type="presParOf" srcId="{0696557E-84D9-4845-BB42-819641E758FC}" destId="{65CC2DDA-74B7-1C40-9934-246CA94A0A05}" srcOrd="1" destOrd="0" presId="urn:microsoft.com/office/officeart/2016/7/layout/VerticalDownArrowProcess"/>
-    <dgm:cxn modelId="{89EBFB08-0617-AC46-9E2E-B38DFD0E7431}" type="presParOf" srcId="{0696557E-84D9-4845-BB42-819641E758FC}" destId="{64E655E2-8A0E-AC40-BEC2-54C12707DA08}" srcOrd="2" destOrd="0" presId="urn:microsoft.com/office/officeart/2016/7/layout/VerticalDownArrowProcess"/>
-    <dgm:cxn modelId="{43557528-8CC4-5943-BEBD-6DB5F7B1329B}" type="presParOf" srcId="{8CBE272C-DFEC-3E45-AFDE-7830A02CF440}" destId="{C97009CD-0E4D-F94E-AE4A-6A7E84864B1E}" srcOrd="9" destOrd="0" presId="urn:microsoft.com/office/officeart/2016/7/layout/VerticalDownArrowProcess"/>
-    <dgm:cxn modelId="{211D1DEE-D741-644D-A88B-ED70CCEC4D94}" type="presParOf" srcId="{8CBE272C-DFEC-3E45-AFDE-7830A02CF440}" destId="{72B03B82-A775-DD47-94DD-2948BCDE37F9}" srcOrd="10" destOrd="0" presId="urn:microsoft.com/office/officeart/2016/7/layout/VerticalDownArrowProcess"/>
-    <dgm:cxn modelId="{FFD34B4B-7907-FA40-84CA-072BD93A33E6}" type="presParOf" srcId="{72B03B82-A775-DD47-94DD-2948BCDE37F9}" destId="{6792E3CC-CC2C-2F42-9E59-6B2599D9ED15}" srcOrd="0" destOrd="0" presId="urn:microsoft.com/office/officeart/2016/7/layout/VerticalDownArrowProcess"/>
-    <dgm:cxn modelId="{33179923-14BF-324E-A846-76330B0C833E}" type="presParOf" srcId="{72B03B82-A775-DD47-94DD-2948BCDE37F9}" destId="{772BFCBB-F9A7-754D-A415-B99AFA81DF30}" srcOrd="1" destOrd="0" presId="urn:microsoft.com/office/officeart/2016/7/layout/VerticalDownArrowProcess"/>
-    <dgm:cxn modelId="{D04118CA-8C74-3042-85C1-1FFF0A18F950}" type="presParOf" srcId="{72B03B82-A775-DD47-94DD-2948BCDE37F9}" destId="{D5C2C13A-A3EF-644D-B983-85DA242B99E6}" srcOrd="2" destOrd="0" presId="urn:microsoft.com/office/officeart/2016/7/layout/VerticalDownArrowProcess"/>
-  </dgm:cxnLst>
-  <dgm:bg/>
-  <dgm:whole/>
-  <dgm:extLst>
-    <a:ext uri="http://schemas.microsoft.com/office/drawing/2008/diagram">
-      <dsp:dataModelExt xmlns:dsp="http://schemas.microsoft.com/office/drawing/2008/diagram" relId="rId6" minVer="http://schemas.openxmlformats.org/drawingml/2006/diagram"/>
-    </a:ext>
-  </dgm:extLst>
-</dgm:dataModel>
-</file>
-
-<file path=ppt/diagrams/drawing1.xml><?xml version="1.0" encoding="utf-8"?>
-<dsp:drawing xmlns:dgm="http://schemas.openxmlformats.org/drawingml/2006/diagram" xmlns:dsp="http://schemas.microsoft.com/office/drawing/2008/diagram" xmlns:a="http://schemas.openxmlformats.org/drawingml/2006/main">
-  <dsp:spTree>
-    <dsp:nvGrpSpPr>
-      <dsp:cNvPr id="0" name=""/>
-      <dsp:cNvGrpSpPr/>
-    </dsp:nvGrpSpPr>
-    <dsp:grpSpPr/>
-    <dsp:sp modelId="{A4A5C01C-9CEA-7542-A9DA-F0BCE5A9D71E}">
-      <dsp:nvSpPr>
-        <dsp:cNvPr id="0" name=""/>
-        <dsp:cNvSpPr/>
-      </dsp:nvSpPr>
-      <dsp:spPr>
-        <a:xfrm>
-          <a:off x="0" y="4398435"/>
-          <a:ext cx="1971377" cy="577292"/>
-        </a:xfrm>
-        <a:prstGeom prst="rect">
-          <a:avLst/>
-        </a:prstGeom>
-        <a:solidFill>
-          <a:schemeClr val="accent2">
-            <a:hueOff val="0"/>
-            <a:satOff val="0"/>
-            <a:lumOff val="0"/>
-            <a:alphaOff val="0"/>
-          </a:schemeClr>
-        </a:solidFill>
-        <a:ln w="12700" cap="flat" cmpd="sng" algn="ctr">
-          <a:solidFill>
-            <a:schemeClr val="accent2">
-              <a:hueOff val="0"/>
-              <a:satOff val="0"/>
-              <a:lumOff val="0"/>
-              <a:alphaOff val="0"/>
-            </a:schemeClr>
-          </a:solidFill>
-          <a:prstDash val="solid"/>
-          <a:miter lim="800000"/>
-        </a:ln>
-        <a:effectLst/>
-      </dsp:spPr>
-      <dsp:style>
-        <a:lnRef idx="2">
-          <a:scrgbClr r="0" g="0" b="0"/>
-        </a:lnRef>
-        <a:fillRef idx="1">
-          <a:scrgbClr r="0" g="0" b="0"/>
-        </a:fillRef>
-        <a:effectRef idx="0">
-          <a:scrgbClr r="0" g="0" b="0"/>
-        </a:effectRef>
-        <a:fontRef idx="minor">
-          <a:schemeClr val="lt1"/>
-        </a:fontRef>
-      </dsp:style>
-      <dsp:txBody>
-        <a:bodyPr spcFirstLastPara="0" vert="horz" wrap="square" lIns="140204" tIns="142240" rIns="140204" bIns="142240" numCol="1" spcCol="1270" anchor="ctr" anchorCtr="0">
-          <a:noAutofit/>
-        </a:bodyPr>
-        <a:lstStyle/>
-        <a:p>
-          <a:pPr marL="0" lvl="0" indent="0" algn="ctr" defTabSz="889000">
-            <a:lnSpc>
-              <a:spcPct val="90000"/>
-            </a:lnSpc>
-            <a:spcBef>
-              <a:spcPct val="0"/>
-            </a:spcBef>
-            <a:spcAft>
-              <a:spcPct val="35000"/>
-            </a:spcAft>
-            <a:buNone/>
-          </a:pPr>
-          <a:r>
-            <a:rPr lang="en-US" sz="2000" kern="1200"/>
-            <a:t>Step 6</a:t>
-          </a:r>
-        </a:p>
-      </dsp:txBody>
-      <dsp:txXfrm>
-        <a:off x="0" y="4398435"/>
-        <a:ext cx="1971377" cy="577292"/>
-      </dsp:txXfrm>
-    </dsp:sp>
-    <dsp:sp modelId="{A4DCEA11-1C52-B84D-831C-C6E82835E69F}">
-      <dsp:nvSpPr>
-        <dsp:cNvPr id="0" name=""/>
-        <dsp:cNvSpPr/>
-      </dsp:nvSpPr>
-      <dsp:spPr>
-        <a:xfrm>
-          <a:off x="1971377" y="4398435"/>
-          <a:ext cx="5914131" cy="577292"/>
-        </a:xfrm>
-        <a:prstGeom prst="rect">
-          <a:avLst/>
-        </a:prstGeom>
-        <a:solidFill>
-          <a:schemeClr val="accent2">
-            <a:tint val="40000"/>
-            <a:alpha val="90000"/>
-            <a:hueOff val="0"/>
-            <a:satOff val="0"/>
-            <a:lumOff val="0"/>
-            <a:alphaOff val="0"/>
-          </a:schemeClr>
-        </a:solidFill>
-        <a:ln w="12700" cap="flat" cmpd="sng" algn="ctr">
-          <a:solidFill>
-            <a:schemeClr val="accent2">
-              <a:tint val="40000"/>
-              <a:alpha val="90000"/>
-              <a:hueOff val="0"/>
-              <a:satOff val="0"/>
-              <a:lumOff val="0"/>
-              <a:alphaOff val="0"/>
-            </a:schemeClr>
-          </a:solidFill>
-          <a:prstDash val="solid"/>
-          <a:miter lim="800000"/>
-        </a:ln>
-        <a:effectLst/>
-      </dsp:spPr>
-      <dsp:style>
-        <a:lnRef idx="2">
-          <a:scrgbClr r="0" g="0" b="0"/>
-        </a:lnRef>
-        <a:fillRef idx="1">
-          <a:scrgbClr r="0" g="0" b="0"/>
-        </a:fillRef>
-        <a:effectRef idx="0">
-          <a:scrgbClr r="0" g="0" b="0"/>
-        </a:effectRef>
-        <a:fontRef idx="minor"/>
-      </dsp:style>
-      <dsp:txBody>
-        <a:bodyPr spcFirstLastPara="0" vert="horz" wrap="square" lIns="119967" tIns="177800" rIns="119967" bIns="177800" numCol="1" spcCol="1270" anchor="ctr" anchorCtr="0">
-          <a:noAutofit/>
-        </a:bodyPr>
-        <a:lstStyle/>
-        <a:p>
-          <a:pPr marL="0" lvl="0" indent="0" algn="l" defTabSz="622300">
-            <a:lnSpc>
-              <a:spcPct val="90000"/>
-            </a:lnSpc>
-            <a:spcBef>
-              <a:spcPct val="0"/>
-            </a:spcBef>
-            <a:spcAft>
-              <a:spcPct val="35000"/>
-            </a:spcAft>
-            <a:buNone/>
-          </a:pPr>
-          <a:endParaRPr lang="en-US" sz="1400" kern="1200" dirty="0"/>
-        </a:p>
-      </dsp:txBody>
-      <dsp:txXfrm>
-        <a:off x="1971377" y="4398435"/>
-        <a:ext cx="5914131" cy="577292"/>
-      </dsp:txXfrm>
-    </dsp:sp>
-    <dsp:sp modelId="{59612E42-2966-7D4B-8F21-AF4D32219590}">
-      <dsp:nvSpPr>
-        <dsp:cNvPr id="0" name=""/>
-        <dsp:cNvSpPr/>
-      </dsp:nvSpPr>
-      <dsp:spPr>
-        <a:xfrm rot="10800000">
-          <a:off x="0" y="3519219"/>
-          <a:ext cx="1971377" cy="887875"/>
-        </a:xfrm>
-        <a:prstGeom prst="upArrowCallout">
-          <a:avLst>
-            <a:gd name="adj1" fmla="val 5000"/>
-            <a:gd name="adj2" fmla="val 10000"/>
-            <a:gd name="adj3" fmla="val 15000"/>
-            <a:gd name="adj4" fmla="val 64977"/>
-          </a:avLst>
-        </a:prstGeom>
-        <a:solidFill>
-          <a:schemeClr val="accent3">
-            <a:hueOff val="0"/>
-            <a:satOff val="0"/>
-            <a:lumOff val="0"/>
-            <a:alphaOff val="0"/>
-          </a:schemeClr>
-        </a:solidFill>
-        <a:ln w="12700" cap="flat" cmpd="sng" algn="ctr">
-          <a:solidFill>
-            <a:schemeClr val="accent3">
-              <a:hueOff val="0"/>
-              <a:satOff val="0"/>
-              <a:lumOff val="0"/>
-              <a:alphaOff val="0"/>
-            </a:schemeClr>
-          </a:solidFill>
-          <a:prstDash val="solid"/>
-          <a:miter lim="800000"/>
-        </a:ln>
-        <a:effectLst/>
-      </dsp:spPr>
-      <dsp:style>
-        <a:lnRef idx="2">
-          <a:scrgbClr r="0" g="0" b="0"/>
-        </a:lnRef>
-        <a:fillRef idx="1">
-          <a:scrgbClr r="0" g="0" b="0"/>
-        </a:fillRef>
-        <a:effectRef idx="0">
-          <a:scrgbClr r="0" g="0" b="0"/>
-        </a:effectRef>
-        <a:fontRef idx="minor">
-          <a:schemeClr val="lt1"/>
-        </a:fontRef>
-      </dsp:style>
-      <dsp:txBody>
-        <a:bodyPr spcFirstLastPara="0" vert="horz" wrap="square" lIns="140204" tIns="142240" rIns="140204" bIns="142240" numCol="1" spcCol="1270" anchor="ctr" anchorCtr="0">
-          <a:noAutofit/>
-        </a:bodyPr>
-        <a:lstStyle/>
-        <a:p>
-          <a:pPr marL="0" lvl="0" indent="0" algn="ctr" defTabSz="889000">
-            <a:lnSpc>
-              <a:spcPct val="90000"/>
-            </a:lnSpc>
-            <a:spcBef>
-              <a:spcPct val="0"/>
-            </a:spcBef>
-            <a:spcAft>
-              <a:spcPct val="35000"/>
-            </a:spcAft>
-            <a:buNone/>
-          </a:pPr>
-          <a:r>
-            <a:rPr lang="en-US" sz="2000" kern="1200"/>
-            <a:t>Step 5</a:t>
-          </a:r>
-        </a:p>
-      </dsp:txBody>
-      <dsp:txXfrm rot="-10800000">
-        <a:off x="0" y="3519219"/>
-        <a:ext cx="1971377" cy="577119"/>
-      </dsp:txXfrm>
-    </dsp:sp>
-    <dsp:sp modelId="{C2A69F78-D06B-8642-9EF8-2DFE7BC3FE00}">
-      <dsp:nvSpPr>
-        <dsp:cNvPr id="0" name=""/>
-        <dsp:cNvSpPr/>
-      </dsp:nvSpPr>
-      <dsp:spPr>
-        <a:xfrm>
-          <a:off x="1971377" y="3519219"/>
-          <a:ext cx="5914131" cy="577119"/>
-        </a:xfrm>
-        <a:prstGeom prst="rect">
-          <a:avLst/>
-        </a:prstGeom>
-        <a:solidFill>
-          <a:schemeClr val="accent3">
-            <a:tint val="40000"/>
-            <a:alpha val="90000"/>
-            <a:hueOff val="0"/>
-            <a:satOff val="0"/>
-            <a:lumOff val="0"/>
-            <a:alphaOff val="0"/>
-          </a:schemeClr>
-        </a:solidFill>
-        <a:ln w="12700" cap="flat" cmpd="sng" algn="ctr">
-          <a:solidFill>
-            <a:schemeClr val="accent3">
-              <a:tint val="40000"/>
-              <a:alpha val="90000"/>
-              <a:hueOff val="0"/>
-              <a:satOff val="0"/>
-              <a:lumOff val="0"/>
-              <a:alphaOff val="0"/>
-            </a:schemeClr>
-          </a:solidFill>
-          <a:prstDash val="solid"/>
-          <a:miter lim="800000"/>
-        </a:ln>
-        <a:effectLst/>
-      </dsp:spPr>
-      <dsp:style>
-        <a:lnRef idx="2">
-          <a:scrgbClr r="0" g="0" b="0"/>
-        </a:lnRef>
-        <a:fillRef idx="1">
-          <a:scrgbClr r="0" g="0" b="0"/>
-        </a:fillRef>
-        <a:effectRef idx="0">
-          <a:scrgbClr r="0" g="0" b="0"/>
-        </a:effectRef>
-        <a:fontRef idx="minor"/>
-      </dsp:style>
-      <dsp:txBody>
-        <a:bodyPr spcFirstLastPara="0" vert="horz" wrap="square" lIns="119967" tIns="177800" rIns="119967" bIns="177800" numCol="1" spcCol="1270" anchor="ctr" anchorCtr="0">
-          <a:noAutofit/>
-        </a:bodyPr>
-        <a:lstStyle/>
-        <a:p>
-          <a:pPr marL="0" lvl="0" indent="0" algn="l" defTabSz="622300">
-            <a:lnSpc>
-              <a:spcPct val="90000"/>
-            </a:lnSpc>
-            <a:spcBef>
-              <a:spcPct val="0"/>
-            </a:spcBef>
-            <a:spcAft>
-              <a:spcPct val="35000"/>
-            </a:spcAft>
-            <a:buNone/>
-          </a:pPr>
-          <a:endParaRPr lang="en-US" sz="1400" kern="1200" dirty="0"/>
-        </a:p>
-      </dsp:txBody>
-      <dsp:txXfrm>
-        <a:off x="1971377" y="3519219"/>
-        <a:ext cx="5914131" cy="577119"/>
-      </dsp:txXfrm>
-    </dsp:sp>
-    <dsp:sp modelId="{8C01F75D-600F-D849-A747-509E8DF8D7E6}">
-      <dsp:nvSpPr>
-        <dsp:cNvPr id="0" name=""/>
-        <dsp:cNvSpPr/>
-      </dsp:nvSpPr>
-      <dsp:spPr>
-        <a:xfrm rot="10800000">
-          <a:off x="0" y="2640003"/>
-          <a:ext cx="1971377" cy="887875"/>
-        </a:xfrm>
-        <a:prstGeom prst="upArrowCallout">
-          <a:avLst>
-            <a:gd name="adj1" fmla="val 5000"/>
-            <a:gd name="adj2" fmla="val 10000"/>
-            <a:gd name="adj3" fmla="val 15000"/>
-            <a:gd name="adj4" fmla="val 64977"/>
-          </a:avLst>
-        </a:prstGeom>
-        <a:solidFill>
-          <a:schemeClr val="accent4">
-            <a:hueOff val="0"/>
-            <a:satOff val="0"/>
-            <a:lumOff val="0"/>
-            <a:alphaOff val="0"/>
-          </a:schemeClr>
-        </a:solidFill>
-        <a:ln w="12700" cap="flat" cmpd="sng" algn="ctr">
-          <a:solidFill>
-            <a:schemeClr val="accent4">
-              <a:hueOff val="0"/>
-              <a:satOff val="0"/>
-              <a:lumOff val="0"/>
-              <a:alphaOff val="0"/>
-            </a:schemeClr>
-          </a:solidFill>
-          <a:prstDash val="solid"/>
-          <a:miter lim="800000"/>
-        </a:ln>
-        <a:effectLst/>
-      </dsp:spPr>
-      <dsp:style>
-        <a:lnRef idx="2">
-          <a:scrgbClr r="0" g="0" b="0"/>
-        </a:lnRef>
-        <a:fillRef idx="1">
-          <a:scrgbClr r="0" g="0" b="0"/>
-        </a:fillRef>
-        <a:effectRef idx="0">
-          <a:scrgbClr r="0" g="0" b="0"/>
-        </a:effectRef>
-        <a:fontRef idx="minor">
-          <a:schemeClr val="lt1"/>
-        </a:fontRef>
-      </dsp:style>
-      <dsp:txBody>
-        <a:bodyPr spcFirstLastPara="0" vert="horz" wrap="square" lIns="140204" tIns="142240" rIns="140204" bIns="142240" numCol="1" spcCol="1270" anchor="ctr" anchorCtr="0">
-          <a:noAutofit/>
-        </a:bodyPr>
-        <a:lstStyle/>
-        <a:p>
-          <a:pPr marL="0" lvl="0" indent="0" algn="ctr" defTabSz="889000">
-            <a:lnSpc>
-              <a:spcPct val="90000"/>
-            </a:lnSpc>
-            <a:spcBef>
-              <a:spcPct val="0"/>
-            </a:spcBef>
-            <a:spcAft>
-              <a:spcPct val="35000"/>
-            </a:spcAft>
-            <a:buNone/>
-          </a:pPr>
-          <a:r>
-            <a:rPr lang="en-US" sz="2000" kern="1200"/>
-            <a:t>Step 4</a:t>
-          </a:r>
-        </a:p>
-      </dsp:txBody>
-      <dsp:txXfrm rot="-10800000">
-        <a:off x="0" y="2640003"/>
-        <a:ext cx="1971377" cy="577119"/>
-      </dsp:txXfrm>
-    </dsp:sp>
-    <dsp:sp modelId="{CE355F69-3EFD-FC43-B36A-0B710B93612D}">
-      <dsp:nvSpPr>
-        <dsp:cNvPr id="0" name=""/>
-        <dsp:cNvSpPr/>
-      </dsp:nvSpPr>
-      <dsp:spPr>
-        <a:xfrm>
-          <a:off x="1971377" y="2640003"/>
-          <a:ext cx="5914131" cy="577119"/>
-        </a:xfrm>
-        <a:prstGeom prst="rect">
-          <a:avLst/>
-        </a:prstGeom>
-        <a:solidFill>
-          <a:schemeClr val="accent4">
-            <a:tint val="40000"/>
-            <a:alpha val="90000"/>
-            <a:hueOff val="0"/>
-            <a:satOff val="0"/>
-            <a:lumOff val="0"/>
-            <a:alphaOff val="0"/>
-          </a:schemeClr>
-        </a:solidFill>
-        <a:ln w="12700" cap="flat" cmpd="sng" algn="ctr">
-          <a:solidFill>
-            <a:schemeClr val="accent4">
-              <a:tint val="40000"/>
-              <a:alpha val="90000"/>
-              <a:hueOff val="0"/>
-              <a:satOff val="0"/>
-              <a:lumOff val="0"/>
-              <a:alphaOff val="0"/>
-            </a:schemeClr>
-          </a:solidFill>
-          <a:prstDash val="solid"/>
-          <a:miter lim="800000"/>
-        </a:ln>
-        <a:effectLst/>
-      </dsp:spPr>
-      <dsp:style>
-        <a:lnRef idx="2">
-          <a:scrgbClr r="0" g="0" b="0"/>
-        </a:lnRef>
-        <a:fillRef idx="1">
-          <a:scrgbClr r="0" g="0" b="0"/>
-        </a:fillRef>
-        <a:effectRef idx="0">
-          <a:scrgbClr r="0" g="0" b="0"/>
-        </a:effectRef>
-        <a:fontRef idx="minor"/>
-      </dsp:style>
-      <dsp:txBody>
-        <a:bodyPr spcFirstLastPara="0" vert="horz" wrap="square" lIns="119967" tIns="177800" rIns="119967" bIns="177800" numCol="1" spcCol="1270" anchor="ctr" anchorCtr="0">
-          <a:noAutofit/>
-        </a:bodyPr>
-        <a:lstStyle/>
-        <a:p>
-          <a:pPr marL="0" lvl="0" indent="0" algn="l" defTabSz="622300">
-            <a:lnSpc>
-              <a:spcPct val="90000"/>
-            </a:lnSpc>
-            <a:spcBef>
-              <a:spcPct val="0"/>
-            </a:spcBef>
-            <a:spcAft>
-              <a:spcPct val="35000"/>
-            </a:spcAft>
-            <a:buNone/>
-          </a:pPr>
-          <a:endParaRPr lang="en-US" sz="1400" kern="1200" dirty="0"/>
-        </a:p>
-      </dsp:txBody>
-      <dsp:txXfrm>
-        <a:off x="1971377" y="2640003"/>
-        <a:ext cx="5914131" cy="577119"/>
-      </dsp:txXfrm>
-    </dsp:sp>
-    <dsp:sp modelId="{176FB10E-67F2-244A-9C51-F1A5D4E7014B}">
-      <dsp:nvSpPr>
-        <dsp:cNvPr id="0" name=""/>
-        <dsp:cNvSpPr/>
-      </dsp:nvSpPr>
-      <dsp:spPr>
-        <a:xfrm rot="10800000">
-          <a:off x="0" y="1760787"/>
-          <a:ext cx="1971377" cy="887875"/>
-        </a:xfrm>
-        <a:prstGeom prst="upArrowCallout">
-          <a:avLst>
-            <a:gd name="adj1" fmla="val 5000"/>
-            <a:gd name="adj2" fmla="val 10000"/>
-            <a:gd name="adj3" fmla="val 15000"/>
-            <a:gd name="adj4" fmla="val 64977"/>
-          </a:avLst>
-        </a:prstGeom>
-        <a:solidFill>
-          <a:schemeClr val="accent5">
-            <a:hueOff val="0"/>
-            <a:satOff val="0"/>
-            <a:lumOff val="0"/>
-            <a:alphaOff val="0"/>
-          </a:schemeClr>
-        </a:solidFill>
-        <a:ln w="12700" cap="flat" cmpd="sng" algn="ctr">
-          <a:solidFill>
-            <a:schemeClr val="accent5">
-              <a:hueOff val="0"/>
-              <a:satOff val="0"/>
-              <a:lumOff val="0"/>
-              <a:alphaOff val="0"/>
-            </a:schemeClr>
-          </a:solidFill>
-          <a:prstDash val="solid"/>
-          <a:miter lim="800000"/>
-        </a:ln>
-        <a:effectLst/>
-      </dsp:spPr>
-      <dsp:style>
-        <a:lnRef idx="2">
-          <a:scrgbClr r="0" g="0" b="0"/>
-        </a:lnRef>
-        <a:fillRef idx="1">
-          <a:scrgbClr r="0" g="0" b="0"/>
-        </a:fillRef>
-        <a:effectRef idx="0">
-          <a:scrgbClr r="0" g="0" b="0"/>
-        </a:effectRef>
-        <a:fontRef idx="minor">
-          <a:schemeClr val="lt1"/>
-        </a:fontRef>
-      </dsp:style>
-      <dsp:txBody>
-        <a:bodyPr spcFirstLastPara="0" vert="horz" wrap="square" lIns="140204" tIns="142240" rIns="140204" bIns="142240" numCol="1" spcCol="1270" anchor="ctr" anchorCtr="0">
-          <a:noAutofit/>
-        </a:bodyPr>
-        <a:lstStyle/>
-        <a:p>
-          <a:pPr marL="0" lvl="0" indent="0" algn="ctr" defTabSz="889000">
-            <a:lnSpc>
-              <a:spcPct val="90000"/>
-            </a:lnSpc>
-            <a:spcBef>
-              <a:spcPct val="0"/>
-            </a:spcBef>
-            <a:spcAft>
-              <a:spcPct val="35000"/>
-            </a:spcAft>
-            <a:buNone/>
-          </a:pPr>
-          <a:r>
-            <a:rPr lang="en-US" sz="2000" kern="1200"/>
-            <a:t>Step 3</a:t>
-          </a:r>
-        </a:p>
-      </dsp:txBody>
-      <dsp:txXfrm rot="-10800000">
-        <a:off x="0" y="1760787"/>
-        <a:ext cx="1971377" cy="577119"/>
-      </dsp:txXfrm>
-    </dsp:sp>
-    <dsp:sp modelId="{B5ADD037-1B52-0741-85DE-261FBD030161}">
-      <dsp:nvSpPr>
-        <dsp:cNvPr id="0" name=""/>
-        <dsp:cNvSpPr/>
-      </dsp:nvSpPr>
-      <dsp:spPr>
-        <a:xfrm>
-          <a:off x="1971377" y="1760787"/>
-          <a:ext cx="5914131" cy="577119"/>
-        </a:xfrm>
-        <a:prstGeom prst="rect">
-          <a:avLst/>
-        </a:prstGeom>
-        <a:solidFill>
-          <a:schemeClr val="accent5">
-            <a:tint val="40000"/>
-            <a:alpha val="90000"/>
-            <a:hueOff val="0"/>
-            <a:satOff val="0"/>
-            <a:lumOff val="0"/>
-            <a:alphaOff val="0"/>
-          </a:schemeClr>
-        </a:solidFill>
-        <a:ln w="12700" cap="flat" cmpd="sng" algn="ctr">
-          <a:solidFill>
-            <a:schemeClr val="accent5">
-              <a:tint val="40000"/>
-              <a:alpha val="90000"/>
-              <a:hueOff val="0"/>
-              <a:satOff val="0"/>
-              <a:lumOff val="0"/>
-              <a:alphaOff val="0"/>
-            </a:schemeClr>
-          </a:solidFill>
-          <a:prstDash val="solid"/>
-          <a:miter lim="800000"/>
-        </a:ln>
-        <a:effectLst/>
-      </dsp:spPr>
-      <dsp:style>
-        <a:lnRef idx="2">
-          <a:scrgbClr r="0" g="0" b="0"/>
-        </a:lnRef>
-        <a:fillRef idx="1">
-          <a:scrgbClr r="0" g="0" b="0"/>
-        </a:fillRef>
-        <a:effectRef idx="0">
-          <a:scrgbClr r="0" g="0" b="0"/>
-        </a:effectRef>
-        <a:fontRef idx="minor"/>
-      </dsp:style>
-      <dsp:txBody>
-        <a:bodyPr spcFirstLastPara="0" vert="horz" wrap="square" lIns="119967" tIns="177800" rIns="119967" bIns="177800" numCol="1" spcCol="1270" anchor="ctr" anchorCtr="0">
-          <a:noAutofit/>
-        </a:bodyPr>
-        <a:lstStyle/>
-        <a:p>
-          <a:pPr marL="0" lvl="0" indent="0" algn="l" defTabSz="622300">
-            <a:lnSpc>
-              <a:spcPct val="90000"/>
-            </a:lnSpc>
-            <a:spcBef>
-              <a:spcPct val="0"/>
-            </a:spcBef>
-            <a:spcAft>
-              <a:spcPct val="35000"/>
-            </a:spcAft>
-            <a:buNone/>
-          </a:pPr>
-          <a:endParaRPr lang="en-US" sz="1400" kern="1200" dirty="0"/>
-        </a:p>
-      </dsp:txBody>
-      <dsp:txXfrm>
-        <a:off x="1971377" y="1760787"/>
-        <a:ext cx="5914131" cy="577119"/>
-      </dsp:txXfrm>
-    </dsp:sp>
-    <dsp:sp modelId="{65CC2DDA-74B7-1C40-9934-246CA94A0A05}">
-      <dsp:nvSpPr>
-        <dsp:cNvPr id="0" name=""/>
-        <dsp:cNvSpPr/>
-      </dsp:nvSpPr>
-      <dsp:spPr>
-        <a:xfrm rot="10800000">
-          <a:off x="0" y="881570"/>
-          <a:ext cx="1971377" cy="887875"/>
-        </a:xfrm>
-        <a:prstGeom prst="upArrowCallout">
-          <a:avLst>
-            <a:gd name="adj1" fmla="val 5000"/>
-            <a:gd name="adj2" fmla="val 10000"/>
-            <a:gd name="adj3" fmla="val 15000"/>
-            <a:gd name="adj4" fmla="val 64977"/>
-          </a:avLst>
-        </a:prstGeom>
-        <a:solidFill>
-          <a:schemeClr val="accent6">
-            <a:hueOff val="0"/>
-            <a:satOff val="0"/>
-            <a:lumOff val="0"/>
-            <a:alphaOff val="0"/>
-          </a:schemeClr>
-        </a:solidFill>
-        <a:ln w="12700" cap="flat" cmpd="sng" algn="ctr">
-          <a:solidFill>
-            <a:schemeClr val="accent6">
-              <a:hueOff val="0"/>
-              <a:satOff val="0"/>
-              <a:lumOff val="0"/>
-              <a:alphaOff val="0"/>
-            </a:schemeClr>
-          </a:solidFill>
-          <a:prstDash val="solid"/>
-          <a:miter lim="800000"/>
-        </a:ln>
-        <a:effectLst/>
-      </dsp:spPr>
-      <dsp:style>
-        <a:lnRef idx="2">
-          <a:scrgbClr r="0" g="0" b="0"/>
-        </a:lnRef>
-        <a:fillRef idx="1">
-          <a:scrgbClr r="0" g="0" b="0"/>
-        </a:fillRef>
-        <a:effectRef idx="0">
-          <a:scrgbClr r="0" g="0" b="0"/>
-        </a:effectRef>
-        <a:fontRef idx="minor">
-          <a:schemeClr val="lt1"/>
-        </a:fontRef>
-      </dsp:style>
-      <dsp:txBody>
-        <a:bodyPr spcFirstLastPara="0" vert="horz" wrap="square" lIns="140204" tIns="142240" rIns="140204" bIns="142240" numCol="1" spcCol="1270" anchor="ctr" anchorCtr="0">
-          <a:noAutofit/>
-        </a:bodyPr>
-        <a:lstStyle/>
-        <a:p>
-          <a:pPr marL="0" lvl="0" indent="0" algn="ctr" defTabSz="889000">
-            <a:lnSpc>
-              <a:spcPct val="90000"/>
-            </a:lnSpc>
-            <a:spcBef>
-              <a:spcPct val="0"/>
-            </a:spcBef>
-            <a:spcAft>
-              <a:spcPct val="35000"/>
-            </a:spcAft>
-            <a:buNone/>
-          </a:pPr>
-          <a:r>
-            <a:rPr lang="en-US" sz="2000" kern="1200"/>
-            <a:t>Step 2</a:t>
-          </a:r>
-        </a:p>
-      </dsp:txBody>
-      <dsp:txXfrm rot="-10800000">
-        <a:off x="0" y="881570"/>
-        <a:ext cx="1971377" cy="577119"/>
-      </dsp:txXfrm>
-    </dsp:sp>
-    <dsp:sp modelId="{64E655E2-8A0E-AC40-BEC2-54C12707DA08}">
-      <dsp:nvSpPr>
-        <dsp:cNvPr id="0" name=""/>
-        <dsp:cNvSpPr/>
-      </dsp:nvSpPr>
-      <dsp:spPr>
-        <a:xfrm>
-          <a:off x="1971377" y="881570"/>
-          <a:ext cx="5914131" cy="577119"/>
-        </a:xfrm>
-        <a:prstGeom prst="rect">
-          <a:avLst/>
-        </a:prstGeom>
-        <a:solidFill>
-          <a:schemeClr val="accent6">
-            <a:tint val="40000"/>
-            <a:alpha val="90000"/>
-            <a:hueOff val="0"/>
-            <a:satOff val="0"/>
-            <a:lumOff val="0"/>
-            <a:alphaOff val="0"/>
-          </a:schemeClr>
-        </a:solidFill>
-        <a:ln w="12700" cap="flat" cmpd="sng" algn="ctr">
-          <a:solidFill>
-            <a:schemeClr val="accent6">
-              <a:tint val="40000"/>
-              <a:alpha val="90000"/>
-              <a:hueOff val="0"/>
-              <a:satOff val="0"/>
-              <a:lumOff val="0"/>
-              <a:alphaOff val="0"/>
-            </a:schemeClr>
-          </a:solidFill>
-          <a:prstDash val="solid"/>
-          <a:miter lim="800000"/>
-        </a:ln>
-        <a:effectLst/>
-      </dsp:spPr>
-      <dsp:style>
-        <a:lnRef idx="2">
-          <a:scrgbClr r="0" g="0" b="0"/>
-        </a:lnRef>
-        <a:fillRef idx="1">
-          <a:scrgbClr r="0" g="0" b="0"/>
-        </a:fillRef>
-        <a:effectRef idx="0">
-          <a:scrgbClr r="0" g="0" b="0"/>
-        </a:effectRef>
-        <a:fontRef idx="minor"/>
-      </dsp:style>
-      <dsp:txBody>
-        <a:bodyPr spcFirstLastPara="0" vert="horz" wrap="square" lIns="119967" tIns="177800" rIns="119967" bIns="177800" numCol="1" spcCol="1270" anchor="ctr" anchorCtr="0">
-          <a:noAutofit/>
-        </a:bodyPr>
-        <a:lstStyle/>
-        <a:p>
-          <a:pPr marL="0" lvl="0" indent="0" algn="l" defTabSz="622300">
-            <a:lnSpc>
-              <a:spcPct val="90000"/>
-            </a:lnSpc>
-            <a:spcBef>
-              <a:spcPct val="0"/>
-            </a:spcBef>
-            <a:spcAft>
-              <a:spcPct val="35000"/>
-            </a:spcAft>
-            <a:buNone/>
-          </a:pPr>
-          <a:endParaRPr lang="en-US" sz="1400" kern="1200" dirty="0"/>
-        </a:p>
-      </dsp:txBody>
-      <dsp:txXfrm>
-        <a:off x="1971377" y="881570"/>
-        <a:ext cx="5914131" cy="577119"/>
-      </dsp:txXfrm>
-    </dsp:sp>
-    <dsp:sp modelId="{772BFCBB-F9A7-754D-A415-B99AFA81DF30}">
-      <dsp:nvSpPr>
-        <dsp:cNvPr id="0" name=""/>
-        <dsp:cNvSpPr/>
-      </dsp:nvSpPr>
-      <dsp:spPr>
-        <a:xfrm rot="10800000">
-          <a:off x="0" y="2354"/>
-          <a:ext cx="1971377" cy="887875"/>
-        </a:xfrm>
-        <a:prstGeom prst="upArrowCallout">
-          <a:avLst>
-            <a:gd name="adj1" fmla="val 5000"/>
-            <a:gd name="adj2" fmla="val 10000"/>
-            <a:gd name="adj3" fmla="val 15000"/>
-            <a:gd name="adj4" fmla="val 64977"/>
-          </a:avLst>
-        </a:prstGeom>
-        <a:solidFill>
-          <a:schemeClr val="accent2">
-            <a:hueOff val="0"/>
-            <a:satOff val="0"/>
-            <a:lumOff val="0"/>
-            <a:alphaOff val="0"/>
-          </a:schemeClr>
-        </a:solidFill>
-        <a:ln w="12700" cap="flat" cmpd="sng" algn="ctr">
-          <a:solidFill>
-            <a:schemeClr val="accent2">
-              <a:hueOff val="0"/>
-              <a:satOff val="0"/>
-              <a:lumOff val="0"/>
-              <a:alphaOff val="0"/>
-            </a:schemeClr>
-          </a:solidFill>
-          <a:prstDash val="solid"/>
-          <a:miter lim="800000"/>
-        </a:ln>
-        <a:effectLst/>
-      </dsp:spPr>
-      <dsp:style>
-        <a:lnRef idx="2">
-          <a:scrgbClr r="0" g="0" b="0"/>
-        </a:lnRef>
-        <a:fillRef idx="1">
-          <a:scrgbClr r="0" g="0" b="0"/>
-        </a:fillRef>
-        <a:effectRef idx="0">
-          <a:scrgbClr r="0" g="0" b="0"/>
-        </a:effectRef>
-        <a:fontRef idx="minor">
-          <a:schemeClr val="lt1"/>
-        </a:fontRef>
-      </dsp:style>
-      <dsp:txBody>
-        <a:bodyPr spcFirstLastPara="0" vert="horz" wrap="square" lIns="140204" tIns="142240" rIns="140204" bIns="142240" numCol="1" spcCol="1270" anchor="ctr" anchorCtr="0">
-          <a:noAutofit/>
-        </a:bodyPr>
-        <a:lstStyle/>
-        <a:p>
-          <a:pPr marL="0" lvl="0" indent="0" algn="ctr" defTabSz="889000">
-            <a:lnSpc>
-              <a:spcPct val="90000"/>
-            </a:lnSpc>
-            <a:spcBef>
-              <a:spcPct val="0"/>
-            </a:spcBef>
-            <a:spcAft>
-              <a:spcPct val="35000"/>
-            </a:spcAft>
-            <a:buNone/>
-          </a:pPr>
-          <a:r>
-            <a:rPr lang="en-US" sz="2000" kern="1200"/>
-            <a:t>Step 1</a:t>
-          </a:r>
-        </a:p>
-      </dsp:txBody>
-      <dsp:txXfrm rot="-10800000">
-        <a:off x="0" y="2354"/>
-        <a:ext cx="1971377" cy="577119"/>
-      </dsp:txXfrm>
-    </dsp:sp>
-    <dsp:sp modelId="{D5C2C13A-A3EF-644D-B983-85DA242B99E6}">
-      <dsp:nvSpPr>
-        <dsp:cNvPr id="0" name=""/>
-        <dsp:cNvSpPr/>
-      </dsp:nvSpPr>
-      <dsp:spPr>
-        <a:xfrm>
-          <a:off x="1971377" y="2354"/>
-          <a:ext cx="5914131" cy="577119"/>
-        </a:xfrm>
-        <a:prstGeom prst="rect">
-          <a:avLst/>
-        </a:prstGeom>
-        <a:solidFill>
-          <a:schemeClr val="accent2">
-            <a:tint val="40000"/>
-            <a:alpha val="90000"/>
-            <a:hueOff val="0"/>
-            <a:satOff val="0"/>
-            <a:lumOff val="0"/>
-            <a:alphaOff val="0"/>
-          </a:schemeClr>
-        </a:solidFill>
-        <a:ln w="12700" cap="flat" cmpd="sng" algn="ctr">
-          <a:solidFill>
-            <a:schemeClr val="accent2">
-              <a:tint val="40000"/>
-              <a:alpha val="90000"/>
-              <a:hueOff val="0"/>
-              <a:satOff val="0"/>
-              <a:lumOff val="0"/>
-              <a:alphaOff val="0"/>
-            </a:schemeClr>
-          </a:solidFill>
-          <a:prstDash val="solid"/>
-          <a:miter lim="800000"/>
-        </a:ln>
-        <a:effectLst/>
-      </dsp:spPr>
-      <dsp:style>
-        <a:lnRef idx="2">
-          <a:scrgbClr r="0" g="0" b="0"/>
-        </a:lnRef>
-        <a:fillRef idx="1">
-          <a:scrgbClr r="0" g="0" b="0"/>
-        </a:fillRef>
-        <a:effectRef idx="0">
-          <a:scrgbClr r="0" g="0" b="0"/>
-        </a:effectRef>
-        <a:fontRef idx="minor"/>
-      </dsp:style>
-      <dsp:txBody>
-        <a:bodyPr spcFirstLastPara="0" vert="horz" wrap="square" lIns="119967" tIns="177800" rIns="119967" bIns="177800" numCol="1" spcCol="1270" anchor="ctr" anchorCtr="0">
-          <a:noAutofit/>
-        </a:bodyPr>
-        <a:lstStyle/>
-        <a:p>
-          <a:pPr marL="0" lvl="0" indent="0" algn="l" defTabSz="622300">
-            <a:lnSpc>
-              <a:spcPct val="90000"/>
-            </a:lnSpc>
-            <a:spcBef>
-              <a:spcPct val="0"/>
-            </a:spcBef>
-            <a:spcAft>
-              <a:spcPct val="35000"/>
-            </a:spcAft>
-            <a:buNone/>
-          </a:pPr>
-          <a:endParaRPr lang="en-US" sz="1400" kern="1200" dirty="0"/>
-        </a:p>
-      </dsp:txBody>
-      <dsp:txXfrm>
-        <a:off x="1971377" y="2354"/>
-        <a:ext cx="5914131" cy="577119"/>
-      </dsp:txXfrm>
-    </dsp:sp>
-  </dsp:spTree>
-</dsp:drawing>
-</file>
-
-<file path=ppt/diagrams/layout1.xml><?xml version="1.0" encoding="utf-8"?>
-<dgm:layoutDef xmlns:dgm="http://schemas.openxmlformats.org/drawingml/2006/diagram" xmlns:a="http://schemas.openxmlformats.org/drawingml/2006/main" uniqueId="urn:microsoft.com/office/officeart/2016/7/layout/VerticalDownArrowProcess">
-  <dgm:title val="Vertical Down Arrow Process"/>
-  <dgm:desc val="Use to show a progression; a timeline; sequential steps in a task, process, or workflow; or to emphasize movement or direction. Level 1 text appears inside an arrow shape while Level 2 text appears below the arrow shapes."/>
-  <dgm:catLst>
-    <dgm:cat type="process" pri="500"/>
-  </dgm:catLst>
-  <dgm:sampData>
-    <dgm:dataModel>
-      <dgm:ptLst>
-        <dgm:pt modelId="0" type="doc"/>
-        <dgm:pt modelId="1">
-          <dgm:prSet phldr="1"/>
-        </dgm:pt>
-        <dgm:pt modelId="11">
-          <dgm:prSet phldr="1"/>
-        </dgm:pt>
-        <dgm:pt modelId="2">
-          <dgm:prSet phldr="1"/>
-        </dgm:pt>
-        <dgm:pt modelId="21">
-          <dgm:prSet phldr="1"/>
-        </dgm:pt>
-        <dgm:pt modelId="3">
-          <dgm:prSet phldr="1"/>
-        </dgm:pt>
-        <dgm:pt modelId="31">
-          <dgm:prSet phldr="1"/>
-        </dgm:pt>
-      </dgm:ptLst>
-      <dgm:cxnLst>
-        <dgm:cxn modelId="4" srcId="0" destId="1" srcOrd="0" destOrd="0"/>
-        <dgm:cxn modelId="5" srcId="0" destId="2" srcOrd="1" destOrd="0"/>
-        <dgm:cxn modelId="6" srcId="0" destId="3" srcOrd="2" destOrd="0"/>
-        <dgm:cxn modelId="13" srcId="1" destId="11" srcOrd="0" destOrd="0"/>
-        <dgm:cxn modelId="23" srcId="2" destId="21" srcOrd="0" destOrd="0"/>
-        <dgm:cxn modelId="33" srcId="3" destId="31" srcOrd="0" destOrd="0"/>
-      </dgm:cxnLst>
-      <dgm:bg/>
-      <dgm:whole/>
-    </dgm:dataModel>
-  </dgm:sampData>
-  <dgm:styleData>
-    <dgm:dataModel>
-      <dgm:ptLst>
-        <dgm:pt modelId="0" type="doc"/>
-        <dgm:pt modelId="1"/>
-        <dgm:pt modelId="11"/>
-        <dgm:pt modelId="2"/>
-        <dgm:pt modelId="21"/>
-      </dgm:ptLst>
-      <dgm:cxnLst>
-        <dgm:cxn modelId="4" srcId="0" destId="1" srcOrd="0" destOrd="0"/>
-        <dgm:cxn modelId="5" srcId="0" destId="2" srcOrd="1" destOrd="0"/>
-        <dgm:cxn modelId="13" srcId="1" destId="11" srcOrd="0" destOrd="0"/>
-        <dgm:cxn modelId="23" srcId="2" destId="21" srcOrd="0" destOrd="0"/>
-      </dgm:cxnLst>
-      <dgm:bg/>
-      <dgm:whole/>
-    </dgm:dataModel>
-  </dgm:styleData>
-  <dgm:clrData>
-    <dgm:dataModel>
-      <dgm:ptLst>
-        <dgm:pt modelId="0" type="doc"/>
-        <dgm:pt modelId="1"/>
-        <dgm:pt modelId="11"/>
-        <dgm:pt modelId="2"/>
-        <dgm:pt modelId="21"/>
-        <dgm:pt modelId="3"/>
-        <dgm:pt modelId="31"/>
-        <dgm:pt modelId="4"/>
-        <dgm:pt modelId="41"/>
-      </dgm:ptLst>
-      <dgm:cxnLst>
-        <dgm:cxn modelId="5" srcId="0" destId="1" srcOrd="0" destOrd="0"/>
-        <dgm:cxn modelId="6" srcId="0" destId="2" srcOrd="1" destOrd="0"/>
-        <dgm:cxn modelId="7" srcId="0" destId="3" srcOrd="2" destOrd="0"/>
-        <dgm:cxn modelId="8" srcId="0" destId="4" srcOrd="3" destOrd="0"/>
-        <dgm:cxn modelId="13" srcId="1" destId="11" srcOrd="0" destOrd="0"/>
-        <dgm:cxn modelId="23" srcId="2" destId="21" srcOrd="0" destOrd="0"/>
-        <dgm:cxn modelId="33" srcId="3" destId="31" srcOrd="0" destOrd="0"/>
-        <dgm:cxn modelId="43" srcId="4" destId="41" srcOrd="0" destOrd="0"/>
-      </dgm:cxnLst>
-      <dgm:bg/>
-      <dgm:whole/>
-    </dgm:dataModel>
-  </dgm:clrData>
-  <dgm:layoutNode name="Name0">
-    <dgm:varLst>
-      <dgm:dir/>
-      <dgm:animLvl val="lvl"/>
-      <dgm:resizeHandles val="exact"/>
-    </dgm:varLst>
-    <dgm:alg type="lin">
-      <dgm:param type="linDir" val="fromB"/>
-    </dgm:alg>
-    <dgm:shape xmlns:r="http://schemas.openxmlformats.org/officeDocument/2006/relationships" r:blip="">
-      <dgm:adjLst/>
-    </dgm:shape>
-    <dgm:presOf/>
-    <dgm:constrLst>
-      <dgm:constr type="h" for="ch" forName="boxAndChildren" refType="h"/>
-      <dgm:constr type="h" for="ch" forName="arrowAndChildren" refType="h" refFor="ch" refForName="boxAndChildren" op="equ" fact="1.538"/>
-      <dgm:constr type="w" for="ch" forName="arrowAndChildren" refType="w"/>
-      <dgm:constr type="w" for="ch" forName="boxAndChildren" refType="w"/>
-      <dgm:constr type="h" for="ch" forName="sp" refType="h" fact="-0.015"/>
-      <dgm:constr type="primFontSz" for="des" forName="parentTextBox" val="36"/>
-      <dgm:constr type="primFontSz" for="des" forName="parentTextArrow" refType="primFontSz" refFor="des" refForName="parentTextBox" op="equ"/>
-      <dgm:constr type="primFontSz" for="des" forName="descendantArrow" val="24"/>
-      <dgm:constr type="primFontSz" for="des" forName="descendantArrow" refType="primFontSz" refFor="des" refForName="parentTextArrow" op="lte"/>
-      <dgm:constr type="primFontSz" for="des" forName="descendantBox" refType="primFontSz" refFor="des" refForName="parentTextArrow" op="lte"/>
-      <dgm:constr type="primFontSz" for="des" forName="descendantBox" refType="primFontSz" refFor="des" refForName="parentTextBox" op="lte"/>
-      <dgm:constr type="primFontSz" for="des" forName="descendantArrow" refType="primFontSz" refFor="des" refForName="parentTextBox" op="lte"/>
-      <dgm:constr type="primFontSz" for="des" forName="descendantBox" refType="primFontSz" refFor="des" refForName="descendantArrow" op="equ"/>
-    </dgm:constrLst>
-    <dgm:ruleLst/>
-    <dgm:forEach name="Name1" axis="ch" ptType="node" st="-1" step="-1">
-      <dgm:choose name="Name2">
-        <dgm:if name="Name3" axis="self" ptType="node" func="revPos" op="equ" val="1">
-          <dgm:layoutNode name="boxAndChildren">
-            <dgm:alg type="composite"/>
-            <dgm:shape xmlns:r="http://schemas.openxmlformats.org/officeDocument/2006/relationships" r:blip="">
-              <dgm:adjLst/>
-            </dgm:shape>
-            <dgm:presOf/>
-            <dgm:constrLst>
-              <dgm:constr type="w" for="ch" forName="parentTextBox" refType="w" fact="0.25"/>
-              <dgm:constr type="h" for="ch" forName="parentTextBox" refType="h"/>
-              <dgm:constr type="t" for="ch" forName="parentTextBox"/>
-              <dgm:constr type="w" for="ch" forName="descendantBox" refType="w" fact="0.75"/>
-              <dgm:constr type="l" for="ch" forName="descendantBox" refType="w" fact="0.25"/>
-              <dgm:constr type="b" for="ch" forName="descendantBox" refType="h"/>
-              <dgm:constr type="h" for="ch" forName="descendantBox" refType="h"/>
-            </dgm:constrLst>
-            <dgm:ruleLst/>
-            <dgm:layoutNode name="parentTextBox" styleLbl="alignNode1">
-              <dgm:alg type="tx"/>
-              <dgm:shape xmlns:r="http://schemas.openxmlformats.org/officeDocument/2006/relationships" type="rect" r:blip="">
-                <dgm:adjLst/>
-              </dgm:shape>
-              <dgm:presOf axis="self"/>
-              <dgm:constrLst>
-                <dgm:constr type="primFontSz" refType="h" op="lte" fact="0.5"/>
-                <dgm:constr type="lMarg" refType="w" fact="0.2016"/>
-                <dgm:constr type="rMarg" refType="w" fact="0.2016"/>
-              </dgm:constrLst>
-              <dgm:ruleLst>
-                <dgm:rule type="primFontSz" val="13" fact="NaN" max="NaN"/>
-              </dgm:ruleLst>
-            </dgm:layoutNode>
-            <dgm:layoutNode name="descendantBox" styleLbl="bgAccFollowNode1">
-              <dgm:alg type="tx">
-                <dgm:param type="stBulletLvl" val="0"/>
-                <dgm:param type="parTxLTRAlign" val="l"/>
-              </dgm:alg>
-              <dgm:shape xmlns:r="http://schemas.openxmlformats.org/officeDocument/2006/relationships" type="rect" r:blip="">
-                <dgm:adjLst/>
-              </dgm:shape>
-              <dgm:presOf/>
-              <dgm:constrLst>
-                <dgm:constr type="tMarg" refType="primFontSz"/>
-                <dgm:constr type="bMarg" refType="primFontSz"/>
-                <dgm:constr type="lMarg" refType="w" fact="0.0575"/>
-                <dgm:constr type="rMarg" refType="w" fact="0.0575"/>
-              </dgm:constrLst>
-              <dgm:presOf axis="des" ptType="node"/>
-              <dgm:ruleLst>
-                <dgm:rule type="primFontSz" val="11" fact="NaN" max="NaN"/>
-              </dgm:ruleLst>
-            </dgm:layoutNode>
-          </dgm:layoutNode>
-        </dgm:if>
-        <dgm:else name="Name17">
-          <dgm:layoutNode name="arrowAndChildren">
-            <dgm:alg type="composite"/>
-            <dgm:shape xmlns:r="http://schemas.openxmlformats.org/officeDocument/2006/relationships" r:blip="">
-              <dgm:adjLst/>
-            </dgm:shape>
-            <dgm:presOf/>
-            <dgm:constrLst>
-              <dgm:constr type="w" for="ch" forName="parentTextArrow" refType="w" fact="0.25"/>
-              <dgm:constr type="t" for="ch" forName="parentTextArrow"/>
-              <dgm:constr type="h" for="ch" forName="parentTextArrow" refType="h" fact="0.65"/>
-              <dgm:constr type="w" for="ch" forName="arrow" refType="w" fact="0.25"/>
-              <dgm:constr type="h" for="ch" forName="arrow" refType="h"/>
-              <dgm:constr type="l" for="ch" forName="descendantArrow" refType="w" fact="0.25"/>
-              <dgm:constr type="w" for="ch" forName="descendantArrow" refType="w" fact="0.75"/>
-              <dgm:constr type="b" for="ch" forName="descendantArrow" refType="h" fact="0.65"/>
-              <dgm:constr type="h" for="ch" forName="descendantArrow" refType="h" fact="0.65"/>
-            </dgm:constrLst>
-            <dgm:ruleLst/>
-            <dgm:layoutNode name="parentTextArrow">
-              <dgm:alg type="tx"/>
-              <dgm:choose name="Name21">
-                <dgm:if name="Name22" axis="ch" ptType="node" func="cnt" op="gte" val="1">
-                  <dgm:shape xmlns:r="http://schemas.openxmlformats.org/officeDocument/2006/relationships" type="rect" r:blip="" zOrderOff="1" hideGeom="1">
-                    <dgm:adjLst/>
-                  </dgm:shape>
-                </dgm:if>
-                <dgm:else name="Name23">
-                  <dgm:shape xmlns:r="http://schemas.openxmlformats.org/officeDocument/2006/relationships" rot="180" type="upArrowCallout" r:blip="">
-                    <dgm:adjLst/>
-                  </dgm:shape>
-                </dgm:else>
-              </dgm:choose>
-              <dgm:presOf axis="self"/>
-              <dgm:constrLst>
-                <dgm:constr type="primFontSz" refType="h" op="lte" fact="0.5"/>
-                <dgm:constr type="lMarg" refType="w" fact="0.2016"/>
-                <dgm:constr type="rMarg" refType="w" fact="0.2016"/>
-              </dgm:constrLst>
-              <dgm:ruleLst>
-                <dgm:rule type="primFontSz" val="13" fact="NaN" max="NaN"/>
-              </dgm:ruleLst>
-            </dgm:layoutNode>
-            <dgm:layoutNode name="arrow" styleLbl="alignNode1">
-              <dgm:alg type="sp"/>
-              <dgm:shape xmlns:r="http://schemas.openxmlformats.org/officeDocument/2006/relationships" rot="180" type="upArrowCallout" r:blip="">
-                <dgm:adjLst>
-                  <dgm:adj idx="1" val="0.05"/>
-                  <dgm:adj idx="2" val="0.1"/>
-                  <dgm:adj idx="3" val="0.15"/>
-                </dgm:adjLst>
-              </dgm:shape>
-              <dgm:presOf axis="self"/>
-              <dgm:constrLst/>
-              <dgm:ruleLst/>
-            </dgm:layoutNode>
-            <dgm:layoutNode name="descendantArrow" styleLbl="bgAccFollowNode1">
-              <dgm:alg type="tx">
-                <dgm:param type="stBulletLvl" val="0"/>
-                <dgm:param type="parTxLTRAlign" val="l"/>
-              </dgm:alg>
-              <dgm:shape xmlns:r="http://schemas.openxmlformats.org/officeDocument/2006/relationships" type="rect" r:blip="">
-                <dgm:adjLst/>
-              </dgm:shape>
-              <dgm:presOf axis="des" ptType="node"/>
-              <dgm:constrLst>
-                <dgm:constr type="tMarg" refType="primFontSz"/>
-                <dgm:constr type="bMarg" refType="primFontSz"/>
-                <dgm:constr type="lMarg" refType="w" fact="0.0575"/>
-                <dgm:constr type="rMarg" refType="w" fact="0.0575"/>
-              </dgm:constrLst>
-              <dgm:ruleLst>
-                <dgm:rule type="primFontSz" val="11" fact="NaN" max="NaN"/>
-              </dgm:ruleLst>
-            </dgm:layoutNode>
-          </dgm:layoutNode>
-        </dgm:else>
-      </dgm:choose>
-      <dgm:forEach name="Name31" axis="precedSib" ptType="sibTrans" st="-1" cnt="1">
-        <dgm:layoutNode name="sp">
-          <dgm:alg type="sp"/>
-          <dgm:shape xmlns:r="http://schemas.openxmlformats.org/officeDocument/2006/relationships" r:blip="">
-            <dgm:adjLst/>
-          </dgm:shape>
-          <dgm:presOf axis="self"/>
-          <dgm:constrLst/>
-          <dgm:ruleLst/>
-        </dgm:layoutNode>
-      </dgm:forEach>
-    </dgm:forEach>
-  </dgm:layoutNode>
-</dgm:layoutDef>
-</file>
-
-<file path=ppt/diagrams/quickStyle1.xml><?xml version="1.0" encoding="utf-8"?>
-<dgm:styleDef xmlns:dgm="http://schemas.openxmlformats.org/drawingml/2006/diagram" xmlns:a="http://schemas.openxmlformats.org/drawingml/2006/main" uniqueId="urn:microsoft.com/office/officeart/2005/8/quickstyle/simple1">
-  <dgm:title val=""/>
-  <dgm:desc val=""/>
-  <dgm:catLst>
-    <dgm:cat type="simple" pri="10100"/>
-  </dgm:catLst>
-  <dgm:scene3d>
-    <a:camera prst="orthographicFront"/>
-    <a:lightRig rig="threePt" dir="t"/>
-  </dgm:scene3d>
-  <dgm:styleLbl name="node0">
-    <dgm:scene3d>
-      <a:camera prst="orthographicFront"/>
-      <a:lightRig rig="threePt" dir="t"/>
-    </dgm:scene3d>
-    <dgm:sp3d/>
-    <dgm:txPr/>
-    <dgm:style>
-      <a:lnRef idx="2">
-        <a:scrgbClr r="0" g="0" b="0"/>
-      </a:lnRef>
-      <a:fillRef idx="1">
-        <a:scrgbClr r="0" g="0" b="0"/>
-      </a:fillRef>
-      <a:effectRef idx="0">
-        <a:scrgbClr r="0" g="0" b="0"/>
-      </a:effectRef>
-      <a:fontRef idx="minor">
-        <a:schemeClr val="lt1"/>
-      </a:fontRef>
-    </dgm:style>
-  </dgm:styleLbl>
-  <dgm:styleLbl name="lnNode1">
-    <dgm:scene3d>
-      <a:camera prst="orthographicFront"/>
-      <a:lightRig rig="threePt" dir="t"/>
-    </dgm:scene3d>
-    <dgm:sp3d/>
-    <dgm:txPr/>
-    <dgm:style>
-      <a:lnRef idx="2">
-        <a:scrgbClr r="0" g="0" b="0"/>
-      </a:lnRef>
-      <a:fillRef idx="1">
-        <a:scrgbClr r="0" g="0" b="0"/>
-      </a:fillRef>
-      <a:effectRef idx="0">
-        <a:scrgbClr r="0" g="0" b="0"/>
-      </a:effectRef>
-      <a:fontRef idx="minor">
-        <a:schemeClr val="lt1"/>
-      </a:fontRef>
-    </dgm:style>
-  </dgm:styleLbl>
-  <dgm:styleLbl name="vennNode1">
-    <dgm:scene3d>
-      <a:camera prst="orthographicFront"/>
-      <a:lightRig rig="threePt" dir="t"/>
-    </dgm:scene3d>
-    <dgm:sp3d/>
-    <dgm:txPr/>
-    <dgm:style>
-      <a:lnRef idx="2">
-        <a:scrgbClr r="0" g="0" b="0"/>
-      </a:lnRef>
-      <a:fillRef idx="1">
-        <a:scrgbClr r="0" g="0" b="0"/>
-      </a:fillRef>
-      <a:effectRef idx="0">
-        <a:scrgbClr r="0" g="0" b="0"/>
-      </a:effectRef>
-      <a:fontRef idx="minor">
-        <a:schemeClr val="tx1"/>
-      </a:fontRef>
-    </dgm:style>
-  </dgm:styleLbl>
-  <dgm:styleLbl name="alignNode1">
-    <dgm:scene3d>
-      <a:camera prst="orthographicFront"/>
-      <a:lightRig rig="threePt" dir="t"/>
-    </dgm:scene3d>
-    <dgm:sp3d/>
-    <dgm:txPr/>
-    <dgm:style>
-      <a:lnRef idx="2">
-        <a:scrgbClr r="0" g="0" b="0"/>
-      </a:lnRef>
-      <a:fillRef idx="1">
-        <a:scrgbClr r="0" g="0" b="0"/>
-      </a:fillRef>
-      <a:effectRef idx="0">
-        <a:scrgbClr r="0" g="0" b="0"/>
-      </a:effectRef>
-      <a:fontRef idx="minor">
-        <a:schemeClr val="lt1"/>
-      </a:fontRef>
-    </dgm:style>
-  </dgm:styleLbl>
-  <dgm:styleLbl name="node1">
-    <dgm:scene3d>
-      <a:camera prst="orthographicFront"/>
-      <a:lightRig rig="threePt" dir="t"/>
-    </dgm:scene3d>
-    <dgm:sp3d/>
-    <dgm:txPr/>
-    <dgm:style>
-      <a:lnRef idx="2">
-        <a:scrgbClr r="0" g="0" b="0"/>
-      </a:lnRef>
-      <a:fillRef idx="1">
-        <a:scrgbClr r="0" g="0" b="0"/>
-      </a:fillRef>
-      <a:effectRef idx="0">
-        <a:scrgbClr r="0" g="0" b="0"/>
-      </a:effectRef>
-      <a:fontRef idx="minor">
-        <a:schemeClr val="lt1"/>
-      </a:fontRef>
-    </dgm:style>
-  </dgm:styleLbl>
-  <dgm:styleLbl name="node2">
-    <dgm:scene3d>
-      <a:camera prst="orthographicFront"/>
-      <a:lightRig rig="threePt" dir="t"/>
-    </dgm:scene3d>
-    <dgm:sp3d/>
-    <dgm:txPr/>
-    <dgm:style>
-      <a:lnRef idx="2">
-        <a:scrgbClr r="0" g="0" b="0"/>
-      </a:lnRef>
-      <a:fillRef idx="1">
-        <a:scrgbClr r="0" g="0" b="0"/>
-      </a:fillRef>
-      <a:effectRef idx="0">
-        <a:scrgbClr r="0" g="0" b="0"/>
-      </a:effectRef>
-      <a:fontRef idx="minor">
-        <a:schemeClr val="lt1"/>
-      </a:fontRef>
-    </dgm:style>
-  </dgm:styleLbl>
-  <dgm:styleLbl name="node3">
-    <dgm:scene3d>
-      <a:camera prst="orthographicFront"/>
-      <a:lightRig rig="threePt" dir="t"/>
-    </dgm:scene3d>
-    <dgm:sp3d/>
-    <dgm:txPr/>
-    <dgm:style>
-      <a:lnRef idx="2">
-        <a:scrgbClr r="0" g="0" b="0"/>
-      </a:lnRef>
-      <a:fillRef idx="1">
-        <a:scrgbClr r="0" g="0" b="0"/>
-      </a:fillRef>
-      <a:effectRef idx="0">
-        <a:scrgbClr r="0" g="0" b="0"/>
-      </a:effectRef>
-      <a:fontRef idx="minor">
-        <a:schemeClr val="lt1"/>
-      </a:fontRef>
-    </dgm:style>
-  </dgm:styleLbl>
-  <dgm:styleLbl name="node4">
-    <dgm:scene3d>
-      <a:camera prst="orthographicFront"/>
-      <a:lightRig rig="threePt" dir="t"/>
-    </dgm:scene3d>
-    <dgm:sp3d/>
-    <dgm:txPr/>
-    <dgm:style>
-      <a:lnRef idx="2">
-        <a:scrgbClr r="0" g="0" b="0"/>
-      </a:lnRef>
-      <a:fillRef idx="1">
-        <a:scrgbClr r="0" g="0" b="0"/>
-      </a:fillRef>
-      <a:effectRef idx="0">
-        <a:scrgbClr r="0" g="0" b="0"/>
-      </a:effectRef>
-      <a:fontRef idx="minor">
-        <a:schemeClr val="lt1"/>
-      </a:fontRef>
-    </dgm:style>
-  </dgm:styleLbl>
-  <dgm:styleLbl name="fgImgPlace1">
-    <dgm:scene3d>
-      <a:camera prst="orthographicFront"/>
-      <a:lightRig rig="threePt" dir="t"/>
-    </dgm:scene3d>
-    <dgm:sp3d/>
-    <dgm:txPr/>
-    <dgm:style>
-      <a:lnRef idx="2">
-        <a:scrgbClr r="0" g="0" b="0"/>
-      </a:lnRef>
-      <a:fillRef idx="1">
-        <a:scrgbClr r="0" g="0" b="0"/>
-      </a:fillRef>
-      <a:effectRef idx="0">
-        <a:scrgbClr r="0" g="0" b="0"/>
-      </a:effectRef>
-      <a:fontRef idx="minor"/>
-    </dgm:style>
-  </dgm:styleLbl>
-  <dgm:styleLbl name="alignImgPlace1">
-    <dgm:scene3d>
-      <a:camera prst="orthographicFront"/>
-      <a:lightRig rig="threePt" dir="t"/>
-    </dgm:scene3d>
-    <dgm:sp3d/>
-    <dgm:txPr/>
-    <dgm:style>
-      <a:lnRef idx="2">
-        <a:scrgbClr r="0" g="0" b="0"/>
-      </a:lnRef>
-      <a:fillRef idx="1">
-        <a:scrgbClr r="0" g="0" b="0"/>
-      </a:fillRef>
-      <a:effectRef idx="0">
-        <a:scrgbClr r="0" g="0" b="0"/>
-      </a:effectRef>
-      <a:fontRef idx="minor"/>
-    </dgm:style>
-  </dgm:styleLbl>
-  <dgm:styleLbl name="bgImgPlace1">
-    <dgm:scene3d>
-      <a:camera prst="orthographicFront"/>
-      <a:lightRig rig="threePt" dir="t"/>
-    </dgm:scene3d>
-    <dgm:sp3d/>
-    <dgm:txPr/>
-    <dgm:style>
-      <a:lnRef idx="2">
-        <a:scrgbClr r="0" g="0" b="0"/>
-      </a:lnRef>
-      <a:fillRef idx="1">
-        <a:scrgbClr r="0" g="0" b="0"/>
-      </a:fillRef>
-      <a:effectRef idx="0">
-        <a:scrgbClr r="0" g="0" b="0"/>
-      </a:effectRef>
-      <a:fontRef idx="minor"/>
-    </dgm:style>
-  </dgm:styleLbl>
-  <dgm:styleLbl name="sibTrans2D1">
-    <dgm:scene3d>
-      <a:camera prst="orthographicFront"/>
-      <a:lightRig rig="threePt" dir="t"/>
-    </dgm:scene3d>
-    <dgm:sp3d/>
-    <dgm:txPr/>
-    <dgm:style>
-      <a:lnRef idx="0">
-        <a:scrgbClr r="0" g="0" b="0"/>
-      </a:lnRef>
-      <a:fillRef idx="1">
-        <a:scrgbClr r="0" g="0" b="0"/>
-      </a:fillRef>
-      <a:effectRef idx="0">
-        <a:scrgbClr r="0" g="0" b="0"/>
-      </a:effectRef>
-      <a:fontRef idx="minor">
-        <a:schemeClr val="lt1"/>
-      </a:fontRef>
-    </dgm:style>
-  </dgm:styleLbl>
-  <dgm:styleLbl name="fgSibTrans2D1">
-    <dgm:scene3d>
-      <a:camera prst="orthographicFront"/>
-      <a:lightRig rig="threePt" dir="t"/>
-    </dgm:scene3d>
-    <dgm:sp3d/>
-    <dgm:txPr/>
-    <dgm:style>
-      <a:lnRef idx="0">
-        <a:scrgbClr r="0" g="0" b="0"/>
-      </a:lnRef>
-      <a:fillRef idx="1">
-        <a:scrgbClr r="0" g="0" b="0"/>
-      </a:fillRef>
-      <a:effectRef idx="0">
-        <a:scrgbClr r="0" g="0" b="0"/>
-      </a:effectRef>
-      <a:fontRef idx="minor">
-        <a:schemeClr val="lt1"/>
-      </a:fontRef>
-    </dgm:style>
-  </dgm:styleLbl>
-  <dgm:styleLbl name="bgSibTrans2D1">
-    <dgm:scene3d>
-      <a:camera prst="orthographicFront"/>
-      <a:lightRig rig="threePt" dir="t"/>
-    </dgm:scene3d>
-    <dgm:sp3d/>
-    <dgm:txPr/>
-    <dgm:style>
-      <a:lnRef idx="0">
-        <a:scrgbClr r="0" g="0" b="0"/>
-      </a:lnRef>
-      <a:fillRef idx="1">
-        <a:scrgbClr r="0" g="0" b="0"/>
-      </a:fillRef>
-      <a:effectRef idx="0">
-        <a:scrgbClr r="0" g="0" b="0"/>
-      </a:effectRef>
-      <a:fontRef idx="minor">
-        <a:schemeClr val="lt1"/>
-      </a:fontRef>
-    </dgm:style>
-  </dgm:styleLbl>
-  <dgm:styleLbl name="sibTrans1D1">
-    <dgm:scene3d>
-      <a:camera prst="orthographicFront"/>
-      <a:lightRig rig="threePt" dir="t"/>
-    </dgm:scene3d>
-    <dgm:sp3d/>
-    <dgm:txPr/>
-    <dgm:style>
-      <a:lnRef idx="1">
-        <a:scrgbClr r="0" g="0" b="0"/>
-      </a:lnRef>
-      <a:fillRef idx="0">
-        <a:scrgbClr r="0" g="0" b="0"/>
-      </a:fillRef>
-      <a:effectRef idx="0">
-        <a:scrgbClr r="0" g="0" b="0"/>
-      </a:effectRef>
-      <a:fontRef idx="minor"/>
-    </dgm:style>
-  </dgm:styleLbl>
-  <dgm:styleLbl name="callout">
-    <dgm:scene3d>
-      <a:camera prst="orthographicFront"/>
-      <a:lightRig rig="threePt" dir="t"/>
-    </dgm:scene3d>
-    <dgm:sp3d/>
-    <dgm:txPr/>
-    <dgm:style>
-      <a:lnRef idx="2">
-        <a:scrgbClr r="0" g="0" b="0"/>
-      </a:lnRef>
-      <a:fillRef idx="1">
-        <a:scrgbClr r="0" g="0" b="0"/>
-      </a:fillRef>
-      <a:effectRef idx="0">
-        <a:scrgbClr r="0" g="0" b="0"/>
-      </a:effectRef>
-      <a:fontRef idx="minor"/>
-    </dgm:style>
-  </dgm:styleLbl>
-  <dgm:styleLbl name="asst0">
-    <dgm:scene3d>
-      <a:camera prst="orthographicFront"/>
-      <a:lightRig rig="threePt" dir="t"/>
-    </dgm:scene3d>
-    <dgm:sp3d/>
-    <dgm:txPr/>
-    <dgm:style>
-      <a:lnRef idx="2">
-        <a:scrgbClr r="0" g="0" b="0"/>
-      </a:lnRef>
-      <a:fillRef idx="1">
-        <a:scrgbClr r="0" g="0" b="0"/>
-      </a:fillRef>
-      <a:effectRef idx="0">
-        <a:scrgbClr r="0" g="0" b="0"/>
-      </a:effectRef>
-      <a:fontRef idx="minor">
-        <a:schemeClr val="lt1"/>
-      </a:fontRef>
-    </dgm:style>
-  </dgm:styleLbl>
-  <dgm:styleLbl name="asst1">
-    <dgm:scene3d>
-      <a:camera prst="orthographicFront"/>
-      <a:lightRig rig="threePt" dir="t"/>
-    </dgm:scene3d>
-    <dgm:sp3d/>
-    <dgm:txPr/>
-    <dgm:style>
-      <a:lnRef idx="2">
-        <a:scrgbClr r="0" g="0" b="0"/>
-      </a:lnRef>
-      <a:fillRef idx="1">
-        <a:scrgbClr r="0" g="0" b="0"/>
-      </a:fillRef>
-      <a:effectRef idx="0">
-        <a:scrgbClr r="0" g="0" b="0"/>
-      </a:effectRef>
-      <a:fontRef idx="minor">
-        <a:schemeClr val="lt1"/>
-      </a:fontRef>
-    </dgm:style>
-  </dgm:styleLbl>
-  <dgm:styleLbl name="asst2">
-    <dgm:scene3d>
-      <a:camera prst="orthographicFront"/>
-      <a:lightRig rig="threePt" dir="t"/>
-    </dgm:scene3d>
-    <dgm:sp3d/>
-    <dgm:txPr/>
-    <dgm:style>
-      <a:lnRef idx="2">
-        <a:scrgbClr r="0" g="0" b="0"/>
-      </a:lnRef>
-      <a:fillRef idx="1">
-        <a:scrgbClr r="0" g="0" b="0"/>
-      </a:fillRef>
-      <a:effectRef idx="0">
-        <a:scrgbClr r="0" g="0" b="0"/>
-      </a:effectRef>
-      <a:fontRef idx="minor">
-        <a:schemeClr val="lt1"/>
-      </a:fontRef>
-    </dgm:style>
-  </dgm:styleLbl>
-  <dgm:styleLbl name="asst3">
-    <dgm:scene3d>
-      <a:camera prst="orthographicFront"/>
-      <a:lightRig rig="threePt" dir="t"/>
-    </dgm:scene3d>
-    <dgm:sp3d/>
-    <dgm:txPr/>
-    <dgm:style>
-      <a:lnRef idx="2">
-        <a:scrgbClr r="0" g="0" b="0"/>
-      </a:lnRef>
-      <a:fillRef idx="1">
-        <a:scrgbClr r="0" g="0" b="0"/>
-      </a:fillRef>
-      <a:effectRef idx="0">
-        <a:scrgbClr r="0" g="0" b="0"/>
-      </a:effectRef>
-      <a:fontRef idx="minor">
-        <a:schemeClr val="lt1"/>
-      </a:fontRef>
-    </dgm:style>
-  </dgm:styleLbl>
-  <dgm:styleLbl name="asst4">
-    <dgm:scene3d>
-      <a:camera prst="orthographicFront"/>
-      <a:lightRig rig="threePt" dir="t"/>
-    </dgm:scene3d>
-    <dgm:sp3d/>
-    <dgm:txPr/>
-    <dgm:style>
-      <a:lnRef idx="2">
-        <a:scrgbClr r="0" g="0" b="0"/>
-      </a:lnRef>
-      <a:fillRef idx="1">
-        <a:scrgbClr r="0" g="0" b="0"/>
-      </a:fillRef>
-      <a:effectRef idx="0">
-        <a:scrgbClr r="0" g="0" b="0"/>
-      </a:effectRef>
-      <a:fontRef idx="minor">
-        <a:schemeClr val="lt1"/>
-      </a:fontRef>
-    </dgm:style>
-  </dgm:styleLbl>
-  <dgm:styleLbl name="parChTrans2D1">
-    <dgm:scene3d>
-      <a:camera prst="orthographicFront"/>
-      <a:lightRig rig="threePt" dir="t"/>
-    </dgm:scene3d>
-    <dgm:sp3d/>
-    <dgm:txPr/>
-    <dgm:style>
-      <a:lnRef idx="2">
-        <a:scrgbClr r="0" g="0" b="0"/>
-      </a:lnRef>
-      <a:fillRef idx="1">
-        <a:scrgbClr r="0" g="0" b="0"/>
-      </a:fillRef>
-      <a:effectRef idx="0">
-        <a:scrgbClr r="0" g="0" b="0"/>
-      </a:effectRef>
-      <a:fontRef idx="minor">
-        <a:schemeClr val="lt1"/>
-      </a:fontRef>
-    </dgm:style>
-  </dgm:styleLbl>
-  <dgm:styleLbl name="parChTrans2D2">
-    <dgm:scene3d>
-      <a:camera prst="orthographicFront"/>
-      <a:lightRig rig="threePt" dir="t"/>
-    </dgm:scene3d>
-    <dgm:sp3d/>
-    <dgm:txPr/>
-    <dgm:style>
-      <a:lnRef idx="2">
-        <a:scrgbClr r="0" g="0" b="0"/>
-      </a:lnRef>
-      <a:fillRef idx="1">
-        <a:scrgbClr r="0" g="0" b="0"/>
-      </a:fillRef>
-      <a:effectRef idx="0">
-        <a:scrgbClr r="0" g="0" b="0"/>
-      </a:effectRef>
-      <a:fontRef idx="minor">
-        <a:schemeClr val="lt1"/>
-      </a:fontRef>
-    </dgm:style>
-  </dgm:styleLbl>
-  <dgm:styleLbl name="parChTrans2D3">
-    <dgm:scene3d>
-      <a:camera prst="orthographicFront"/>
-      <a:lightRig rig="threePt" dir="t"/>
-    </dgm:scene3d>
-    <dgm:sp3d/>
-    <dgm:txPr/>
-    <dgm:style>
-      <a:lnRef idx="2">
-        <a:scrgbClr r="0" g="0" b="0"/>
-      </a:lnRef>
-      <a:fillRef idx="1">
-        <a:scrgbClr r="0" g="0" b="0"/>
-      </a:fillRef>
-      <a:effectRef idx="0">
-        <a:scrgbClr r="0" g="0" b="0"/>
-      </a:effectRef>
-      <a:fontRef idx="minor">
-        <a:schemeClr val="lt1"/>
-      </a:fontRef>
-    </dgm:style>
-  </dgm:styleLbl>
-  <dgm:styleLbl name="parChTrans2D4">
-    <dgm:scene3d>
-      <a:camera prst="orthographicFront"/>
-      <a:lightRig rig="threePt" dir="t"/>
-    </dgm:scene3d>
-    <dgm:sp3d/>
-    <dgm:txPr/>
-    <dgm:style>
-      <a:lnRef idx="2">
-        <a:scrgbClr r="0" g="0" b="0"/>
-      </a:lnRef>
-      <a:fillRef idx="1">
-        <a:scrgbClr r="0" g="0" b="0"/>
-      </a:fillRef>
-      <a:effectRef idx="0">
-        <a:scrgbClr r="0" g="0" b="0"/>
-      </a:effectRef>
-      <a:fontRef idx="minor">
-        <a:schemeClr val="lt1"/>
-      </a:fontRef>
-    </dgm:style>
-  </dgm:styleLbl>
-  <dgm:styleLbl name="parChTrans1D1">
-    <dgm:scene3d>
-      <a:camera prst="orthographicFront"/>
-      <a:lightRig rig="threePt" dir="t"/>
-    </dgm:scene3d>
-    <dgm:sp3d/>
-    <dgm:txPr/>
-    <dgm:style>
-      <a:lnRef idx="2">
-        <a:scrgbClr r="0" g="0" b="0"/>
-      </a:lnRef>
-      <a:fillRef idx="0">
-        <a:scrgbClr r="0" g="0" b="0"/>
-      </a:fillRef>
-      <a:effectRef idx="0">
-        <a:scrgbClr r="0" g="0" b="0"/>
-      </a:effectRef>
-      <a:fontRef idx="minor"/>
-    </dgm:style>
-  </dgm:styleLbl>
-  <dgm:styleLbl name="parChTrans1D2">
-    <dgm:scene3d>
-      <a:camera prst="orthographicFront"/>
-      <a:lightRig rig="threePt" dir="t"/>
-    </dgm:scene3d>
-    <dgm:sp3d/>
-    <dgm:txPr/>
-    <dgm:style>
-      <a:lnRef idx="2">
-        <a:scrgbClr r="0" g="0" b="0"/>
-      </a:lnRef>
-      <a:fillRef idx="0">
-        <a:scrgbClr r="0" g="0" b="0"/>
-      </a:fillRef>
-      <a:effectRef idx="0">
-        <a:scrgbClr r="0" g="0" b="0"/>
-      </a:effectRef>
-      <a:fontRef idx="minor"/>
-    </dgm:style>
-  </dgm:styleLbl>
-  <dgm:styleLbl name="parChTrans1D3">
-    <dgm:scene3d>
-      <a:camera prst="orthographicFront"/>
-      <a:lightRig rig="threePt" dir="t"/>
-    </dgm:scene3d>
-    <dgm:sp3d/>
-    <dgm:txPr/>
-    <dgm:style>
-      <a:lnRef idx="2">
-        <a:scrgbClr r="0" g="0" b="0"/>
-      </a:lnRef>
-      <a:fillRef idx="0">
-        <a:scrgbClr r="0" g="0" b="0"/>
-      </a:fillRef>
-      <a:effectRef idx="0">
-        <a:scrgbClr r="0" g="0" b="0"/>
-      </a:effectRef>
-      <a:fontRef idx="minor"/>
-    </dgm:style>
-  </dgm:styleLbl>
-  <dgm:styleLbl name="parChTrans1D4">
-    <dgm:scene3d>
-      <a:camera prst="orthographicFront"/>
-      <a:lightRig rig="threePt" dir="t"/>
-    </dgm:scene3d>
-    <dgm:sp3d/>
-    <dgm:txPr/>
-    <dgm:style>
-      <a:lnRef idx="2">
-        <a:scrgbClr r="0" g="0" b="0"/>
-      </a:lnRef>
-      <a:fillRef idx="0">
-        <a:scrgbClr r="0" g="0" b="0"/>
-      </a:fillRef>
-      <a:effectRef idx="0">
-        <a:scrgbClr r="0" g="0" b="0"/>
-      </a:effectRef>
-      <a:fontRef idx="minor"/>
-    </dgm:style>
-  </dgm:styleLbl>
-  <dgm:styleLbl name="fgAcc1">
-    <dgm:scene3d>
-      <a:camera prst="orthographicFront"/>
-      <a:lightRig rig="threePt" dir="t"/>
-    </dgm:scene3d>
-    <dgm:sp3d/>
-    <dgm:txPr/>
-    <dgm:style>
-      <a:lnRef idx="2">
-        <a:scrgbClr r="0" g="0" b="0"/>
-      </a:lnRef>
-      <a:fillRef idx="1">
-        <a:scrgbClr r="0" g="0" b="0"/>
-      </a:fillRef>
-      <a:effectRef idx="0">
-        <a:scrgbClr r="0" g="0" b="0"/>
-      </a:effectRef>
-      <a:fontRef idx="minor"/>
-    </dgm:style>
-  </dgm:styleLbl>
-  <dgm:styleLbl name="conFgAcc1">
-    <dgm:scene3d>
-      <a:camera prst="orthographicFront"/>
-      <a:lightRig rig="threePt" dir="t"/>
-    </dgm:scene3d>
-    <dgm:sp3d/>
-    <dgm:txPr/>
-    <dgm:style>
-      <a:lnRef idx="2">
-        <a:scrgbClr r="0" g="0" b="0"/>
-      </a:lnRef>
-      <a:fillRef idx="1">
-        <a:scrgbClr r="0" g="0" b="0"/>
-      </a:fillRef>
-      <a:effectRef idx="0">
-        <a:scrgbClr r="0" g="0" b="0"/>
-      </a:effectRef>
-      <a:fontRef idx="minor"/>
-    </dgm:style>
-  </dgm:styleLbl>
-  <dgm:styleLbl name="alignAcc1">
-    <dgm:scene3d>
-      <a:camera prst="orthographicFront"/>
-      <a:lightRig rig="threePt" dir="t"/>
-    </dgm:scene3d>
-    <dgm:sp3d/>
-    <dgm:txPr/>
-    <dgm:style>
-      <a:lnRef idx="2">
-        <a:scrgbClr r="0" g="0" b="0"/>
-      </a:lnRef>
-      <a:fillRef idx="1">
-        <a:scrgbClr r="0" g="0" b="0"/>
-      </a:fillRef>
-      <a:effectRef idx="0">
-        <a:scrgbClr r="0" g="0" b="0"/>
-      </a:effectRef>
-      <a:fontRef idx="minor"/>
-    </dgm:style>
-  </dgm:styleLbl>
-  <dgm:styleLbl name="trAlignAcc1">
-    <dgm:scene3d>
-      <a:camera prst="orthographicFront"/>
-      <a:lightRig rig="threePt" dir="t"/>
-    </dgm:scene3d>
-    <dgm:sp3d/>
-    <dgm:txPr/>
-    <dgm:style>
-      <a:lnRef idx="1">
-        <a:scrgbClr r="0" g="0" b="0"/>
-      </a:lnRef>
-      <a:fillRef idx="1">
-        <a:scrgbClr r="0" g="0" b="0"/>
-      </a:fillRef>
-      <a:effectRef idx="0">
-        <a:scrgbClr r="0" g="0" b="0"/>
-      </a:effectRef>
-      <a:fontRef idx="minor"/>
-    </dgm:style>
-  </dgm:styleLbl>
-  <dgm:styleLbl name="bgAcc1">
-    <dgm:scene3d>
-      <a:camera prst="orthographicFront"/>
-      <a:lightRig rig="threePt" dir="t"/>
-    </dgm:scene3d>
-    <dgm:sp3d/>
-    <dgm:txPr/>
-    <dgm:style>
-      <a:lnRef idx="2">
-        <a:scrgbClr r="0" g="0" b="0"/>
-      </a:lnRef>
-      <a:fillRef idx="1">
-        <a:scrgbClr r="0" g="0" b="0"/>
-      </a:fillRef>
-      <a:effectRef idx="0">
-        <a:scrgbClr r="0" g="0" b="0"/>
-      </a:effectRef>
-      <a:fontRef idx="minor"/>
-    </dgm:style>
-  </dgm:styleLbl>
-  <dgm:styleLbl name="solidFgAcc1">
-    <dgm:scene3d>
-      <a:camera prst="orthographicFront"/>
-      <a:lightRig rig="threePt" dir="t"/>
-    </dgm:scene3d>
-    <dgm:sp3d/>
-    <dgm:txPr/>
-    <dgm:style>
-      <a:lnRef idx="2">
-        <a:scrgbClr r="0" g="0" b="0"/>
-      </a:lnRef>
-      <a:fillRef idx="1">
-        <a:scrgbClr r="0" g="0" b="0"/>
-      </a:fillRef>
-      <a:effectRef idx="0">
-        <a:scrgbClr r="0" g="0" b="0"/>
-      </a:effectRef>
-      <a:fontRef idx="minor"/>
-    </dgm:style>
-  </dgm:styleLbl>
-  <dgm:styleLbl name="solidAlignAcc1">
-    <dgm:scene3d>
-      <a:camera prst="orthographicFront"/>
-      <a:lightRig rig="threePt" dir="t"/>
-    </dgm:scene3d>
-    <dgm:sp3d/>
-    <dgm:txPr/>
-    <dgm:style>
-      <a:lnRef idx="2">
-        <a:scrgbClr r="0" g="0" b="0"/>
-      </a:lnRef>
-      <a:fillRef idx="1">
-        <a:scrgbClr r="0" g="0" b="0"/>
-      </a:fillRef>
-      <a:effectRef idx="0">
-        <a:scrgbClr r="0" g="0" b="0"/>
-      </a:effectRef>
-      <a:fontRef idx="minor"/>
-    </dgm:style>
-  </dgm:styleLbl>
-  <dgm:styleLbl name="solidBgAcc1">
-    <dgm:scene3d>
-      <a:camera prst="orthographicFront"/>
-      <a:lightRig rig="threePt" dir="t"/>
-    </dgm:scene3d>
-    <dgm:sp3d/>
-    <dgm:txPr/>
-    <dgm:style>
-      <a:lnRef idx="2">
-        <a:scrgbClr r="0" g="0" b="0"/>
-      </a:lnRef>
-      <a:fillRef idx="1">
-        <a:scrgbClr r="0" g="0" b="0"/>
-      </a:fillRef>
-      <a:effectRef idx="0">
-        <a:scrgbClr r="0" g="0" b="0"/>
-      </a:effectRef>
-      <a:fontRef idx="minor"/>
-    </dgm:style>
-  </dgm:styleLbl>
-  <dgm:styleLbl name="fgAccFollowNode1">
-    <dgm:scene3d>
-      <a:camera prst="orthographicFront"/>
-      <a:lightRig rig="threePt" dir="t"/>
-    </dgm:scene3d>
-    <dgm:sp3d/>
-    <dgm:txPr/>
-    <dgm:style>
-      <a:lnRef idx="2">
-        <a:scrgbClr r="0" g="0" b="0"/>
-      </a:lnRef>
-      <a:fillRef idx="1">
-        <a:scrgbClr r="0" g="0" b="0"/>
-      </a:fillRef>
-      <a:effectRef idx="0">
-        <a:scrgbClr r="0" g="0" b="0"/>
-      </a:effectRef>
-      <a:fontRef idx="minor"/>
-    </dgm:style>
-  </dgm:styleLbl>
-  <dgm:styleLbl name="alignAccFollowNode1">
-    <dgm:scene3d>
-      <a:camera prst="orthographicFront"/>
-      <a:lightRig rig="threePt" dir="t"/>
-    </dgm:scene3d>
-    <dgm:sp3d/>
-    <dgm:txPr/>
-    <dgm:style>
-      <a:lnRef idx="2">
-        <a:scrgbClr r="0" g="0" b="0"/>
-      </a:lnRef>
-      <a:fillRef idx="1">
-        <a:scrgbClr r="0" g="0" b="0"/>
-      </a:fillRef>
-      <a:effectRef idx="0">
-        <a:scrgbClr r="0" g="0" b="0"/>
-      </a:effectRef>
-      <a:fontRef idx="minor"/>
-    </dgm:style>
-  </dgm:styleLbl>
-  <dgm:styleLbl name="bgAccFollowNode1">
-    <dgm:scene3d>
-      <a:camera prst="orthographicFront"/>
-      <a:lightRig rig="threePt" dir="t"/>
-    </dgm:scene3d>
-    <dgm:sp3d/>
-    <dgm:txPr/>
-    <dgm:style>
-      <a:lnRef idx="2">
-        <a:scrgbClr r="0" g="0" b="0"/>
-      </a:lnRef>
-      <a:fillRef idx="1">
-        <a:scrgbClr r="0" g="0" b="0"/>
-      </a:fillRef>
-      <a:effectRef idx="0">
-        <a:scrgbClr r="0" g="0" b="0"/>
-      </a:effectRef>
-      <a:fontRef idx="minor"/>
-    </dgm:style>
-  </dgm:styleLbl>
-  <dgm:styleLbl name="fgAcc0">
-    <dgm:scene3d>
-      <a:camera prst="orthographicFront"/>
-      <a:lightRig rig="threePt" dir="t"/>
-    </dgm:scene3d>
-    <dgm:sp3d/>
-    <dgm:txPr/>
-    <dgm:style>
-      <a:lnRef idx="2">
-        <a:scrgbClr r="0" g="0" b="0"/>
-      </a:lnRef>
-      <a:fillRef idx="1">
-        <a:scrgbClr r="0" g="0" b="0"/>
-      </a:fillRef>
-      <a:effectRef idx="0">
-        <a:scrgbClr r="0" g="0" b="0"/>
-      </a:effectRef>
-      <a:fontRef idx="minor"/>
-    </dgm:style>
-  </dgm:styleLbl>
-  <dgm:styleLbl name="fgAcc2">
-    <dgm:scene3d>
-      <a:camera prst="orthographicFront"/>
-      <a:lightRig rig="threePt" dir="t"/>
-    </dgm:scene3d>
-    <dgm:sp3d/>
-    <dgm:txPr/>
-    <dgm:style>
-      <a:lnRef idx="2">
-        <a:scrgbClr r="0" g="0" b="0"/>
-      </a:lnRef>
-      <a:fillRef idx="1">
-        <a:scrgbClr r="0" g="0" b="0"/>
-      </a:fillRef>
-      <a:effectRef idx="0">
-        <a:scrgbClr r="0" g="0" b="0"/>
-      </a:effectRef>
-      <a:fontRef idx="minor"/>
-    </dgm:style>
-  </dgm:styleLbl>
-  <dgm:styleLbl name="fgAcc3">
-    <dgm:scene3d>
-      <a:camera prst="orthographicFront"/>
-      <a:lightRig rig="threePt" dir="t"/>
-    </dgm:scene3d>
-    <dgm:sp3d/>
-    <dgm:txPr/>
-    <dgm:style>
-      <a:lnRef idx="2">
-        <a:scrgbClr r="0" g="0" b="0"/>
-      </a:lnRef>
-      <a:fillRef idx="1">
-        <a:scrgbClr r="0" g="0" b="0"/>
-      </a:fillRef>
-      <a:effectRef idx="0">
-        <a:scrgbClr r="0" g="0" b="0"/>
-      </a:effectRef>
-      <a:fontRef idx="minor"/>
-    </dgm:style>
-  </dgm:styleLbl>
-  <dgm:styleLbl name="fgAcc4">
-    <dgm:scene3d>
-      <a:camera prst="orthographicFront"/>
-      <a:lightRig rig="threePt" dir="t"/>
-    </dgm:scene3d>
-    <dgm:sp3d/>
-    <dgm:txPr/>
-    <dgm:style>
-      <a:lnRef idx="2">
-        <a:scrgbClr r="0" g="0" b="0"/>
-      </a:lnRef>
-      <a:fillRef idx="1">
-        <a:scrgbClr r="0" g="0" b="0"/>
-      </a:fillRef>
-      <a:effectRef idx="0">
-        <a:scrgbClr r="0" g="0" b="0"/>
-      </a:effectRef>
-      <a:fontRef idx="minor"/>
-    </dgm:style>
-  </dgm:styleLbl>
-  <dgm:styleLbl name="bgShp">
-    <dgm:scene3d>
-      <a:camera prst="orthographicFront"/>
-      <a:lightRig rig="threePt" dir="t"/>
-    </dgm:scene3d>
-    <dgm:sp3d/>
-    <dgm:txPr/>
-    <dgm:style>
-      <a:lnRef idx="0">
-        <a:scrgbClr r="0" g="0" b="0"/>
-      </a:lnRef>
-      <a:fillRef idx="1">
-        <a:scrgbClr r="0" g="0" b="0"/>
-      </a:fillRef>
-      <a:effectRef idx="0">
-        <a:scrgbClr r="0" g="0" b="0"/>
-      </a:effectRef>
-      <a:fontRef idx="minor"/>
-    </dgm:style>
-  </dgm:styleLbl>
-  <dgm:styleLbl name="dkBgShp">
-    <dgm:scene3d>
-      <a:camera prst="orthographicFront"/>
-      <a:lightRig rig="threePt" dir="t"/>
-    </dgm:scene3d>
-    <dgm:sp3d/>
-    <dgm:txPr/>
-    <dgm:style>
-      <a:lnRef idx="0">
-        <a:scrgbClr r="0" g="0" b="0"/>
-      </a:lnRef>
-      <a:fillRef idx="1">
-        <a:scrgbClr r="0" g="0" b="0"/>
-      </a:fillRef>
-      <a:effectRef idx="0">
-        <a:scrgbClr r="0" g="0" b="0"/>
-      </a:effectRef>
-      <a:fontRef idx="minor"/>
-    </dgm:style>
-  </dgm:styleLbl>
-  <dgm:styleLbl name="trBgShp">
-    <dgm:scene3d>
-      <a:camera prst="orthographicFront"/>
-      <a:lightRig rig="threePt" dir="t"/>
-    </dgm:scene3d>
-    <dgm:sp3d/>
-    <dgm:txPr/>
-    <dgm:style>
-      <a:lnRef idx="0">
-        <a:scrgbClr r="0" g="0" b="0"/>
-      </a:lnRef>
-      <a:fillRef idx="1">
-        <a:scrgbClr r="0" g="0" b="0"/>
-      </a:fillRef>
-      <a:effectRef idx="0">
-        <a:scrgbClr r="0" g="0" b="0"/>
-      </a:effectRef>
-      <a:fontRef idx="minor"/>
-    </dgm:style>
-  </dgm:styleLbl>
-  <dgm:styleLbl name="fgShp">
-    <dgm:scene3d>
-      <a:camera prst="orthographicFront"/>
-      <a:lightRig rig="threePt" dir="t"/>
-    </dgm:scene3d>
-    <dgm:sp3d/>
-    <dgm:txPr/>
-    <dgm:style>
-      <a:lnRef idx="2">
-        <a:scrgbClr r="0" g="0" b="0"/>
-      </a:lnRef>
-      <a:fillRef idx="1">
-        <a:scrgbClr r="0" g="0" b="0"/>
-      </a:fillRef>
-      <a:effectRef idx="0">
-        <a:scrgbClr r="0" g="0" b="0"/>
-      </a:effectRef>
-      <a:fontRef idx="minor"/>
-    </dgm:style>
-  </dgm:styleLbl>
-  <dgm:styleLbl name="revTx">
-    <dgm:scene3d>
-      <a:camera prst="orthographicFront"/>
-      <a:lightRig rig="threePt" dir="t"/>
-    </dgm:scene3d>
-    <dgm:sp3d/>
-    <dgm:txPr/>
-    <dgm:style>
-      <a:lnRef idx="0">
-        <a:scrgbClr r="0" g="0" b="0"/>
-      </a:lnRef>
-      <a:fillRef idx="0">
-        <a:scrgbClr r="0" g="0" b="0"/>
-      </a:fillRef>
-      <a:effectRef idx="0">
-        <a:scrgbClr r="0" g="0" b="0"/>
-      </a:effectRef>
-      <a:fontRef idx="minor"/>
-    </dgm:style>
-  </dgm:styleLbl>
-</dgm:styleDef>
-</file>
-
 <file path=ppt/notesMasters/notesMaster1.xml><?xml version="1.0" encoding="utf-8"?>
 <p:notesMaster xmlns:a="http://schemas.openxmlformats.org/drawingml/2006/main" xmlns:r="http://schemas.openxmlformats.org/officeDocument/2006/relationships" xmlns:p="http://schemas.openxmlformats.org/presentationml/2006/main">
   <p:cSld>
@@ -4045,7 +237,7 @@
           <a:p>
             <a:fld id="{7F4782C7-A981-DA49-9F80-7A4E75405182}" type="datetimeFigureOut">
               <a:rPr lang="en-US" smtClean="0"/>
-              <a:t>1/16/2026</a:t>
+              <a:t>4/30/26</a:t>
             </a:fld>
             <a:endParaRPr lang="en-US"/>
           </a:p>
@@ -6345,7 +2537,7 @@
           </a:prstGeom>
         </p:spPr>
         <p:txBody>
-          <a:bodyPr vert="horz" lIns="91440" tIns="45720" rIns="91440" bIns="45720" rtlCol="0" anchor="ctr" wrap="square">
+          <a:bodyPr vert="horz" wrap="square" lIns="91440" tIns="45720" rIns="91440" bIns="45720" rtlCol="0" anchor="ctr">
             <a:normAutofit/>
           </a:bodyPr>
           <a:lstStyle>
@@ -6369,7 +2561,7 @@
           </a:lstStyle>
           <a:p>
             <a:r>
-              <a:rPr sz="2800" b="1"/>
+              <a:rPr sz="2800" b="1" dirty="0"/>
               <a:t>Hallucination Reduction in Large Language Models</a:t>
             </a:r>
             <a:endParaRPr lang="en-US" altLang="en-US" b="1" dirty="0">
@@ -6382,7 +2574,7 @@
           </a:p>
           <a:p>
             <a:r>
-              <a:rPr sz="2400"/>
+              <a:rPr sz="2400" dirty="0"/>
               <a:t>A Comparative Study of Prompt Engineering and RAG</a:t>
             </a:r>
           </a:p>
@@ -6601,8 +2793,8 @@
         </p:nvSpPr>
         <p:spPr>
           <a:xfrm>
-            <a:off x="661944" y="5771650"/>
-            <a:ext cx="2172390" cy="738664"/>
+            <a:off x="337191" y="5795731"/>
+            <a:ext cx="3972050" cy="830997"/>
           </a:xfrm>
           <a:prstGeom prst="rect">
             <a:avLst/>
@@ -6616,19 +2808,27 @@
           <a:lstStyle/>
           <a:p>
             <a:r>
-              <a:rPr sz="1600"/>
+              <a:rPr sz="1600" dirty="0"/>
               <a:t>By: Emilio Garcia Martinez (ID: 100783029)</a:t>
             </a:r>
           </a:p>
           <a:p>
             <a:r>
-              <a:rPr sz="1600"/>
-              <a:t>Course: AI700-001 | Prof. Reda Nacif Elalaoui</a:t>
-            </a:r>
-          </a:p>
-          <a:p>
-            <a:r>
-              <a:rPr sz="1600"/>
+              <a:rPr sz="1600" dirty="0"/>
+              <a:t>Course: AI700-001 | Prof. Reda </a:t>
+            </a:r>
+            <a:r>
+              <a:rPr sz="1600" dirty="0" err="1"/>
+              <a:t>Nacif</a:t>
+            </a:r>
+            <a:r>
+              <a:rPr sz="1600" dirty="0"/>
+              <a:t> Elalaoui</a:t>
+            </a:r>
+          </a:p>
+          <a:p>
+            <a:r>
+              <a:rPr sz="1600" dirty="0"/>
               <a:t>Date: May 2026 | Spring 2026</a:t>
             </a:r>
           </a:p>
@@ -6712,42 +2912,50 @@
         </p:spPr>
         <p:txBody>
           <a:bodyPr wrap="square">
-            <a:normAutofit/>
+            <a:noAutofit/>
           </a:bodyPr>
           <a:lstStyle/>
           <a:p>
             <a:r>
-              <a:rPr sz="1600"/>
-              <a:t>RAG + Optimized prompting is the most reliable hallucination mitigation on LLaMA 3.2 (3B).</a:t>
-            </a:r>
-          </a:p>
-          <a:p>
-            <a:r>
-              <a:rPr sz="1600"/>
+              <a:rPr sz="2400" dirty="0"/>
+              <a:t>RAG + Optimized prompting is the most reliable hallucination mitigation on </a:t>
+            </a:r>
+            <a:r>
+              <a:rPr sz="2400" dirty="0" err="1"/>
+              <a:t>LLaMA</a:t>
+            </a:r>
+            <a:r>
+              <a:rPr sz="2400" dirty="0"/>
+              <a:t> 3.2 (3B).</a:t>
+            </a:r>
+          </a:p>
+          <a:p>
+            <a:r>
+              <a:rPr sz="2400" dirty="0"/>
               <a:t>RAG and Self-Consistency also produce statistically significant gains.</a:t>
             </a:r>
           </a:p>
           <a:p>
             <a:r>
-              <a:rPr sz="1600"/>
+              <a:rPr sz="2400" dirty="0"/>
               <a:t>Chain-of-Thought is not effective at this model size — confirms scale-dependence findings.</a:t>
             </a:r>
           </a:p>
           <a:p>
             <a:r>
-              <a:rPr sz="1600"/>
+              <a:rPr sz="2400" dirty="0"/>
               <a:t>Residual errors are mostly partial-truth — model surfaces the topic but fails to commit to the verified fact.</a:t>
             </a:r>
           </a:p>
           <a:p>
             <a:r>
-              <a:rPr sz="1600"/>
+              <a:rPr sz="2400" dirty="0"/>
               <a:t>Future work: factual-entailment verification, hallucination-aware fine-tuning [4], and larger-model replication.</a:t>
             </a:r>
           </a:p>
           <a:p>
             <a:r>
-              <a:rPr sz="1600"/>
+              <a:rPr sz="2400" dirty="0"/>
               <a:t>Public release: full pipeline + dataset + results on GitHub for reproducibility.</a:t>
             </a:r>
           </a:p>
@@ -6930,73 +3138,158 @@
         </p:nvSpPr>
         <p:spPr>
           <a:xfrm>
-            <a:off x="628650" y="1308295"/>
+            <a:off x="628650" y="1077067"/>
             <a:ext cx="7886700" cy="4862099"/>
           </a:xfrm>
         </p:spPr>
         <p:txBody>
-          <a:bodyPr wrap="square"/>
+          <a:bodyPr wrap="square">
+            <a:noAutofit/>
+          </a:bodyPr>
           <a:lstStyle/>
           <a:p>
             <a:pPr marL="0" indent="0">
               <a:buNone/>
             </a:pPr>
             <a:r>
-              <a:rPr sz="1200"/>
+              <a:rPr sz="2400" dirty="0"/>
               <a:t>[1] Dang, Vu, Nguyen. "Survey on hallucinations in LLMs." Frontiers in AI, 2025.</a:t>
             </a:r>
           </a:p>
           <a:p>
-            <a:r>
-              <a:rPr sz="1200"/>
-              <a:t>[2] Bang et al. "HalluLens benchmark." ACL 2025.</a:t>
-            </a:r>
-          </a:p>
-          <a:p>
-            <a:r>
-              <a:rPr sz="1200"/>
-              <a:t>[3] Wang et al. "Self-Consistency improves CoT." ICLR 2023.</a:t>
-            </a:r>
-          </a:p>
-          <a:p>
-            <a:r>
-              <a:rPr sz="1200"/>
+            <a:pPr marL="0" indent="0">
+              <a:buNone/>
+            </a:pPr>
+            <a:r>
+              <a:rPr sz="2400" dirty="0"/>
+              <a:t>[2] Bang et al. "</a:t>
+            </a:r>
+            <a:r>
+              <a:rPr sz="2400" dirty="0" err="1"/>
+              <a:t>HalluLens</a:t>
+            </a:r>
+            <a:r>
+              <a:rPr sz="2400" dirty="0"/>
+              <a:t> benchmark." ACL 2025.</a:t>
+            </a:r>
+          </a:p>
+          <a:p>
+            <a:pPr marL="0" indent="0">
+              <a:buNone/>
+            </a:pPr>
+            <a:r>
+              <a:rPr sz="2400" dirty="0"/>
+              <a:t>[3] Wang et al. "Self-Consistency improves </a:t>
+            </a:r>
+            <a:r>
+              <a:rPr sz="2400" dirty="0" err="1"/>
+              <a:t>CoT</a:t>
+            </a:r>
+            <a:r>
+              <a:rPr sz="2400" dirty="0"/>
+              <a:t>." ICLR 2023.</a:t>
+            </a:r>
+          </a:p>
+          <a:p>
+            <a:pPr marL="0" indent="0">
+              <a:buNone/>
+            </a:pPr>
+            <a:r>
+              <a:rPr sz="2400" dirty="0"/>
               <a:t>[4] Song et al. "RAG-HAT." EMNLP 2024.</a:t>
             </a:r>
           </a:p>
           <a:p>
-            <a:r>
-              <a:rPr sz="1200"/>
-              <a:t>[5] Lin, Hilton, Evans. "TruthfulQA." ACL 2022.</a:t>
-            </a:r>
-          </a:p>
-          <a:p>
-            <a:r>
-              <a:rPr sz="1200"/>
+            <a:pPr marL="0" indent="0">
+              <a:buNone/>
+            </a:pPr>
+            <a:r>
+              <a:rPr sz="2400" dirty="0"/>
+              <a:t>[5] Lin, Hilton, Evans. "</a:t>
+            </a:r>
+            <a:r>
+              <a:rPr sz="2400" dirty="0" err="1"/>
+              <a:t>TruthfulQA</a:t>
+            </a:r>
+            <a:r>
+              <a:rPr sz="2400" dirty="0"/>
+              <a:t>." ACL 2022.</a:t>
+            </a:r>
+          </a:p>
+          <a:p>
+            <a:pPr marL="0" indent="0">
+              <a:buNone/>
+            </a:pPr>
+            <a:r>
+              <a:rPr sz="2400" dirty="0"/>
               <a:t>[6] Lin. "ROUGE." 2004.</a:t>
             </a:r>
           </a:p>
           <a:p>
-            <a:r>
-              <a:rPr sz="1200"/>
-              <a:t>[7] Lewis et al. "Retrieval-Augmented Generation." NeurIPS 2020.</a:t>
-            </a:r>
-          </a:p>
-          <a:p>
-            <a:r>
-              <a:rPr sz="1200"/>
-              <a:t>[8] Wei et al. "Chain-of-Thought prompting." NeurIPS 2022.</a:t>
-            </a:r>
-          </a:p>
-          <a:p>
-            <a:r>
-              <a:rPr sz="1200"/>
-              <a:t>[9] AI@Meta. "LLaMA 3.2 model card," 2024.</a:t>
-            </a:r>
-          </a:p>
-          <a:p>
-            <a:r>
-              <a:rPr sz="1200"/>
+            <a:pPr marL="0" indent="0">
+              <a:buNone/>
+            </a:pPr>
+            <a:r>
+              <a:rPr sz="2400" dirty="0"/>
+              <a:t>[7] Lewis et al. "Retrieval-Augmented Generation." </a:t>
+            </a:r>
+            <a:r>
+              <a:rPr sz="2400" dirty="0" err="1"/>
+              <a:t>NeurIPS</a:t>
+            </a:r>
+            <a:r>
+              <a:rPr sz="2400" dirty="0"/>
+              <a:t> 2020.</a:t>
+            </a:r>
+          </a:p>
+          <a:p>
+            <a:pPr marL="0" indent="0">
+              <a:buNone/>
+            </a:pPr>
+            <a:r>
+              <a:rPr sz="2400" dirty="0"/>
+              <a:t>[8] Wei et al. "Chain-of-Thought prompting." </a:t>
+            </a:r>
+            <a:r>
+              <a:rPr sz="2400" dirty="0" err="1"/>
+              <a:t>NeurIPS</a:t>
+            </a:r>
+            <a:r>
+              <a:rPr sz="2400" dirty="0"/>
+              <a:t> 2022.</a:t>
+            </a:r>
+          </a:p>
+          <a:p>
+            <a:pPr marL="0" indent="0">
+              <a:buNone/>
+            </a:pPr>
+            <a:r>
+              <a:rPr sz="2400" dirty="0"/>
+              <a:t>[9] </a:t>
+            </a:r>
+            <a:r>
+              <a:rPr sz="2400" dirty="0" err="1"/>
+              <a:t>AI@Meta</a:t>
+            </a:r>
+            <a:r>
+              <a:rPr sz="2400" dirty="0"/>
+              <a:t>. "</a:t>
+            </a:r>
+            <a:r>
+              <a:rPr sz="2400" dirty="0" err="1"/>
+              <a:t>LLaMA</a:t>
+            </a:r>
+            <a:r>
+              <a:rPr sz="2400" dirty="0"/>
+              <a:t> 3.2 model card," 2024.</a:t>
+            </a:r>
+          </a:p>
+          <a:p>
+            <a:pPr marL="0" indent="0">
+              <a:buNone/>
+            </a:pPr>
+            <a:r>
+              <a:rPr sz="2400" dirty="0"/>
               <a:t>[10] Ollama. "Run LLMs locally," 2024.</a:t>
             </a:r>
           </a:p>
@@ -7465,39 +3758,65 @@
           </a:xfrm>
         </p:spPr>
         <p:txBody>
-          <a:bodyPr wrap="square"/>
+          <a:bodyPr wrap="square">
+            <a:normAutofit/>
+          </a:bodyPr>
           <a:lstStyle/>
           <a:p>
             <a:pPr marL="0" indent="0">
               <a:buNone/>
             </a:pPr>
             <a:r>
-              <a:rPr sz="1800"/>
+              <a:rPr dirty="0"/>
               <a:t>Hallucination: LLMs generating fluent but factually incorrect text.</a:t>
             </a:r>
           </a:p>
           <a:p>
             <a:r>
-              <a:rPr sz="1800"/>
-              <a:t>Persistent failure mode in LLaMA, GPT, Claude — high-stakes risk in medicine, law, education.</a:t>
-            </a:r>
-          </a:p>
-          <a:p>
-            <a:r>
-              <a:rPr sz="1800"/>
-              <a:t>Goal: compare six mitigation techniques on LLaMA 3.2 (3B) under one protocol.</a:t>
-            </a:r>
-          </a:p>
-          <a:p>
-            <a:r>
-              <a:rPr sz="1800"/>
+              <a:rPr dirty="0"/>
+              <a:t>Persistent failure mode in </a:t>
+            </a:r>
+            <a:r>
+              <a:rPr dirty="0" err="1"/>
+              <a:t>LLaMA</a:t>
+            </a:r>
+            <a:r>
+              <a:rPr dirty="0"/>
+              <a:t>, GPT, Claude — high-stakes risk in medicine, law, education.</a:t>
+            </a:r>
+          </a:p>
+          <a:p>
+            <a:r>
+              <a:rPr dirty="0"/>
+              <a:t>Goal: compare six mitigation techniques on </a:t>
+            </a:r>
+            <a:r>
+              <a:rPr dirty="0" err="1"/>
+              <a:t>LLaMA</a:t>
+            </a:r>
+            <a:r>
+              <a:rPr dirty="0"/>
+              <a:t> 3.2 (3B) under one protocol.</a:t>
+            </a:r>
+          </a:p>
+          <a:p>
+            <a:r>
+              <a:rPr dirty="0"/>
               <a:t>Six methods: Baseline, Chain-of-Thought, Few-Shot, Self-Consistency, RAG, RAG + Optimized.</a:t>
             </a:r>
           </a:p>
           <a:p>
             <a:r>
-              <a:rPr sz="1800"/>
-              <a:t>Evaluation: 30-question TruthfulQA subset, automated metrics, bootstrap statistics.</a:t>
+              <a:rPr dirty="0"/>
+              <a:t>Evaluation: 30-question </a:t>
+            </a:r>
+            <a:r>
+              <a:rPr dirty="0" err="1"/>
+              <a:t>TruthfulQA</a:t>
+            </a:r>
+            <a:r>
+              <a:rPr dirty="0"/>
+              <a:t> subset, automated metrics, bootstrap statistics.</a:t>
             </a:r>
           </a:p>
         </p:txBody>
@@ -7645,35 +3964,37 @@
           </a:xfrm>
         </p:spPr>
         <p:txBody>
-          <a:bodyPr wrap="square"/>
+          <a:bodyPr wrap="square">
+            <a:normAutofit/>
+          </a:bodyPr>
           <a:lstStyle/>
           <a:p>
             <a:r>
-              <a:rPr sz="1800"/>
+              <a:rPr dirty="0"/>
               <a:t>Healthcare assistants — wrong dosage / drug-interaction advice can harm patients.</a:t>
             </a:r>
           </a:p>
           <a:p>
             <a:r>
-              <a:rPr sz="1800"/>
+              <a:rPr dirty="0"/>
               <a:t>Legal &amp; finance copilots — fabricated case law or numbers create liability.</a:t>
             </a:r>
           </a:p>
           <a:p>
             <a:r>
-              <a:rPr sz="1800"/>
+              <a:rPr dirty="0"/>
               <a:t>Educational tutors — myth reinforcement in History / Science misinforms students.</a:t>
             </a:r>
           </a:p>
           <a:p>
             <a:r>
-              <a:rPr sz="1800"/>
+              <a:rPr dirty="0"/>
               <a:t>Customer support automation — confidently wrong answers erode trust.</a:t>
             </a:r>
           </a:p>
           <a:p>
             <a:r>
-              <a:rPr sz="1800"/>
+              <a:rPr dirty="0"/>
               <a:t>Reducing hallucination is foundational to deploying LLMs in any production setting.</a:t>
             </a:r>
           </a:p>
@@ -7877,13 +4198,13 @@
         </p:nvSpPr>
         <p:spPr>
           <a:xfrm>
-            <a:off x="628650" y="1371601"/>
+            <a:off x="628650" y="1114052"/>
             <a:ext cx="7782639" cy="5029200"/>
           </a:xfrm>
         </p:spPr>
         <p:txBody>
           <a:bodyPr wrap="square">
-            <a:normAutofit/>
+            <a:noAutofit/>
           </a:bodyPr>
           <a:lstStyle/>
           <a:p>
@@ -7892,43 +4213,91 @@
               <a:buChar char="•"/>
             </a:pPr>
             <a:r>
-              <a:rPr sz="1600"/>
+              <a:rPr sz="2400" dirty="0"/>
               <a:t>Dang et al. (2025): survey &amp; taxonomy of LLM hallucinations [1].</a:t>
             </a:r>
           </a:p>
           <a:p>
-            <a:r>
-              <a:rPr sz="1600"/>
-              <a:t>Bang et al. (2025): HalluLens benchmark for systematic evaluation [2].</a:t>
-            </a:r>
-          </a:p>
-          <a:p>
-            <a:r>
-              <a:rPr sz="1600"/>
-              <a:t>Wang et al. (2023): Self-Consistency boosts CoT reasoning [3].</a:t>
-            </a:r>
-          </a:p>
-          <a:p>
-            <a:r>
-              <a:rPr sz="1600"/>
+            <a:pPr marL="285750" indent="-285750">
+              <a:buFont typeface="Arial" panose="020B0604020202020204" pitchFamily="34" charset="0"/>
+              <a:buChar char="•"/>
+            </a:pPr>
+            <a:r>
+              <a:rPr sz="2400" dirty="0"/>
+              <a:t>Bang et al. (2025): </a:t>
+            </a:r>
+            <a:r>
+              <a:rPr sz="2400" dirty="0" err="1"/>
+              <a:t>HalluLens</a:t>
+            </a:r>
+            <a:r>
+              <a:rPr sz="2400" dirty="0"/>
+              <a:t> benchmark for systematic evaluation [2].</a:t>
+            </a:r>
+          </a:p>
+          <a:p>
+            <a:pPr marL="285750" indent="-285750">
+              <a:buFont typeface="Arial" panose="020B0604020202020204" pitchFamily="34" charset="0"/>
+              <a:buChar char="•"/>
+            </a:pPr>
+            <a:r>
+              <a:rPr sz="2400" dirty="0"/>
+              <a:t>Wang et al. (2023): Self-Consistency boosts </a:t>
+            </a:r>
+            <a:r>
+              <a:rPr sz="2400" dirty="0" err="1"/>
+              <a:t>CoT</a:t>
+            </a:r>
+            <a:r>
+              <a:rPr sz="2400" dirty="0"/>
+              <a:t> reasoning [3].</a:t>
+            </a:r>
+          </a:p>
+          <a:p>
+            <a:pPr marL="285750" indent="-285750">
+              <a:buFont typeface="Arial" panose="020B0604020202020204" pitchFamily="34" charset="0"/>
+              <a:buChar char="•"/>
+            </a:pPr>
+            <a:r>
+              <a:rPr sz="2400" dirty="0"/>
               <a:t>Song et al. (2024): RAG-HAT — hallucination-aware tuning for RAG [4].</a:t>
             </a:r>
           </a:p>
           <a:p>
-            <a:r>
-              <a:rPr sz="1600"/>
-              <a:t>Lin et al. (2022): TruthfulQA targets imitative falsehoods [5].</a:t>
-            </a:r>
-          </a:p>
-          <a:p>
-            <a:r>
-              <a:rPr sz="1600"/>
+            <a:pPr marL="285750" indent="-285750">
+              <a:buFont typeface="Arial" panose="020B0604020202020204" pitchFamily="34" charset="0"/>
+              <a:buChar char="•"/>
+            </a:pPr>
+            <a:r>
+              <a:rPr sz="2400" dirty="0"/>
+              <a:t>Lin et al. (2022): </a:t>
+            </a:r>
+            <a:r>
+              <a:rPr sz="2400" dirty="0" err="1"/>
+              <a:t>TruthfulQA</a:t>
+            </a:r>
+            <a:r>
+              <a:rPr sz="2400" dirty="0"/>
+              <a:t> targets imitative falsehoods [5].</a:t>
+            </a:r>
+          </a:p>
+          <a:p>
+            <a:pPr marL="285750" indent="-285750">
+              <a:buFont typeface="Arial" panose="020B0604020202020204" pitchFamily="34" charset="0"/>
+              <a:buChar char="•"/>
+            </a:pPr>
+            <a:r>
+              <a:rPr sz="2400" dirty="0"/>
               <a:t>Lewis et al. (2020): Retrieval-Augmented Generation framework [7].</a:t>
             </a:r>
           </a:p>
           <a:p>
-            <a:r>
-              <a:rPr sz="1600"/>
+            <a:pPr marL="285750" indent="-285750">
+              <a:buFont typeface="Arial" panose="020B0604020202020204" pitchFamily="34" charset="0"/>
+              <a:buChar char="•"/>
+            </a:pPr>
+            <a:r>
+              <a:rPr sz="2400" dirty="0"/>
               <a:t>Wei et al. (2022): Chain-of-Thought prompting elicits reasoning [8].</a:t>
             </a:r>
           </a:p>
@@ -8040,38 +4409,49 @@
             <p:ph sz="half" idx="1"/>
           </p:nvPr>
         </p:nvSpPr>
-        <p:spPr/>
-        <p:txBody>
-          <a:bodyPr wrap="square"/>
+        <p:spPr>
+          <a:xfrm>
+            <a:off x="628650" y="1124607"/>
+            <a:ext cx="7886700" cy="4909153"/>
+          </a:xfrm>
+        </p:spPr>
+        <p:txBody>
+          <a:bodyPr wrap="square">
+            <a:noAutofit/>
+          </a:bodyPr>
           <a:lstStyle/>
           <a:p>
             <a:r>
-              <a:rPr sz="1800"/>
+              <a:rPr dirty="0"/>
               <a:t>RAG and verification methods consistently outperform pure prompt engineering on factual tasks.</a:t>
             </a:r>
-            <a:endParaRPr lang="en-US"/>
-          </a:p>
-          <a:p>
-            <a:r>
-              <a:rPr sz="1800"/>
+            <a:endParaRPr lang="en-US" dirty="0"/>
+          </a:p>
+          <a:p>
+            <a:r>
+              <a:rPr dirty="0"/>
               <a:t>Self-Consistency's value depends on cost tolerance — 3+ inference passes per query.</a:t>
             </a:r>
           </a:p>
           <a:p>
             <a:r>
-              <a:rPr sz="1800"/>
-              <a:t>CoT benefits scale with model size; small models (≤7B) often see marginal or negative gains.</a:t>
-            </a:r>
-          </a:p>
-          <a:p>
-            <a:r>
-              <a:rPr sz="1800"/>
+              <a:rPr dirty="0" err="1"/>
+              <a:t>CoT</a:t>
+            </a:r>
+            <a:r>
+              <a:rPr dirty="0"/>
+              <a:t> benefits scale with model size; small models (≤7B) often see marginal or negative gains.</a:t>
+            </a:r>
+          </a:p>
+          <a:p>
+            <a:r>
+              <a:rPr dirty="0"/>
               <a:t>Open evaluation gap: few studies report paired statistical tests on small open-weight models running locally.</a:t>
             </a:r>
           </a:p>
           <a:p>
             <a:r>
-              <a:rPr sz="1800"/>
+              <a:rPr dirty="0"/>
               <a:t>This work contributes a fully reproducible local pipeline with bootstrap CIs and error-type analysis.</a:t>
             </a:r>
           </a:p>
@@ -8362,15 +4742,15 @@
           <p:nvPr/>
         </p:nvPicPr>
         <p:blipFill>
-          <a:blip r:embed="rId7"/>
+          <a:blip r:embed="rId2"/>
           <a:stretch>
             <a:fillRect/>
           </a:stretch>
         </p:blipFill>
         <p:spPr>
           <a:xfrm>
-            <a:off x="628651" y="1128713"/>
-            <a:ext cx="7885509" cy="4978083"/>
+            <a:off x="628651" y="1008993"/>
+            <a:ext cx="7885509" cy="5347358"/>
           </a:xfrm>
           <a:prstGeom prst="rect">
             <a:avLst/>
@@ -8430,39 +4810,46 @@
           </a:xfrm>
         </p:spPr>
         <p:txBody>
-          <a:bodyPr wrap="square"/>
+          <a:bodyPr wrap="square">
+            <a:normAutofit/>
+          </a:bodyPr>
           <a:lstStyle/>
           <a:p>
-            <a:pPr marL="342900" indent="-342900">
-              <a:buAutoNum type="arabicPeriod"/>
-            </a:pPr>
-            <a:r>
-              <a:rPr sz="1600"/>
+            <a:r>
+              <a:rPr sz="2800" dirty="0"/>
               <a:t>Hallucination Rate: 1 if response overlaps known-incorrect more than correct answer.</a:t>
             </a:r>
           </a:p>
           <a:p>
             <a:r>
-              <a:rPr sz="1600"/>
+              <a:rPr sz="2800" dirty="0"/>
               <a:t>ROUGE-L: longest common subsequence overlap between response and ground truth.</a:t>
             </a:r>
           </a:p>
           <a:p>
             <a:r>
-              <a:rPr sz="1600"/>
+              <a:rPr sz="2800" dirty="0"/>
               <a:t>Factual Accuracy = 0.6 × keyword recall + 0.4 × ROUGE-L (rewards salient facts under paraphrase).</a:t>
             </a:r>
           </a:p>
           <a:p>
             <a:r>
-              <a:rPr sz="1600"/>
+              <a:rPr sz="2800" dirty="0"/>
               <a:t>Bootstrap 95% CI: 10,000 resamples per method.</a:t>
             </a:r>
           </a:p>
           <a:p>
             <a:r>
-              <a:rPr sz="1600"/>
-              <a:t>Paired bootstrap test: per-question Δ vs baseline; two-sided p from sign-flip fraction.</a:t>
+              <a:rPr sz="2800" dirty="0"/>
+              <a:t>Paired bootstrap test: per-question </a:t>
+            </a:r>
+            <a:r>
+              <a:rPr sz="2800" dirty="0" err="1"/>
+              <a:t>Δ</a:t>
+            </a:r>
+            <a:r>
+              <a:rPr sz="2800" dirty="0"/>
+              <a:t> vs baseline; two-sided p from sign-flip fraction.</a:t>
             </a:r>
           </a:p>
         </p:txBody>
@@ -8727,7 +5114,7 @@
         </p:nvSpPr>
         <p:spPr>
           <a:xfrm>
-            <a:off x="628650" y="1805927"/>
+            <a:off x="628650" y="1112245"/>
             <a:ext cx="7886700" cy="3476724"/>
           </a:xfrm>
         </p:spPr>
@@ -8736,50 +5123,66 @@
           <a:lstStyle/>
           <a:p>
             <a:r>
-              <a:rPr sz="1400"/>
+              <a:rPr sz="1400" dirty="0"/>
               <a:t>Best method: RAG + Optimized (factual accuracy 0.556, +43.3% over baseline).</a:t>
             </a:r>
             <a:endParaRPr lang="en-US" dirty="0"/>
           </a:p>
           <a:p>
             <a:r>
-              <a:rPr sz="1400"/>
+              <a:rPr sz="1400" dirty="0"/>
               <a:t>RAG + Optimized:  0.556 [0.489, 0.624]   (+0.168 vs baseline, p = 0.001)</a:t>
             </a:r>
           </a:p>
           <a:p>
             <a:r>
-              <a:rPr sz="1400"/>
+              <a:rPr sz="1400" dirty="0"/>
               <a:t>RAG:                 0.510 [0.417, 0.605]   (+0.121, p = 0.031)</a:t>
             </a:r>
           </a:p>
           <a:p>
             <a:r>
-              <a:rPr sz="1400"/>
+              <a:rPr sz="1400" dirty="0"/>
               <a:t>Self-Consistency: 0.448 [0.385, 0.514]   (+0.060, p = 0.034)</a:t>
             </a:r>
           </a:p>
           <a:p>
             <a:r>
-              <a:rPr sz="1400"/>
-              <a:t>Few-Shot:           0.460 [0.394, 0.527]   (+0.072, p = 0.125, n.s.)</a:t>
-            </a:r>
-          </a:p>
-          <a:p>
-            <a:r>
-              <a:rPr sz="1400"/>
-              <a:t>Chain-of-Thought: 0.346 [0.292, 0.408]   (-0.042, p = 0.340, n.s.)</a:t>
-            </a:r>
-          </a:p>
-          <a:p>
-            <a:r>
-              <a:rPr sz="1400"/>
+              <a:rPr sz="1400" dirty="0"/>
+              <a:t>Few-Shot:           0.460 [0.394, 0.527]   (+0.072, p = 0.125, </a:t>
+            </a:r>
+            <a:r>
+              <a:rPr sz="1400" dirty="0" err="1"/>
+              <a:t>n.s</a:t>
+            </a:r>
+            <a:r>
+              <a:rPr sz="1400" dirty="0"/>
+              <a:t>.)</a:t>
+            </a:r>
+          </a:p>
+          <a:p>
+            <a:r>
+              <a:rPr sz="1400" dirty="0"/>
+              <a:t>Chain-of-Thought: 0.346 [0.292, 0.408]   (-0.042, p = 0.340, </a:t>
+            </a:r>
+            <a:r>
+              <a:rPr sz="1400" dirty="0" err="1"/>
+              <a:t>n.s</a:t>
+            </a:r>
+            <a:r>
+              <a:rPr sz="1400" dirty="0"/>
+              <a:t>.)</a:t>
+            </a:r>
+          </a:p>
+          <a:p>
+            <a:r>
+              <a:rPr sz="1400" dirty="0"/>
               <a:t>Baseline:           0.388 [0.313, 0.468]</a:t>
             </a:r>
           </a:p>
           <a:p>
             <a:r>
-              <a:rPr sz="1400"/>
+              <a:rPr sz="1400" dirty="0"/>
               <a:t>Error analysis: residual failures dominated by partial-truth, not full fabrication.</a:t>
             </a:r>
           </a:p>
@@ -8801,7 +5204,7 @@
         </p:blipFill>
         <p:spPr>
           <a:xfrm>
-            <a:off x="3840480" y="3657600"/>
+            <a:off x="2057400" y="3637992"/>
             <a:ext cx="5029200" cy="2834640"/>
           </a:xfrm>
           <a:prstGeom prst="rect">

</xml_diff>